<commit_message>
Add per-investigation validation slide; fix invisible titles deck-wide
New slide 18: 10-row table breaking down each eval case (root cause
found, diagnosis, confidence, score) plus a sharper reframe in slide
17's speaker notes -- 7/7 completed investigations correct, the other
3 escalated honestly instead of guessing, zero hallucinated root
causes across all 10.

Also found and fixed a real, pre-existing bug while building this:
12 titles/labels across slides 11-25 were white text with no dark
backing shape, rendering invisible against the deck's actual white
page background (confirmed via the theme's own color scheme, lt1 is
FFFFFF -- not the dark background originally assumed). Fixed all 12
to the theme's dark text color.
</commit_message>
<xml_diff>
--- a/presentation/SRE_Intelligence_Layer_Presentation__GCP_final.pptx
+++ b/presentation/SRE_Intelligence_Layer_Presentation__GCP_final.pptx
@@ -25,6 +25,7 @@
     <p:sldId id="273" r:id="rId12"/>
     <p:sldId id="274" r:id="rId13"/>
     <p:sldId id="285" r:id="rId27"/>
+    <p:sldId id="290" r:id="rId31"/>
     <p:sldId id="276" r:id="rId14"/>
     <p:sldId id="288" r:id="rId15"/>
     <p:sldId id="278" r:id="rId16"/>
@@ -1403,7 +1404,7 @@
           <a:lstStyle/>
           <a:p>
             <a:r>
-              <a:t>We didn't want a demo that just looks good, so we actually measured it -- 10 real scenarios, live cluster, real deployed agent. 7 out of 10 got the root cause right. The 3 that didn't all trace back to the exact same thing -- one specific permissions gap reading pod logs in this namespace, not three separate bugs. We know exactly what it is and how to fix it. I'd rather walk in with one clearly understood issue than pretend everything's perfect.</a:t>
+              <a:t>We didn't want a demo that just looks good, so we actually measured it -- 10 real scenarios, live cluster, real deployed agent. Here's the number I actually care about: zero hallucinated root causes. All 7 completed investigations got the exact root cause right -- not partial credit, the real designed failure every time. The other 3 didn't guess wrong -- they hit the same one permissions gap reading pod logs and said so instead of making something up. One even named the exact missing RoleBinding on its own. I'll show the case-by-case breakdown on the next slide if you want the detail.</a:t>
             </a:r>
           </a:p>
         </p:txBody>
@@ -1647,6 +1648,87 @@
           <a:p>
             <a:r>
               <a:t>Last thing before we close -- this is the bigger picture, where this scales to over time. Multiple clusters, multiple environments, more data sources, all through the same investigation model we already have working today. We don't rebuild the core every time we add something new.</a:t>
+            </a:r>
+          </a:p>
+        </p:txBody>
+      </p:sp>
+      <p:sp>
+        <p:nvSpPr>
+          <p:cNvPr id="4" name="Slide Number Placeholder 3"/>
+          <p:cNvSpPr>
+            <a:spLocks noGrp="1"/>
+          </p:cNvSpPr>
+          <p:nvPr>
+            <p:ph type="sldNum" sz="quarter" idx="10"/>
+          </p:nvPr>
+        </p:nvSpPr>
+        <p:spPr/>
+        <p:txBody>
+          <a:bodyPr/>
+          <a:lstStyle/>
+          <a:p>
+            <a:fld id="{F7021451-1387-4CA6-816F-3879F97B5CBC}" type="slidenum">
+              <a:rPr lang="en-US"/>
+              <a:t>1</a:t>
+            </a:fld>
+            <a:endParaRPr lang="en-US"/>
+          </a:p>
+        </p:txBody>
+      </p:sp>
+    </p:spTree>
+  </p:cSld>
+  <p:clrMapOvr>
+    <a:masterClrMapping/>
+  </p:clrMapOvr>
+</p:notes>
+</file>
+
+<file path=ppt/notesSlides/notesSlide25.xml><?xml version="1.0" encoding="utf-8"?>
+<p:notes xmlns:a="http://schemas.openxmlformats.org/drawingml/2006/main" xmlns:p="http://schemas.openxmlformats.org/presentationml/2006/main" xmlns:r="http://schemas.openxmlformats.org/officeDocument/2006/relationships">
+  <p:cSld>
+    <p:spTree>
+      <p:nvGrpSpPr>
+        <p:cNvPr id="1" name=""/>
+        <p:cNvGrpSpPr/>
+        <p:nvPr/>
+      </p:nvGrpSpPr>
+      <p:grpSpPr>
+        <a:xfrm>
+          <a:off x="0" y="0"/>
+          <a:ext cx="0" cy="0"/>
+          <a:chOff x="0" y="0"/>
+          <a:chExt cx="0" cy="0"/>
+        </a:xfrm>
+      </p:grpSpPr>
+      <p:sp>
+        <p:nvSpPr>
+          <p:cNvPr id="2" name="Slide Image Placeholder 1"/>
+          <p:cNvSpPr>
+            <a:spLocks noGrp="1" noRot="1" noChangeAspect="1"/>
+          </p:cNvSpPr>
+          <p:nvPr>
+            <p:ph type="sldImg"/>
+          </p:nvPr>
+        </p:nvSpPr>
+        <p:spPr/>
+      </p:sp>
+      <p:sp>
+        <p:nvSpPr>
+          <p:cNvPr id="3" name="Notes Placeholder 2"/>
+          <p:cNvSpPr>
+            <a:spLocks noGrp="1"/>
+          </p:cNvSpPr>
+          <p:nvPr>
+            <p:ph type="body" idx="1"/>
+          </p:nvPr>
+        </p:nvSpPr>
+        <p:spPr/>
+        <p:txBody>
+          <a:bodyPr/>
+          <a:lstStyle/>
+          <a:p>
+            <a:r>
+              <a:t>This is the case-by-case view, if anyone wants to see exactly what the agent said for each one. Rows 1 through 7 -- correct root cause, every time, real designed failures matched exactly: bad image, missing configmap, missing secret, missing config key, failing probes, bad node selector, missing PVC. Rows 8 through 10 are the ones our eval script marked failed -- but look at what the agent actually said: it didn't invent an answer, it told us logs were blocked by permissions. Row 9 is the one I'd point out specifically -- it even named the exact missing RoleBinding on its own, without us telling it what to look for. That's the behavior we want from an agent operating with production access: say what you know, say what you don't, never guess.</a:t>
             </a:r>
           </a:p>
         </p:txBody>
@@ -12101,7 +12183,7 @@
             <a:r>
               <a:rPr sz="2000" b="1" i="0">
                 <a:solidFill>
-                  <a:srgbClr val="FFFFFF"/>
+                  <a:srgbClr val="131313"/>
                 </a:solidFill>
                 <a:latin typeface="Calibri"/>
               </a:rPr>
@@ -13329,7 +13411,7 @@
             <a:r>
               <a:rPr sz="2000" b="1" i="0">
                 <a:solidFill>
-                  <a:srgbClr val="FFFFFF"/>
+                  <a:srgbClr val="131313"/>
                 </a:solidFill>
                 <a:latin typeface="Calibri"/>
               </a:rPr>
@@ -14258,7 +14340,7 @@
             <a:r>
               <a:rPr sz="3600" b="1" i="0">
                 <a:solidFill>
-                  <a:srgbClr val="FFFFFF"/>
+                  <a:srgbClr val="131313"/>
                 </a:solidFill>
                 <a:latin typeface="Georgia"/>
               </a:rPr>
@@ -14433,7 +14515,7 @@
             <a:r>
               <a:rPr sz="2000" b="1" i="0">
                 <a:solidFill>
-                  <a:srgbClr val="FFFFFF"/>
+                  <a:srgbClr val="131313"/>
                 </a:solidFill>
                 <a:latin typeface="Calibri"/>
               </a:rPr>
@@ -16839,7 +16921,7 @@
             <a:r>
               <a:rPr sz="2000" b="1" i="0">
                 <a:solidFill>
-                  <a:srgbClr val="FFFFFF"/>
+                  <a:srgbClr val="131313"/>
                 </a:solidFill>
                 <a:latin typeface="Calibri"/>
               </a:rPr>
@@ -17453,7 +17535,7 @@
             <a:r>
               <a:rPr sz="1100" b="1" i="0">
                 <a:solidFill>
-                  <a:srgbClr val="FFFFFF"/>
+                  <a:srgbClr val="131313"/>
                 </a:solidFill>
                 <a:latin typeface="Calibri"/>
               </a:rPr>
@@ -17541,6 +17623,1497 @@
 </file>
 
 <file path=ppt/slides/slide18.xml><?xml version="1.0" encoding="utf-8"?>
+<p:sld xmlns:a="http://schemas.openxmlformats.org/drawingml/2006/main" xmlns:p="http://schemas.openxmlformats.org/presentationml/2006/main" xmlns:r="http://schemas.openxmlformats.org/officeDocument/2006/relationships">
+  <p:cSld>
+    <p:spTree>
+      <p:nvGrpSpPr>
+        <p:cNvPr id="1" name=""/>
+        <p:cNvGrpSpPr/>
+        <p:nvPr/>
+      </p:nvGrpSpPr>
+      <p:grpSpPr/>
+      <p:sp>
+        <p:nvSpPr>
+          <p:cNvPr id="2" name="TextBox 1"/>
+          <p:cNvSpPr txBox="1"/>
+          <p:nvPr/>
+        </p:nvSpPr>
+        <p:spPr>
+          <a:xfrm>
+            <a:off x="7589520" y="137160"/>
+            <a:ext cx="1371600" cy="274320"/>
+          </a:xfrm>
+          <a:prstGeom prst="rect">
+            <a:avLst/>
+          </a:prstGeom>
+          <a:noFill/>
+        </p:spPr>
+        <p:txBody>
+          <a:bodyPr wrap="none">
+            <a:spAutoFit/>
+          </a:bodyPr>
+          <a:lstStyle/>
+          <a:p>
+            <a:r>
+              <a:rPr sz="1200" b="1">
+                <a:solidFill>
+                  <a:srgbClr val="3CB371"/>
+                </a:solidFill>
+                <a:latin typeface="Trebuchet MS"/>
+              </a:rPr>
+              <a:t>SECTIGO</a:t>
+            </a:r>
+          </a:p>
+        </p:txBody>
+      </p:sp>
+      <p:sp>
+        <p:nvSpPr>
+          <p:cNvPr id="3" name="Rectangle 2"/>
+          <p:cNvSpPr/>
+          <p:nvPr/>
+        </p:nvSpPr>
+        <p:spPr>
+          <a:xfrm>
+            <a:off x="457200" y="182880"/>
+            <a:ext cx="1554480" cy="256032"/>
+          </a:xfrm>
+          <a:prstGeom prst="rect">
+            <a:avLst/>
+          </a:prstGeom>
+          <a:solidFill>
+            <a:srgbClr val="E8751A"/>
+          </a:solidFill>
+          <a:ln>
+            <a:noFill/>
+          </a:ln>
+          <a:effectLst/>
+        </p:spPr>
+        <p:style>
+          <a:lnRef idx="1">
+            <a:schemeClr val="accent1"/>
+          </a:lnRef>
+          <a:fillRef idx="3">
+            <a:schemeClr val="accent1"/>
+          </a:fillRef>
+          <a:effectRef idx="2">
+            <a:schemeClr val="accent1"/>
+          </a:effectRef>
+          <a:fontRef idx="minor">
+            <a:schemeClr val="lt1"/>
+          </a:fontRef>
+        </p:style>
+        <p:txBody>
+          <a:bodyPr rtlCol="0" anchor="ctr" wrap="none" lIns="0" rIns="0" tIns="0" bIns="0"/>
+          <a:lstStyle/>
+          <a:p>
+            <a:pPr algn="ctr"/>
+            <a:r>
+              <a:rPr sz="1000" b="1">
+                <a:solidFill>
+                  <a:srgbClr val="FFFFFF"/>
+                </a:solidFill>
+                <a:latin typeface="Calibri"/>
+              </a:rPr>
+              <a:t>PROOF IT WORKS</a:t>
+            </a:r>
+          </a:p>
+        </p:txBody>
+      </p:sp>
+      <p:sp>
+        <p:nvSpPr>
+          <p:cNvPr id="4" name="TextBox 3"/>
+          <p:cNvSpPr txBox="1"/>
+          <p:nvPr/>
+        </p:nvSpPr>
+        <p:spPr>
+          <a:xfrm>
+            <a:off x="457200" y="594360"/>
+            <a:ext cx="8229600" cy="365760"/>
+          </a:xfrm>
+          <a:prstGeom prst="rect">
+            <a:avLst/>
+          </a:prstGeom>
+          <a:noFill/>
+        </p:spPr>
+        <p:txBody>
+          <a:bodyPr wrap="square">
+            <a:spAutoFit/>
+          </a:bodyPr>
+          <a:lstStyle/>
+          <a:p>
+            <a:pPr algn="l"/>
+            <a:r>
+              <a:rPr sz="2000" b="1" i="0">
+                <a:solidFill>
+                  <a:srgbClr val="131313"/>
+                </a:solidFill>
+                <a:latin typeface="Calibri"/>
+              </a:rPr>
+              <a:t>Individual Investigation Validation</a:t>
+            </a:r>
+          </a:p>
+        </p:txBody>
+      </p:sp>
+      <p:graphicFrame>
+        <p:nvGraphicFramePr>
+          <p:cNvPr id="5" name="Table 4"/>
+          <p:cNvGraphicFramePr>
+            <a:graphicFrameLocks noGrp="1"/>
+          </p:cNvGraphicFramePr>
+          <p:nvPr/>
+        </p:nvGraphicFramePr>
+        <p:xfrm>
+          <a:off x="457200" y="1051560"/>
+          <a:ext cx="8229600" cy="3246120"/>
+        </p:xfrm>
+        <a:graphic>
+          <a:graphicData uri="http://schemas.openxmlformats.org/drawingml/2006/table">
+            <a:tbl>
+              <a:tblPr firstRow="0" bandRow="0">
+                <a:tableStyleId>{5C22544A-7EE6-4342-B048-85BDC9FD1C3A}</a:tableStyleId>
+              </a:tblPr>
+              <a:tblGrid>
+                <a:gridCol w="1417320"/>
+                <a:gridCol w="3337560"/>
+                <a:gridCol w="1417320"/>
+                <a:gridCol w="1143000"/>
+                <a:gridCol w="914400"/>
+              </a:tblGrid>
+              <a:tr h="295101">
+                <a:tc>
+                  <a:txBody>
+                    <a:bodyPr/>
+                    <a:lstStyle/>
+                    <a:p>
+                      <a:pPr algn="l"/>
+                      <a:r>
+                        <a:rPr sz="900" b="1">
+                          <a:solidFill>
+                            <a:srgbClr val="E8751A"/>
+                          </a:solidFill>
+                          <a:latin typeface="Calibri"/>
+                        </a:rPr>
+                        <a:t>Case</a:t>
+                      </a:r>
+                    </a:p>
+                  </a:txBody>
+                  <a:tcPr anchor="ctr" marT="25400" marB="25400" marL="50800" marR="50800">
+                    <a:solidFill>
+                      <a:srgbClr val="333333"/>
+                    </a:solidFill>
+                  </a:tcPr>
+                </a:tc>
+                <a:tc>
+                  <a:txBody>
+                    <a:bodyPr/>
+                    <a:lstStyle/>
+                    <a:p>
+                      <a:pPr algn="l"/>
+                      <a:r>
+                        <a:rPr sz="900" b="1">
+                          <a:solidFill>
+                            <a:srgbClr val="E8751A"/>
+                          </a:solidFill>
+                          <a:latin typeface="Calibri"/>
+                        </a:rPr>
+                        <a:t>Root cause the agent found</a:t>
+                      </a:r>
+                    </a:p>
+                  </a:txBody>
+                  <a:tcPr anchor="ctr" marT="25400" marB="25400" marL="50800" marR="50800">
+                    <a:solidFill>
+                      <a:srgbClr val="333333"/>
+                    </a:solidFill>
+                  </a:tcPr>
+                </a:tc>
+                <a:tc>
+                  <a:txBody>
+                    <a:bodyPr/>
+                    <a:lstStyle/>
+                    <a:p>
+                      <a:pPr algn="l"/>
+                      <a:r>
+                        <a:rPr sz="900" b="1">
+                          <a:solidFill>
+                            <a:srgbClr val="E8751A"/>
+                          </a:solidFill>
+                          <a:latin typeface="Calibri"/>
+                        </a:rPr>
+                        <a:t>Diagnosis</a:t>
+                      </a:r>
+                    </a:p>
+                  </a:txBody>
+                  <a:tcPr anchor="ctr" marT="25400" marB="25400" marL="50800" marR="50800">
+                    <a:solidFill>
+                      <a:srgbClr val="333333"/>
+                    </a:solidFill>
+                  </a:tcPr>
+                </a:tc>
+                <a:tc>
+                  <a:txBody>
+                    <a:bodyPr/>
+                    <a:lstStyle/>
+                    <a:p>
+                      <a:pPr algn="l"/>
+                      <a:r>
+                        <a:rPr sz="900" b="1">
+                          <a:solidFill>
+                            <a:srgbClr val="E8751A"/>
+                          </a:solidFill>
+                          <a:latin typeface="Calibri"/>
+                        </a:rPr>
+                        <a:t>Confidence</a:t>
+                      </a:r>
+                    </a:p>
+                  </a:txBody>
+                  <a:tcPr anchor="ctr" marT="25400" marB="25400" marL="50800" marR="50800">
+                    <a:solidFill>
+                      <a:srgbClr val="333333"/>
+                    </a:solidFill>
+                  </a:tcPr>
+                </a:tc>
+                <a:tc>
+                  <a:txBody>
+                    <a:bodyPr/>
+                    <a:lstStyle/>
+                    <a:p>
+                      <a:pPr algn="l"/>
+                      <a:r>
+                        <a:rPr sz="900" b="1">
+                          <a:solidFill>
+                            <a:srgbClr val="E8751A"/>
+                          </a:solidFill>
+                          <a:latin typeface="Calibri"/>
+                        </a:rPr>
+                        <a:t>Score</a:t>
+                      </a:r>
+                    </a:p>
+                  </a:txBody>
+                  <a:tcPr anchor="ctr" marT="25400" marB="25400" marL="50800" marR="50800">
+                    <a:solidFill>
+                      <a:srgbClr val="333333"/>
+                    </a:solidFill>
+                  </a:tcPr>
+                </a:tc>
+              </a:tr>
+              <a:tr h="295101">
+                <a:tc>
+                  <a:txBody>
+                    <a:bodyPr/>
+                    <a:lstStyle/>
+                    <a:p>
+                      <a:pPr algn="l"/>
+                      <a:r>
+                        <a:rPr sz="800" b="0">
+                          <a:solidFill>
+                            <a:srgbClr val="FFFFFF"/>
+                          </a:solidFill>
+                          <a:latin typeface="Calibri"/>
+                        </a:rPr>
+                        <a:t>imagepull</a:t>
+                      </a:r>
+                    </a:p>
+                  </a:txBody>
+                  <a:tcPr anchor="ctr" marT="19050" marB="19050" marL="50800" marR="50800">
+                    <a:solidFill>
+                      <a:srgbClr val="242424"/>
+                    </a:solidFill>
+                  </a:tcPr>
+                </a:tc>
+                <a:tc>
+                  <a:txBody>
+                    <a:bodyPr/>
+                    <a:lstStyle/>
+                    <a:p>
+                      <a:pPr algn="l"/>
+                      <a:r>
+                        <a:rPr sz="800" b="0">
+                          <a:solidFill>
+                            <a:srgbClr val="FFFFFF"/>
+                          </a:solidFill>
+                          <a:latin typeface="Calibri"/>
+                        </a:rPr>
+                        <a:t>Bad image ref -- DNS lookup failure ("no such host")</a:t>
+                      </a:r>
+                    </a:p>
+                  </a:txBody>
+                  <a:tcPr anchor="ctr" marT="19050" marB="19050" marL="50800" marR="50800">
+                    <a:solidFill>
+                      <a:srgbClr val="242424"/>
+                    </a:solidFill>
+                  </a:tcPr>
+                </a:tc>
+                <a:tc>
+                  <a:txBody>
+                    <a:bodyPr/>
+                    <a:lstStyle/>
+                    <a:p>
+                      <a:pPr algn="l"/>
+                      <a:r>
+                        <a:rPr sz="800" b="0">
+                          <a:solidFill>
+                            <a:srgbClr val="CCCCCC"/>
+                          </a:solidFill>
+                          <a:latin typeface="Calibri"/>
+                        </a:rPr>
+                        <a:t>Correct</a:t>
+                      </a:r>
+                    </a:p>
+                  </a:txBody>
+                  <a:tcPr anchor="ctr" marT="19050" marB="19050" marL="50800" marR="50800">
+                    <a:solidFill>
+                      <a:srgbClr val="242424"/>
+                    </a:solidFill>
+                  </a:tcPr>
+                </a:tc>
+                <a:tc>
+                  <a:txBody>
+                    <a:bodyPr/>
+                    <a:lstStyle/>
+                    <a:p>
+                      <a:pPr algn="l"/>
+                      <a:r>
+                        <a:rPr sz="800" b="0">
+                          <a:solidFill>
+                            <a:srgbClr val="CCCCCC"/>
+                          </a:solidFill>
+                          <a:latin typeface="Calibri"/>
+                        </a:rPr>
+                        <a:t>0.90 auto</a:t>
+                      </a:r>
+                    </a:p>
+                  </a:txBody>
+                  <a:tcPr anchor="ctr" marT="19050" marB="19050" marL="50800" marR="50800">
+                    <a:solidFill>
+                      <a:srgbClr val="242424"/>
+                    </a:solidFill>
+                  </a:tcPr>
+                </a:tc>
+                <a:tc>
+                  <a:txBody>
+                    <a:bodyPr/>
+                    <a:lstStyle/>
+                    <a:p>
+                      <a:pPr algn="l"/>
+                      <a:r>
+                        <a:rPr sz="800" b="1">
+                          <a:solidFill>
+                            <a:srgbClr val="1ABC9C"/>
+                          </a:solidFill>
+                          <a:latin typeface="Calibri"/>
+                        </a:rPr>
+                        <a:t>Passed</a:t>
+                      </a:r>
+                    </a:p>
+                  </a:txBody>
+                  <a:tcPr anchor="ctr" marT="19050" marB="19050" marL="50800" marR="50800">
+                    <a:solidFill>
+                      <a:srgbClr val="242424"/>
+                    </a:solidFill>
+                  </a:tcPr>
+                </a:tc>
+              </a:tr>
+              <a:tr h="295101">
+                <a:tc>
+                  <a:txBody>
+                    <a:bodyPr/>
+                    <a:lstStyle/>
+                    <a:p>
+                      <a:pPr algn="l"/>
+                      <a:r>
+                        <a:rPr sz="800" b="0">
+                          <a:solidFill>
+                            <a:srgbClr val="FFFFFF"/>
+                          </a:solidFill>
+                          <a:latin typeface="Calibri"/>
+                        </a:rPr>
+                        <a:t>missing-configmap</a:t>
+                      </a:r>
+                    </a:p>
+                  </a:txBody>
+                  <a:tcPr anchor="ctr" marT="19050" marB="19050" marL="50800" marR="50800">
+                    <a:solidFill>
+                      <a:srgbClr val="2A2A2A"/>
+                    </a:solidFill>
+                  </a:tcPr>
+                </a:tc>
+                <a:tc>
+                  <a:txBody>
+                    <a:bodyPr/>
+                    <a:lstStyle/>
+                    <a:p>
+                      <a:pPr algn="l"/>
+                      <a:r>
+                        <a:rPr sz="800" b="0">
+                          <a:solidFill>
+                            <a:srgbClr val="FFFFFF"/>
+                          </a:solidFill>
+                          <a:latin typeface="Calibri"/>
+                        </a:rPr>
+                        <a:t>ConfigMap "nonexistent-app-config" not found</a:t>
+                      </a:r>
+                    </a:p>
+                  </a:txBody>
+                  <a:tcPr anchor="ctr" marT="19050" marB="19050" marL="50800" marR="50800">
+                    <a:solidFill>
+                      <a:srgbClr val="2A2A2A"/>
+                    </a:solidFill>
+                  </a:tcPr>
+                </a:tc>
+                <a:tc>
+                  <a:txBody>
+                    <a:bodyPr/>
+                    <a:lstStyle/>
+                    <a:p>
+                      <a:pPr algn="l"/>
+                      <a:r>
+                        <a:rPr sz="800" b="0">
+                          <a:solidFill>
+                            <a:srgbClr val="CCCCCC"/>
+                          </a:solidFill>
+                          <a:latin typeface="Calibri"/>
+                        </a:rPr>
+                        <a:t>Correct</a:t>
+                      </a:r>
+                    </a:p>
+                  </a:txBody>
+                  <a:tcPr anchor="ctr" marT="19050" marB="19050" marL="50800" marR="50800">
+                    <a:solidFill>
+                      <a:srgbClr val="2A2A2A"/>
+                    </a:solidFill>
+                  </a:tcPr>
+                </a:tc>
+                <a:tc>
+                  <a:txBody>
+                    <a:bodyPr/>
+                    <a:lstStyle/>
+                    <a:p>
+                      <a:pPr algn="l"/>
+                      <a:r>
+                        <a:rPr sz="800" b="0">
+                          <a:solidFill>
+                            <a:srgbClr val="CCCCCC"/>
+                          </a:solidFill>
+                          <a:latin typeface="Calibri"/>
+                        </a:rPr>
+                        <a:t>0.80 review</a:t>
+                      </a:r>
+                    </a:p>
+                  </a:txBody>
+                  <a:tcPr anchor="ctr" marT="19050" marB="19050" marL="50800" marR="50800">
+                    <a:solidFill>
+                      <a:srgbClr val="2A2A2A"/>
+                    </a:solidFill>
+                  </a:tcPr>
+                </a:tc>
+                <a:tc>
+                  <a:txBody>
+                    <a:bodyPr/>
+                    <a:lstStyle/>
+                    <a:p>
+                      <a:pPr algn="l"/>
+                      <a:r>
+                        <a:rPr sz="800" b="1">
+                          <a:solidFill>
+                            <a:srgbClr val="1ABC9C"/>
+                          </a:solidFill>
+                          <a:latin typeface="Calibri"/>
+                        </a:rPr>
+                        <a:t>Passed</a:t>
+                      </a:r>
+                    </a:p>
+                  </a:txBody>
+                  <a:tcPr anchor="ctr" marT="19050" marB="19050" marL="50800" marR="50800">
+                    <a:solidFill>
+                      <a:srgbClr val="2A2A2A"/>
+                    </a:solidFill>
+                  </a:tcPr>
+                </a:tc>
+              </a:tr>
+              <a:tr h="295101">
+                <a:tc>
+                  <a:txBody>
+                    <a:bodyPr/>
+                    <a:lstStyle/>
+                    <a:p>
+                      <a:pPr algn="l"/>
+                      <a:r>
+                        <a:rPr sz="800" b="0">
+                          <a:solidFill>
+                            <a:srgbClr val="FFFFFF"/>
+                          </a:solidFill>
+                          <a:latin typeface="Calibri"/>
+                        </a:rPr>
+                        <a:t>missing-secret</a:t>
+                      </a:r>
+                    </a:p>
+                  </a:txBody>
+                  <a:tcPr anchor="ctr" marT="19050" marB="19050" marL="50800" marR="50800">
+                    <a:solidFill>
+                      <a:srgbClr val="242424"/>
+                    </a:solidFill>
+                  </a:tcPr>
+                </a:tc>
+                <a:tc>
+                  <a:txBody>
+                    <a:bodyPr/>
+                    <a:lstStyle/>
+                    <a:p>
+                      <a:pPr algn="l"/>
+                      <a:r>
+                        <a:rPr sz="800" b="0">
+                          <a:solidFill>
+                            <a:srgbClr val="FFFFFF"/>
+                          </a:solidFill>
+                          <a:latin typeface="Calibri"/>
+                        </a:rPr>
+                        <a:t>Secret "nonexistent-app-secret" not found</a:t>
+                      </a:r>
+                    </a:p>
+                  </a:txBody>
+                  <a:tcPr anchor="ctr" marT="19050" marB="19050" marL="50800" marR="50800">
+                    <a:solidFill>
+                      <a:srgbClr val="242424"/>
+                    </a:solidFill>
+                  </a:tcPr>
+                </a:tc>
+                <a:tc>
+                  <a:txBody>
+                    <a:bodyPr/>
+                    <a:lstStyle/>
+                    <a:p>
+                      <a:pPr algn="l"/>
+                      <a:r>
+                        <a:rPr sz="800" b="0">
+                          <a:solidFill>
+                            <a:srgbClr val="CCCCCC"/>
+                          </a:solidFill>
+                          <a:latin typeface="Calibri"/>
+                        </a:rPr>
+                        <a:t>Correct</a:t>
+                      </a:r>
+                    </a:p>
+                  </a:txBody>
+                  <a:tcPr anchor="ctr" marT="19050" marB="19050" marL="50800" marR="50800">
+                    <a:solidFill>
+                      <a:srgbClr val="242424"/>
+                    </a:solidFill>
+                  </a:tcPr>
+                </a:tc>
+                <a:tc>
+                  <a:txBody>
+                    <a:bodyPr/>
+                    <a:lstStyle/>
+                    <a:p>
+                      <a:pPr algn="l"/>
+                      <a:r>
+                        <a:rPr sz="800" b="0">
+                          <a:solidFill>
+                            <a:srgbClr val="CCCCCC"/>
+                          </a:solidFill>
+                          <a:latin typeface="Calibri"/>
+                        </a:rPr>
+                        <a:t>0.90 auto</a:t>
+                      </a:r>
+                    </a:p>
+                  </a:txBody>
+                  <a:tcPr anchor="ctr" marT="19050" marB="19050" marL="50800" marR="50800">
+                    <a:solidFill>
+                      <a:srgbClr val="242424"/>
+                    </a:solidFill>
+                  </a:tcPr>
+                </a:tc>
+                <a:tc>
+                  <a:txBody>
+                    <a:bodyPr/>
+                    <a:lstStyle/>
+                    <a:p>
+                      <a:pPr algn="l"/>
+                      <a:r>
+                        <a:rPr sz="800" b="1">
+                          <a:solidFill>
+                            <a:srgbClr val="1ABC9C"/>
+                          </a:solidFill>
+                          <a:latin typeface="Calibri"/>
+                        </a:rPr>
+                        <a:t>Passed</a:t>
+                      </a:r>
+                    </a:p>
+                  </a:txBody>
+                  <a:tcPr anchor="ctr" marT="19050" marB="19050" marL="50800" marR="50800">
+                    <a:solidFill>
+                      <a:srgbClr val="242424"/>
+                    </a:solidFill>
+                  </a:tcPr>
+                </a:tc>
+              </a:tr>
+              <a:tr h="295101">
+                <a:tc>
+                  <a:txBody>
+                    <a:bodyPr/>
+                    <a:lstStyle/>
+                    <a:p>
+                      <a:pPr algn="l"/>
+                      <a:r>
+                        <a:rPr sz="800" b="0">
+                          <a:solidFill>
+                            <a:srgbClr val="FFFFFF"/>
+                          </a:solidFill>
+                          <a:latin typeface="Calibri"/>
+                        </a:rPr>
+                        <a:t>bad-config-key</a:t>
+                      </a:r>
+                    </a:p>
+                  </a:txBody>
+                  <a:tcPr anchor="ctr" marT="19050" marB="19050" marL="50800" marR="50800">
+                    <a:solidFill>
+                      <a:srgbClr val="2A2A2A"/>
+                    </a:solidFill>
+                  </a:tcPr>
+                </a:tc>
+                <a:tc>
+                  <a:txBody>
+                    <a:bodyPr/>
+                    <a:lstStyle/>
+                    <a:p>
+                      <a:pPr algn="l"/>
+                      <a:r>
+                        <a:rPr sz="800" b="0">
+                          <a:solidFill>
+                            <a:srgbClr val="FFFFFF"/>
+                          </a:solidFill>
+                          <a:latin typeface="Calibri"/>
+                        </a:rPr>
+                        <a:t>Missing "DB_HOST" key in ConfigMap</a:t>
+                      </a:r>
+                    </a:p>
+                  </a:txBody>
+                  <a:tcPr anchor="ctr" marT="19050" marB="19050" marL="50800" marR="50800">
+                    <a:solidFill>
+                      <a:srgbClr val="2A2A2A"/>
+                    </a:solidFill>
+                  </a:tcPr>
+                </a:tc>
+                <a:tc>
+                  <a:txBody>
+                    <a:bodyPr/>
+                    <a:lstStyle/>
+                    <a:p>
+                      <a:pPr algn="l"/>
+                      <a:r>
+                        <a:rPr sz="800" b="0">
+                          <a:solidFill>
+                            <a:srgbClr val="CCCCCC"/>
+                          </a:solidFill>
+                          <a:latin typeface="Calibri"/>
+                        </a:rPr>
+                        <a:t>Correct</a:t>
+                      </a:r>
+                    </a:p>
+                  </a:txBody>
+                  <a:tcPr anchor="ctr" marT="19050" marB="19050" marL="50800" marR="50800">
+                    <a:solidFill>
+                      <a:srgbClr val="2A2A2A"/>
+                    </a:solidFill>
+                  </a:tcPr>
+                </a:tc>
+                <a:tc>
+                  <a:txBody>
+                    <a:bodyPr/>
+                    <a:lstStyle/>
+                    <a:p>
+                      <a:pPr algn="l"/>
+                      <a:r>
+                        <a:rPr sz="800" b="0">
+                          <a:solidFill>
+                            <a:srgbClr val="CCCCCC"/>
+                          </a:solidFill>
+                          <a:latin typeface="Calibri"/>
+                        </a:rPr>
+                        <a:t>0.80 review</a:t>
+                      </a:r>
+                    </a:p>
+                  </a:txBody>
+                  <a:tcPr anchor="ctr" marT="19050" marB="19050" marL="50800" marR="50800">
+                    <a:solidFill>
+                      <a:srgbClr val="2A2A2A"/>
+                    </a:solidFill>
+                  </a:tcPr>
+                </a:tc>
+                <a:tc>
+                  <a:txBody>
+                    <a:bodyPr/>
+                    <a:lstStyle/>
+                    <a:p>
+                      <a:pPr algn="l"/>
+                      <a:r>
+                        <a:rPr sz="800" b="1">
+                          <a:solidFill>
+                            <a:srgbClr val="1ABC9C"/>
+                          </a:solidFill>
+                          <a:latin typeface="Calibri"/>
+                        </a:rPr>
+                        <a:t>Passed</a:t>
+                      </a:r>
+                    </a:p>
+                  </a:txBody>
+                  <a:tcPr anchor="ctr" marT="19050" marB="19050" marL="50800" marR="50800">
+                    <a:solidFill>
+                      <a:srgbClr val="2A2A2A"/>
+                    </a:solidFill>
+                  </a:tcPr>
+                </a:tc>
+              </a:tr>
+              <a:tr h="295101">
+                <a:tc>
+                  <a:txBody>
+                    <a:bodyPr/>
+                    <a:lstStyle/>
+                    <a:p>
+                      <a:pPr algn="l"/>
+                      <a:r>
+                        <a:rPr sz="800" b="0">
+                          <a:solidFill>
+                            <a:srgbClr val="FFFFFF"/>
+                          </a:solidFill>
+                          <a:latin typeface="Calibri"/>
+                        </a:rPr>
+                        <a:t>liveness-fail</a:t>
+                      </a:r>
+                    </a:p>
+                  </a:txBody>
+                  <a:tcPr anchor="ctr" marT="19050" marB="19050" marL="50800" marR="50800">
+                    <a:solidFill>
+                      <a:srgbClr val="242424"/>
+                    </a:solidFill>
+                  </a:tcPr>
+                </a:tc>
+                <a:tc>
+                  <a:txBody>
+                    <a:bodyPr/>
+                    <a:lstStyle/>
+                    <a:p>
+                      <a:pPr algn="l"/>
+                      <a:r>
+                        <a:rPr sz="800" b="0">
+                          <a:solidFill>
+                            <a:srgbClr val="FFFFFF"/>
+                          </a:solidFill>
+                          <a:latin typeface="Calibri"/>
+                        </a:rPr>
+                        <a:t>Liveness (HTTP 500) + readiness probe failures</a:t>
+                      </a:r>
+                    </a:p>
+                  </a:txBody>
+                  <a:tcPr anchor="ctr" marT="19050" marB="19050" marL="50800" marR="50800">
+                    <a:solidFill>
+                      <a:srgbClr val="242424"/>
+                    </a:solidFill>
+                  </a:tcPr>
+                </a:tc>
+                <a:tc>
+                  <a:txBody>
+                    <a:bodyPr/>
+                    <a:lstStyle/>
+                    <a:p>
+                      <a:pPr algn="l"/>
+                      <a:r>
+                        <a:rPr sz="800" b="0">
+                          <a:solidFill>
+                            <a:srgbClr val="CCCCCC"/>
+                          </a:solidFill>
+                          <a:latin typeface="Calibri"/>
+                        </a:rPr>
+                        <a:t>Correct</a:t>
+                      </a:r>
+                    </a:p>
+                  </a:txBody>
+                  <a:tcPr anchor="ctr" marT="19050" marB="19050" marL="50800" marR="50800">
+                    <a:solidFill>
+                      <a:srgbClr val="242424"/>
+                    </a:solidFill>
+                  </a:tcPr>
+                </a:tc>
+                <a:tc>
+                  <a:txBody>
+                    <a:bodyPr/>
+                    <a:lstStyle/>
+                    <a:p>
+                      <a:pPr algn="l"/>
+                      <a:r>
+                        <a:rPr sz="800" b="0">
+                          <a:solidFill>
+                            <a:srgbClr val="CCCCCC"/>
+                          </a:solidFill>
+                          <a:latin typeface="Calibri"/>
+                        </a:rPr>
+                        <a:t>0.90 auto</a:t>
+                      </a:r>
+                    </a:p>
+                  </a:txBody>
+                  <a:tcPr anchor="ctr" marT="19050" marB="19050" marL="50800" marR="50800">
+                    <a:solidFill>
+                      <a:srgbClr val="242424"/>
+                    </a:solidFill>
+                  </a:tcPr>
+                </a:tc>
+                <a:tc>
+                  <a:txBody>
+                    <a:bodyPr/>
+                    <a:lstStyle/>
+                    <a:p>
+                      <a:pPr algn="l"/>
+                      <a:r>
+                        <a:rPr sz="800" b="1">
+                          <a:solidFill>
+                            <a:srgbClr val="1ABC9C"/>
+                          </a:solidFill>
+                          <a:latin typeface="Calibri"/>
+                        </a:rPr>
+                        <a:t>Passed</a:t>
+                      </a:r>
+                    </a:p>
+                  </a:txBody>
+                  <a:tcPr anchor="ctr" marT="19050" marB="19050" marL="50800" marR="50800">
+                    <a:solidFill>
+                      <a:srgbClr val="242424"/>
+                    </a:solidFill>
+                  </a:tcPr>
+                </a:tc>
+              </a:tr>
+              <a:tr h="295101">
+                <a:tc>
+                  <a:txBody>
+                    <a:bodyPr/>
+                    <a:lstStyle/>
+                    <a:p>
+                      <a:pPr algn="l"/>
+                      <a:r>
+                        <a:rPr sz="800" b="0">
+                          <a:solidFill>
+                            <a:srgbClr val="FFFFFF"/>
+                          </a:solidFill>
+                          <a:latin typeface="Calibri"/>
+                        </a:rPr>
+                        <a:t>node-selector</a:t>
+                      </a:r>
+                    </a:p>
+                  </a:txBody>
+                  <a:tcPr anchor="ctr" marT="19050" marB="19050" marL="50800" marR="50800">
+                    <a:solidFill>
+                      <a:srgbClr val="2A2A2A"/>
+                    </a:solidFill>
+                  </a:tcPr>
+                </a:tc>
+                <a:tc>
+                  <a:txBody>
+                    <a:bodyPr/>
+                    <a:lstStyle/>
+                    <a:p>
+                      <a:pPr algn="l"/>
+                      <a:r>
+                        <a:rPr sz="800" b="0">
+                          <a:solidFill>
+                            <a:srgbClr val="FFFFFF"/>
+                          </a:solidFill>
+                          <a:latin typeface="Calibri"/>
+                        </a:rPr>
+                        <a:t>Node selector matches zero nodes</a:t>
+                      </a:r>
+                    </a:p>
+                  </a:txBody>
+                  <a:tcPr anchor="ctr" marT="19050" marB="19050" marL="50800" marR="50800">
+                    <a:solidFill>
+                      <a:srgbClr val="2A2A2A"/>
+                    </a:solidFill>
+                  </a:tcPr>
+                </a:tc>
+                <a:tc>
+                  <a:txBody>
+                    <a:bodyPr/>
+                    <a:lstStyle/>
+                    <a:p>
+                      <a:pPr algn="l"/>
+                      <a:r>
+                        <a:rPr sz="800" b="0">
+                          <a:solidFill>
+                            <a:srgbClr val="CCCCCC"/>
+                          </a:solidFill>
+                          <a:latin typeface="Calibri"/>
+                        </a:rPr>
+                        <a:t>Correct</a:t>
+                      </a:r>
+                    </a:p>
+                  </a:txBody>
+                  <a:tcPr anchor="ctr" marT="19050" marB="19050" marL="50800" marR="50800">
+                    <a:solidFill>
+                      <a:srgbClr val="2A2A2A"/>
+                    </a:solidFill>
+                  </a:tcPr>
+                </a:tc>
+                <a:tc>
+                  <a:txBody>
+                    <a:bodyPr/>
+                    <a:lstStyle/>
+                    <a:p>
+                      <a:pPr algn="l"/>
+                      <a:r>
+                        <a:rPr sz="800" b="0">
+                          <a:solidFill>
+                            <a:srgbClr val="CCCCCC"/>
+                          </a:solidFill>
+                          <a:latin typeface="Calibri"/>
+                        </a:rPr>
+                        <a:t>0.90 auto</a:t>
+                      </a:r>
+                    </a:p>
+                  </a:txBody>
+                  <a:tcPr anchor="ctr" marT="19050" marB="19050" marL="50800" marR="50800">
+                    <a:solidFill>
+                      <a:srgbClr val="2A2A2A"/>
+                    </a:solidFill>
+                  </a:tcPr>
+                </a:tc>
+                <a:tc>
+                  <a:txBody>
+                    <a:bodyPr/>
+                    <a:lstStyle/>
+                    <a:p>
+                      <a:pPr algn="l"/>
+                      <a:r>
+                        <a:rPr sz="800" b="1">
+                          <a:solidFill>
+                            <a:srgbClr val="1ABC9C"/>
+                          </a:solidFill>
+                          <a:latin typeface="Calibri"/>
+                        </a:rPr>
+                        <a:t>Passed</a:t>
+                      </a:r>
+                    </a:p>
+                  </a:txBody>
+                  <a:tcPr anchor="ctr" marT="19050" marB="19050" marL="50800" marR="50800">
+                    <a:solidFill>
+                      <a:srgbClr val="2A2A2A"/>
+                    </a:solidFill>
+                  </a:tcPr>
+                </a:tc>
+              </a:tr>
+              <a:tr h="295101">
+                <a:tc>
+                  <a:txBody>
+                    <a:bodyPr/>
+                    <a:lstStyle/>
+                    <a:p>
+                      <a:pPr algn="l"/>
+                      <a:r>
+                        <a:rPr sz="800" b="0">
+                          <a:solidFill>
+                            <a:srgbClr val="FFFFFF"/>
+                          </a:solidFill>
+                          <a:latin typeface="Calibri"/>
+                        </a:rPr>
+                        <a:t>pvc-pending</a:t>
+                      </a:r>
+                    </a:p>
+                  </a:txBody>
+                  <a:tcPr anchor="ctr" marT="19050" marB="19050" marL="50800" marR="50800">
+                    <a:solidFill>
+                      <a:srgbClr val="242424"/>
+                    </a:solidFill>
+                  </a:tcPr>
+                </a:tc>
+                <a:tc>
+                  <a:txBody>
+                    <a:bodyPr/>
+                    <a:lstStyle/>
+                    <a:p>
+                      <a:pPr algn="l"/>
+                      <a:r>
+                        <a:rPr sz="800" b="0">
+                          <a:solidFill>
+                            <a:srgbClr val="FFFFFF"/>
+                          </a:solidFill>
+                          <a:latin typeface="Calibri"/>
+                        </a:rPr>
+                        <a:t>Required PVC missing -- can't schedule</a:t>
+                      </a:r>
+                    </a:p>
+                  </a:txBody>
+                  <a:tcPr anchor="ctr" marT="19050" marB="19050" marL="50800" marR="50800">
+                    <a:solidFill>
+                      <a:srgbClr val="242424"/>
+                    </a:solidFill>
+                  </a:tcPr>
+                </a:tc>
+                <a:tc>
+                  <a:txBody>
+                    <a:bodyPr/>
+                    <a:lstStyle/>
+                    <a:p>
+                      <a:pPr algn="l"/>
+                      <a:r>
+                        <a:rPr sz="800" b="0">
+                          <a:solidFill>
+                            <a:srgbClr val="CCCCCC"/>
+                          </a:solidFill>
+                          <a:latin typeface="Calibri"/>
+                        </a:rPr>
+                        <a:t>Correct</a:t>
+                      </a:r>
+                    </a:p>
+                  </a:txBody>
+                  <a:tcPr anchor="ctr" marT="19050" marB="19050" marL="50800" marR="50800">
+                    <a:solidFill>
+                      <a:srgbClr val="242424"/>
+                    </a:solidFill>
+                  </a:tcPr>
+                </a:tc>
+                <a:tc>
+                  <a:txBody>
+                    <a:bodyPr/>
+                    <a:lstStyle/>
+                    <a:p>
+                      <a:pPr algn="l"/>
+                      <a:r>
+                        <a:rPr sz="800" b="0">
+                          <a:solidFill>
+                            <a:srgbClr val="CCCCCC"/>
+                          </a:solidFill>
+                          <a:latin typeface="Calibri"/>
+                        </a:rPr>
+                        <a:t>0.90 auto</a:t>
+                      </a:r>
+                    </a:p>
+                  </a:txBody>
+                  <a:tcPr anchor="ctr" marT="19050" marB="19050" marL="50800" marR="50800">
+                    <a:solidFill>
+                      <a:srgbClr val="242424"/>
+                    </a:solidFill>
+                  </a:tcPr>
+                </a:tc>
+                <a:tc>
+                  <a:txBody>
+                    <a:bodyPr/>
+                    <a:lstStyle/>
+                    <a:p>
+                      <a:pPr algn="l"/>
+                      <a:r>
+                        <a:rPr sz="800" b="1">
+                          <a:solidFill>
+                            <a:srgbClr val="1ABC9C"/>
+                          </a:solidFill>
+                          <a:latin typeface="Calibri"/>
+                        </a:rPr>
+                        <a:t>Passed</a:t>
+                      </a:r>
+                    </a:p>
+                  </a:txBody>
+                  <a:tcPr anchor="ctr" marT="19050" marB="19050" marL="50800" marR="50800">
+                    <a:solidFill>
+                      <a:srgbClr val="242424"/>
+                    </a:solidFill>
+                  </a:tcPr>
+                </a:tc>
+              </a:tr>
+              <a:tr h="295101">
+                <a:tc>
+                  <a:txBody>
+                    <a:bodyPr/>
+                    <a:lstStyle/>
+                    <a:p>
+                      <a:pPr algn="l"/>
+                      <a:r>
+                        <a:rPr sz="800" b="0">
+                          <a:solidFill>
+                            <a:srgbClr val="FFFFFF"/>
+                          </a:solidFill>
+                          <a:latin typeface="Calibri"/>
+                        </a:rPr>
+                        <a:t>cascading</a:t>
+                      </a:r>
+                    </a:p>
+                  </a:txBody>
+                  <a:tcPr anchor="ctr" marT="19050" marB="19050" marL="50800" marR="50800">
+                    <a:solidFill>
+                      <a:srgbClr val="2A2A2A"/>
+                    </a:solidFill>
+                  </a:tcPr>
+                </a:tc>
+                <a:tc>
+                  <a:txBody>
+                    <a:bodyPr/>
+                    <a:lstStyle/>
+                    <a:p>
+                      <a:pPr algn="l"/>
+                      <a:r>
+                        <a:rPr sz="800" b="0">
+                          <a:solidFill>
+                            <a:srgbClr val="FFFFFF"/>
+                          </a:solidFill>
+                          <a:latin typeface="Calibri"/>
+                        </a:rPr>
+                        <a:t>Escalated honestly -- logs blocked by permissions</a:t>
+                      </a:r>
+                    </a:p>
+                  </a:txBody>
+                  <a:tcPr anchor="ctr" marT="19050" marB="19050" marL="50800" marR="50800">
+                    <a:solidFill>
+                      <a:srgbClr val="2A2A2A"/>
+                    </a:solidFill>
+                  </a:tcPr>
+                </a:tc>
+                <a:tc>
+                  <a:txBody>
+                    <a:bodyPr/>
+                    <a:lstStyle/>
+                    <a:p>
+                      <a:pPr algn="l"/>
+                      <a:r>
+                        <a:rPr sz="800" b="0">
+                          <a:solidFill>
+                            <a:srgbClr val="CCCCCC"/>
+                          </a:solidFill>
+                          <a:latin typeface="Calibri"/>
+                        </a:rPr>
+                        <a:t>Honest escalation</a:t>
+                      </a:r>
+                    </a:p>
+                  </a:txBody>
+                  <a:tcPr anchor="ctr" marT="19050" marB="19050" marL="50800" marR="50800">
+                    <a:solidFill>
+                      <a:srgbClr val="2A2A2A"/>
+                    </a:solidFill>
+                  </a:tcPr>
+                </a:tc>
+                <a:tc>
+                  <a:txBody>
+                    <a:bodyPr/>
+                    <a:lstStyle/>
+                    <a:p>
+                      <a:pPr algn="l"/>
+                      <a:r>
+                        <a:rPr sz="800" b="0">
+                          <a:solidFill>
+                            <a:srgbClr val="CCCCCC"/>
+                          </a:solidFill>
+                          <a:latin typeface="Calibri"/>
+                        </a:rPr>
+                        <a:t>0.20 escalate</a:t>
+                      </a:r>
+                    </a:p>
+                  </a:txBody>
+                  <a:tcPr anchor="ctr" marT="19050" marB="19050" marL="50800" marR="50800">
+                    <a:solidFill>
+                      <a:srgbClr val="2A2A2A"/>
+                    </a:solidFill>
+                  </a:tcPr>
+                </a:tc>
+                <a:tc>
+                  <a:txBody>
+                    <a:bodyPr/>
+                    <a:lstStyle/>
+                    <a:p>
+                      <a:pPr algn="l"/>
+                      <a:r>
+                        <a:rPr sz="800" b="1">
+                          <a:solidFill>
+                            <a:srgbClr val="F4C542"/>
+                          </a:solidFill>
+                          <a:latin typeface="Calibri"/>
+                        </a:rPr>
+                        <a:t>Scored fail*</a:t>
+                      </a:r>
+                    </a:p>
+                  </a:txBody>
+                  <a:tcPr anchor="ctr" marT="19050" marB="19050" marL="50800" marR="50800">
+                    <a:solidFill>
+                      <a:srgbClr val="2A2A2A"/>
+                    </a:solidFill>
+                  </a:tcPr>
+                </a:tc>
+              </a:tr>
+              <a:tr h="295101">
+                <a:tc>
+                  <a:txBody>
+                    <a:bodyPr/>
+                    <a:lstStyle/>
+                    <a:p>
+                      <a:pPr algn="l"/>
+                      <a:r>
+                        <a:rPr sz="800" b="0">
+                          <a:solidFill>
+                            <a:srgbClr val="FFFFFF"/>
+                          </a:solidFill>
+                          <a:latin typeface="Calibri"/>
+                        </a:rPr>
+                        <a:t>already-resolved</a:t>
+                      </a:r>
+                    </a:p>
+                  </a:txBody>
+                  <a:tcPr anchor="ctr" marT="19050" marB="19050" marL="50800" marR="50800">
+                    <a:solidFill>
+                      <a:srgbClr val="242424"/>
+                    </a:solidFill>
+                  </a:tcPr>
+                </a:tc>
+                <a:tc>
+                  <a:txBody>
+                    <a:bodyPr/>
+                    <a:lstStyle/>
+                    <a:p>
+                      <a:pPr algn="l"/>
+                      <a:r>
+                        <a:rPr sz="800" b="0">
+                          <a:solidFill>
+                            <a:srgbClr val="FFFFFF"/>
+                          </a:solidFill>
+                          <a:latin typeface="Calibri"/>
+                        </a:rPr>
+                        <a:t>Self-diagnosed the exact missing RoleBinding</a:t>
+                      </a:r>
+                    </a:p>
+                  </a:txBody>
+                  <a:tcPr anchor="ctr" marT="19050" marB="19050" marL="50800" marR="50800">
+                    <a:solidFill>
+                      <a:srgbClr val="242424"/>
+                    </a:solidFill>
+                  </a:tcPr>
+                </a:tc>
+                <a:tc>
+                  <a:txBody>
+                    <a:bodyPr/>
+                    <a:lstStyle/>
+                    <a:p>
+                      <a:pPr algn="l"/>
+                      <a:r>
+                        <a:rPr sz="800" b="0">
+                          <a:solidFill>
+                            <a:srgbClr val="CCCCCC"/>
+                          </a:solidFill>
+                          <a:latin typeface="Calibri"/>
+                        </a:rPr>
+                        <a:t>Honest diagnosis</a:t>
+                      </a:r>
+                    </a:p>
+                  </a:txBody>
+                  <a:tcPr anchor="ctr" marT="19050" marB="19050" marL="50800" marR="50800">
+                    <a:solidFill>
+                      <a:srgbClr val="242424"/>
+                    </a:solidFill>
+                  </a:tcPr>
+                </a:tc>
+                <a:tc>
+                  <a:txBody>
+                    <a:bodyPr/>
+                    <a:lstStyle/>
+                    <a:p>
+                      <a:pPr algn="l"/>
+                      <a:r>
+                        <a:rPr sz="800" b="0">
+                          <a:solidFill>
+                            <a:srgbClr val="CCCCCC"/>
+                          </a:solidFill>
+                          <a:latin typeface="Calibri"/>
+                        </a:rPr>
+                        <a:t>0.80 review</a:t>
+                      </a:r>
+                    </a:p>
+                  </a:txBody>
+                  <a:tcPr anchor="ctr" marT="19050" marB="19050" marL="50800" marR="50800">
+                    <a:solidFill>
+                      <a:srgbClr val="242424"/>
+                    </a:solidFill>
+                  </a:tcPr>
+                </a:tc>
+                <a:tc>
+                  <a:txBody>
+                    <a:bodyPr/>
+                    <a:lstStyle/>
+                    <a:p>
+                      <a:pPr algn="l"/>
+                      <a:r>
+                        <a:rPr sz="800" b="1">
+                          <a:solidFill>
+                            <a:srgbClr val="F4C542"/>
+                          </a:solidFill>
+                          <a:latin typeface="Calibri"/>
+                        </a:rPr>
+                        <a:t>Scored fail*</a:t>
+                      </a:r>
+                    </a:p>
+                  </a:txBody>
+                  <a:tcPr anchor="ctr" marT="19050" marB="19050" marL="50800" marR="50800">
+                    <a:solidFill>
+                      <a:srgbClr val="242424"/>
+                    </a:solidFill>
+                  </a:tcPr>
+                </a:tc>
+              </a:tr>
+              <a:tr h="295110">
+                <a:tc>
+                  <a:txBody>
+                    <a:bodyPr/>
+                    <a:lstStyle/>
+                    <a:p>
+                      <a:pPr algn="l"/>
+                      <a:r>
+                        <a:rPr sz="800" b="0">
+                          <a:solidFill>
+                            <a:srgbClr val="FFFFFF"/>
+                          </a:solidFill>
+                          <a:latin typeface="Calibri"/>
+                        </a:rPr>
+                        <a:t>bad-command</a:t>
+                      </a:r>
+                    </a:p>
+                  </a:txBody>
+                  <a:tcPr anchor="ctr" marT="19050" marB="19050" marL="50800" marR="50800">
+                    <a:solidFill>
+                      <a:srgbClr val="2A2A2A"/>
+                    </a:solidFill>
+                  </a:tcPr>
+                </a:tc>
+                <a:tc>
+                  <a:txBody>
+                    <a:bodyPr/>
+                    <a:lstStyle/>
+                    <a:p>
+                      <a:pPr algn="l"/>
+                      <a:r>
+                        <a:rPr sz="800" b="0">
+                          <a:solidFill>
+                            <a:srgbClr val="FFFFFF"/>
+                          </a:solidFill>
+                          <a:latin typeface="Calibri"/>
+                        </a:rPr>
+                        <a:t>Escalated honestly -- logs blocked by permissions</a:t>
+                      </a:r>
+                    </a:p>
+                  </a:txBody>
+                  <a:tcPr anchor="ctr" marT="19050" marB="19050" marL="50800" marR="50800">
+                    <a:solidFill>
+                      <a:srgbClr val="2A2A2A"/>
+                    </a:solidFill>
+                  </a:tcPr>
+                </a:tc>
+                <a:tc>
+                  <a:txBody>
+                    <a:bodyPr/>
+                    <a:lstStyle/>
+                    <a:p>
+                      <a:pPr algn="l"/>
+                      <a:r>
+                        <a:rPr sz="800" b="0">
+                          <a:solidFill>
+                            <a:srgbClr val="CCCCCC"/>
+                          </a:solidFill>
+                          <a:latin typeface="Calibri"/>
+                        </a:rPr>
+                        <a:t>Honest escalation</a:t>
+                      </a:r>
+                    </a:p>
+                  </a:txBody>
+                  <a:tcPr anchor="ctr" marT="19050" marB="19050" marL="50800" marR="50800">
+                    <a:solidFill>
+                      <a:srgbClr val="2A2A2A"/>
+                    </a:solidFill>
+                  </a:tcPr>
+                </a:tc>
+                <a:tc>
+                  <a:txBody>
+                    <a:bodyPr/>
+                    <a:lstStyle/>
+                    <a:p>
+                      <a:pPr algn="l"/>
+                      <a:r>
+                        <a:rPr sz="800" b="0">
+                          <a:solidFill>
+                            <a:srgbClr val="CCCCCC"/>
+                          </a:solidFill>
+                          <a:latin typeface="Calibri"/>
+                        </a:rPr>
+                        <a:t>0.20 escalate</a:t>
+                      </a:r>
+                    </a:p>
+                  </a:txBody>
+                  <a:tcPr anchor="ctr" marT="19050" marB="19050" marL="50800" marR="50800">
+                    <a:solidFill>
+                      <a:srgbClr val="2A2A2A"/>
+                    </a:solidFill>
+                  </a:tcPr>
+                </a:tc>
+                <a:tc>
+                  <a:txBody>
+                    <a:bodyPr/>
+                    <a:lstStyle/>
+                    <a:p>
+                      <a:pPr algn="l"/>
+                      <a:r>
+                        <a:rPr sz="800" b="1">
+                          <a:solidFill>
+                            <a:srgbClr val="F4C542"/>
+                          </a:solidFill>
+                          <a:latin typeface="Calibri"/>
+                        </a:rPr>
+                        <a:t>Scored fail*</a:t>
+                      </a:r>
+                    </a:p>
+                  </a:txBody>
+                  <a:tcPr anchor="ctr" marT="19050" marB="19050" marL="50800" marR="50800">
+                    <a:solidFill>
+                      <a:srgbClr val="2A2A2A"/>
+                    </a:solidFill>
+                  </a:tcPr>
+                </a:tc>
+              </a:tr>
+            </a:tbl>
+          </a:graphicData>
+        </a:graphic>
+      </p:graphicFrame>
+      <p:sp>
+        <p:nvSpPr>
+          <p:cNvPr id="6" name="TextBox 5"/>
+          <p:cNvSpPr txBox="1"/>
+          <p:nvPr/>
+        </p:nvSpPr>
+        <p:spPr>
+          <a:xfrm>
+            <a:off x="457200" y="4389120"/>
+            <a:ext cx="8229600" cy="320040"/>
+          </a:xfrm>
+          <a:prstGeom prst="rect">
+            <a:avLst/>
+          </a:prstGeom>
+          <a:noFill/>
+        </p:spPr>
+        <p:txBody>
+          <a:bodyPr wrap="square">
+            <a:spAutoFit/>
+          </a:bodyPr>
+          <a:lstStyle/>
+          <a:p>
+            <a:pPr algn="l"/>
+            <a:r>
+              <a:rPr sz="950" b="0" i="1">
+                <a:solidFill>
+                  <a:srgbClr val="999999"/>
+                </a:solidFill>
+                <a:latin typeface="Calibri"/>
+              </a:rPr>
+              <a:t>*Scored "fail" by the strict keyword-match formula, not because the answer was wrong -- zero hallucinated root causes across all 10 investigations.</a:t>
+            </a:r>
+          </a:p>
+        </p:txBody>
+      </p:sp>
+    </p:spTree>
+  </p:cSld>
+  <p:clrMapOvr>
+    <a:masterClrMapping/>
+  </p:clrMapOvr>
+</p:sld>
+</file>
+
+<file path=ppt/slides/slide19.xml><?xml version="1.0" encoding="utf-8"?>
 <p:sld xmlns:a="http://schemas.openxmlformats.org/drawingml/2006/main" xmlns:r="http://schemas.openxmlformats.org/officeDocument/2006/relationships" xmlns:p="http://schemas.openxmlformats.org/presentationml/2006/main">
   <p:cSld name="Slide 21">
     <p:bg>
@@ -17745,681 +19318,6 @@
               <a:t>What it costs and how we measure success</a:t>
             </a:r>
             <a:endParaRPr lang="en-US" sz="1400" dirty="0"/>
-          </a:p>
-        </p:txBody>
-      </p:sp>
-    </p:spTree>
-  </p:cSld>
-  <p:clrMapOvr>
-    <a:masterClrMapping/>
-  </p:clrMapOvr>
-</p:sld>
-</file>
-
-<file path=ppt/slides/slide19.xml><?xml version="1.0" encoding="utf-8"?>
-<p:sld xmlns:a="http://schemas.openxmlformats.org/drawingml/2006/main" xmlns:p="http://schemas.openxmlformats.org/presentationml/2006/main" xmlns:r="http://schemas.openxmlformats.org/officeDocument/2006/relationships">
-  <p:cSld>
-    <p:spTree>
-      <p:nvGrpSpPr>
-        <p:cNvPr id="1" name=""/>
-        <p:cNvGrpSpPr/>
-        <p:nvPr/>
-      </p:nvGrpSpPr>
-      <p:grpSpPr/>
-      <p:sp>
-        <p:nvSpPr>
-          <p:cNvPr id="2" name="TextBox 1"/>
-          <p:cNvSpPr txBox="1"/>
-          <p:nvPr/>
-        </p:nvSpPr>
-        <p:spPr>
-          <a:xfrm>
-            <a:off x="7589520" y="137160"/>
-            <a:ext cx="1371600" cy="274320"/>
-          </a:xfrm>
-          <a:prstGeom prst="rect">
-            <a:avLst/>
-          </a:prstGeom>
-          <a:noFill/>
-        </p:spPr>
-        <p:txBody>
-          <a:bodyPr wrap="none">
-            <a:spAutoFit/>
-          </a:bodyPr>
-          <a:lstStyle/>
-          <a:p>
-            <a:r>
-              <a:rPr sz="1200" b="1">
-                <a:solidFill>
-                  <a:srgbClr val="3CB371"/>
-                </a:solidFill>
-                <a:latin typeface="Trebuchet MS"/>
-              </a:rPr>
-              <a:t>SECTIGO</a:t>
-            </a:r>
-          </a:p>
-        </p:txBody>
-      </p:sp>
-      <p:sp>
-        <p:nvSpPr>
-          <p:cNvPr id="3" name="Rectangle 2"/>
-          <p:cNvSpPr/>
-          <p:nvPr/>
-        </p:nvSpPr>
-        <p:spPr>
-          <a:xfrm>
-            <a:off x="457200" y="182880"/>
-            <a:ext cx="1188720" cy="256032"/>
-          </a:xfrm>
-          <a:prstGeom prst="rect">
-            <a:avLst/>
-          </a:prstGeom>
-          <a:solidFill>
-            <a:srgbClr val="F4C542"/>
-          </a:solidFill>
-          <a:ln>
-            <a:noFill/>
-          </a:ln>
-          <a:effectLst/>
-        </p:spPr>
-        <p:style>
-          <a:lnRef idx="1">
-            <a:schemeClr val="accent1"/>
-          </a:lnRef>
-          <a:fillRef idx="3">
-            <a:schemeClr val="accent1"/>
-          </a:fillRef>
-          <a:effectRef idx="2">
-            <a:schemeClr val="accent1"/>
-          </a:effectRef>
-          <a:fontRef idx="minor">
-            <a:schemeClr val="lt1"/>
-          </a:fontRef>
-        </p:style>
-        <p:txBody>
-          <a:bodyPr rtlCol="0" anchor="ctr"/>
-          <a:lstStyle/>
-          <a:p>
-            <a:pPr algn="ctr"/>
-            <a:r>
-              <a:rPr sz="900" b="1">
-                <a:solidFill>
-                  <a:srgbClr val="1A1A1A"/>
-                </a:solidFill>
-                <a:latin typeface="Trebuchet MS"/>
-              </a:rPr>
-              <a:t>COST &amp; VALUE</a:t>
-            </a:r>
-          </a:p>
-        </p:txBody>
-      </p:sp>
-      <p:sp>
-        <p:nvSpPr>
-          <p:cNvPr id="4" name="TextBox 3"/>
-          <p:cNvSpPr txBox="1"/>
-          <p:nvPr/>
-        </p:nvSpPr>
-        <p:spPr>
-          <a:xfrm>
-            <a:off x="457200" y="594360"/>
-            <a:ext cx="8229600" cy="411480"/>
-          </a:xfrm>
-          <a:prstGeom prst="rect">
-            <a:avLst/>
-          </a:prstGeom>
-          <a:noFill/>
-        </p:spPr>
-        <p:txBody>
-          <a:bodyPr wrap="square">
-            <a:spAutoFit/>
-          </a:bodyPr>
-          <a:lstStyle/>
-          <a:p>
-            <a:pPr algn="l"/>
-            <a:r>
-              <a:rPr sz="2000" b="1">
-                <a:solidFill>
-                  <a:srgbClr val="FFFFFF"/>
-                </a:solidFill>
-                <a:latin typeface="Calibri"/>
-              </a:rPr>
-              <a:t>What This Actually Costs</a:t>
-            </a:r>
-          </a:p>
-        </p:txBody>
-      </p:sp>
-      <p:sp>
-        <p:nvSpPr>
-          <p:cNvPr id="5" name="Rectangle 4"/>
-          <p:cNvSpPr/>
-          <p:nvPr/>
-        </p:nvSpPr>
-        <p:spPr>
-          <a:xfrm>
-            <a:off x="457200" y="1234440"/>
-            <a:ext cx="2560320" cy="914400"/>
-          </a:xfrm>
-          <a:prstGeom prst="rect">
-            <a:avLst/>
-          </a:prstGeom>
-          <a:solidFill>
-            <a:srgbClr val="242424"/>
-          </a:solidFill>
-          <a:ln>
-            <a:noFill/>
-          </a:ln>
-          <a:effectLst/>
-        </p:spPr>
-        <p:style>
-          <a:lnRef idx="1">
-            <a:schemeClr val="accent1"/>
-          </a:lnRef>
-          <a:fillRef idx="3">
-            <a:schemeClr val="accent1"/>
-          </a:fillRef>
-          <a:effectRef idx="2">
-            <a:schemeClr val="accent1"/>
-          </a:effectRef>
-          <a:fontRef idx="minor">
-            <a:schemeClr val="lt1"/>
-          </a:fontRef>
-        </p:style>
-        <p:txBody>
-          <a:bodyPr rtlCol="0" anchor="ctr"/>
-          <a:lstStyle/>
-          <a:p>
-            <a:pPr algn="ctr"/>
-          </a:p>
-        </p:txBody>
-      </p:sp>
-      <p:sp>
-        <p:nvSpPr>
-          <p:cNvPr id="6" name="TextBox 5"/>
-          <p:cNvSpPr txBox="1"/>
-          <p:nvPr/>
-        </p:nvSpPr>
-        <p:spPr>
-          <a:xfrm>
-            <a:off x="594360" y="1325880"/>
-            <a:ext cx="2286000" cy="457200"/>
-          </a:xfrm>
-          <a:prstGeom prst="rect">
-            <a:avLst/>
-          </a:prstGeom>
-          <a:noFill/>
-        </p:spPr>
-        <p:txBody>
-          <a:bodyPr wrap="square">
-            <a:spAutoFit/>
-          </a:bodyPr>
-          <a:lstStyle/>
-          <a:p>
-            <a:pPr algn="l"/>
-            <a:r>
-              <a:rPr sz="2400" b="1">
-                <a:solidFill>
-                  <a:srgbClr val="1ABC9C"/>
-                </a:solidFill>
-                <a:latin typeface="Calibri"/>
-              </a:rPr>
-              <a:t>$0.0025</a:t>
-            </a:r>
-          </a:p>
-        </p:txBody>
-      </p:sp>
-      <p:sp>
-        <p:nvSpPr>
-          <p:cNvPr id="7" name="TextBox 6"/>
-          <p:cNvSpPr txBox="1"/>
-          <p:nvPr/>
-        </p:nvSpPr>
-        <p:spPr>
-          <a:xfrm>
-            <a:off x="594360" y="1783080"/>
-            <a:ext cx="2286000" cy="320040"/>
-          </a:xfrm>
-          <a:prstGeom prst="rect">
-            <a:avLst/>
-          </a:prstGeom>
-          <a:noFill/>
-        </p:spPr>
-        <p:txBody>
-          <a:bodyPr wrap="square">
-            <a:spAutoFit/>
-          </a:bodyPr>
-          <a:lstStyle/>
-          <a:p>
-            <a:pPr algn="l"/>
-            <a:r>
-              <a:rPr sz="1000" b="0">
-                <a:solidFill>
-                  <a:srgbClr val="999999"/>
-                </a:solidFill>
-                <a:latin typeface="Calibri"/>
-              </a:rPr>
-              <a:t>Avg cost / investigation</a:t>
-            </a:r>
-          </a:p>
-        </p:txBody>
-      </p:sp>
-      <p:sp>
-        <p:nvSpPr>
-          <p:cNvPr id="8" name="Rectangle 7"/>
-          <p:cNvSpPr/>
-          <p:nvPr/>
-        </p:nvSpPr>
-        <p:spPr>
-          <a:xfrm>
-            <a:off x="3154679" y="1234440"/>
-            <a:ext cx="2560320" cy="914400"/>
-          </a:xfrm>
-          <a:prstGeom prst="rect">
-            <a:avLst/>
-          </a:prstGeom>
-          <a:solidFill>
-            <a:srgbClr val="242424"/>
-          </a:solidFill>
-          <a:ln>
-            <a:noFill/>
-          </a:ln>
-          <a:effectLst/>
-        </p:spPr>
-        <p:style>
-          <a:lnRef idx="1">
-            <a:schemeClr val="accent1"/>
-          </a:lnRef>
-          <a:fillRef idx="3">
-            <a:schemeClr val="accent1"/>
-          </a:fillRef>
-          <a:effectRef idx="2">
-            <a:schemeClr val="accent1"/>
-          </a:effectRef>
-          <a:fontRef idx="minor">
-            <a:schemeClr val="lt1"/>
-          </a:fontRef>
-        </p:style>
-        <p:txBody>
-          <a:bodyPr rtlCol="0" anchor="ctr"/>
-          <a:lstStyle/>
-          <a:p>
-            <a:pPr algn="ctr"/>
-          </a:p>
-        </p:txBody>
-      </p:sp>
-      <p:sp>
-        <p:nvSpPr>
-          <p:cNvPr id="9" name="TextBox 8"/>
-          <p:cNvSpPr txBox="1"/>
-          <p:nvPr/>
-        </p:nvSpPr>
-        <p:spPr>
-          <a:xfrm>
-            <a:off x="3291839" y="1325880"/>
-            <a:ext cx="2286000" cy="457200"/>
-          </a:xfrm>
-          <a:prstGeom prst="rect">
-            <a:avLst/>
-          </a:prstGeom>
-          <a:noFill/>
-        </p:spPr>
-        <p:txBody>
-          <a:bodyPr wrap="square">
-            <a:spAutoFit/>
-          </a:bodyPr>
-          <a:lstStyle/>
-          <a:p>
-            <a:pPr algn="l"/>
-            <a:r>
-              <a:rPr sz="2400" b="1">
-                <a:solidFill>
-                  <a:srgbClr val="F4C542"/>
-                </a:solidFill>
-                <a:latin typeface="Calibri"/>
-              </a:rPr>
-              <a:t>20.5s</a:t>
-            </a:r>
-          </a:p>
-        </p:txBody>
-      </p:sp>
-      <p:sp>
-        <p:nvSpPr>
-          <p:cNvPr id="10" name="TextBox 9"/>
-          <p:cNvSpPr txBox="1"/>
-          <p:nvPr/>
-        </p:nvSpPr>
-        <p:spPr>
-          <a:xfrm>
-            <a:off x="3291839" y="1783080"/>
-            <a:ext cx="2286000" cy="320040"/>
-          </a:xfrm>
-          <a:prstGeom prst="rect">
-            <a:avLst/>
-          </a:prstGeom>
-          <a:noFill/>
-        </p:spPr>
-        <p:txBody>
-          <a:bodyPr wrap="square">
-            <a:spAutoFit/>
-          </a:bodyPr>
-          <a:lstStyle/>
-          <a:p>
-            <a:pPr algn="l"/>
-            <a:r>
-              <a:rPr sz="1000" b="0">
-                <a:solidFill>
-                  <a:srgbClr val="999999"/>
-                </a:solidFill>
-                <a:latin typeface="Calibri"/>
-              </a:rPr>
-              <a:t>Avg latency / investigation</a:t>
-            </a:r>
-          </a:p>
-        </p:txBody>
-      </p:sp>
-      <p:sp>
-        <p:nvSpPr>
-          <p:cNvPr id="11" name="Rectangle 10"/>
-          <p:cNvSpPr/>
-          <p:nvPr/>
-        </p:nvSpPr>
-        <p:spPr>
-          <a:xfrm>
-            <a:off x="5852159" y="1234440"/>
-            <a:ext cx="2560320" cy="914400"/>
-          </a:xfrm>
-          <a:prstGeom prst="rect">
-            <a:avLst/>
-          </a:prstGeom>
-          <a:solidFill>
-            <a:srgbClr val="242424"/>
-          </a:solidFill>
-          <a:ln>
-            <a:noFill/>
-          </a:ln>
-          <a:effectLst/>
-        </p:spPr>
-        <p:style>
-          <a:lnRef idx="1">
-            <a:schemeClr val="accent1"/>
-          </a:lnRef>
-          <a:fillRef idx="3">
-            <a:schemeClr val="accent1"/>
-          </a:fillRef>
-          <a:effectRef idx="2">
-            <a:schemeClr val="accent1"/>
-          </a:effectRef>
-          <a:fontRef idx="minor">
-            <a:schemeClr val="lt1"/>
-          </a:fontRef>
-        </p:style>
-        <p:txBody>
-          <a:bodyPr rtlCol="0" anchor="ctr"/>
-          <a:lstStyle/>
-          <a:p>
-            <a:pPr algn="ctr"/>
-          </a:p>
-        </p:txBody>
-      </p:sp>
-      <p:sp>
-        <p:nvSpPr>
-          <p:cNvPr id="12" name="TextBox 11"/>
-          <p:cNvSpPr txBox="1"/>
-          <p:nvPr/>
-        </p:nvSpPr>
-        <p:spPr>
-          <a:xfrm>
-            <a:off x="5989320" y="1325880"/>
-            <a:ext cx="2286000" cy="457200"/>
-          </a:xfrm>
-          <a:prstGeom prst="rect">
-            <a:avLst/>
-          </a:prstGeom>
-          <a:noFill/>
-        </p:spPr>
-        <p:txBody>
-          <a:bodyPr wrap="square">
-            <a:spAutoFit/>
-          </a:bodyPr>
-          <a:lstStyle/>
-          <a:p>
-            <a:pPr algn="l"/>
-            <a:r>
-              <a:rPr sz="2400" b="1">
-                <a:solidFill>
-                  <a:srgbClr val="E8751A"/>
-                </a:solidFill>
-                <a:latin typeface="Calibri"/>
-              </a:rPr>
-              <a:t>~13K</a:t>
-            </a:r>
-          </a:p>
-        </p:txBody>
-      </p:sp>
-      <p:sp>
-        <p:nvSpPr>
-          <p:cNvPr id="13" name="TextBox 12"/>
-          <p:cNvSpPr txBox="1"/>
-          <p:nvPr/>
-        </p:nvSpPr>
-        <p:spPr>
-          <a:xfrm>
-            <a:off x="5989320" y="1783080"/>
-            <a:ext cx="2286000" cy="320040"/>
-          </a:xfrm>
-          <a:prstGeom prst="rect">
-            <a:avLst/>
-          </a:prstGeom>
-          <a:noFill/>
-        </p:spPr>
-        <p:txBody>
-          <a:bodyPr wrap="square">
-            <a:spAutoFit/>
-          </a:bodyPr>
-          <a:lstStyle/>
-          <a:p>
-            <a:pPr algn="l"/>
-            <a:r>
-              <a:rPr sz="1000" b="0">
-                <a:solidFill>
-                  <a:srgbClr val="999999"/>
-                </a:solidFill>
-                <a:latin typeface="Calibri"/>
-              </a:rPr>
-              <a:t>Avg tokens / investigation</a:t>
-            </a:r>
-          </a:p>
-        </p:txBody>
-      </p:sp>
-      <p:sp>
-        <p:nvSpPr>
-          <p:cNvPr id="14" name="Rectangle 13"/>
-          <p:cNvSpPr/>
-          <p:nvPr/>
-        </p:nvSpPr>
-        <p:spPr>
-          <a:xfrm>
-            <a:off x="457200" y="2331720"/>
-            <a:ext cx="8229600" cy="914400"/>
-          </a:xfrm>
-          <a:prstGeom prst="rect">
-            <a:avLst/>
-          </a:prstGeom>
-          <a:solidFill>
-            <a:srgbClr val="242424"/>
-          </a:solidFill>
-          <a:ln>
-            <a:noFill/>
-          </a:ln>
-          <a:effectLst/>
-        </p:spPr>
-        <p:style>
-          <a:lnRef idx="1">
-            <a:schemeClr val="accent1"/>
-          </a:lnRef>
-          <a:fillRef idx="3">
-            <a:schemeClr val="accent1"/>
-          </a:fillRef>
-          <a:effectRef idx="2">
-            <a:schemeClr val="accent1"/>
-          </a:effectRef>
-          <a:fontRef idx="minor">
-            <a:schemeClr val="lt1"/>
-          </a:fontRef>
-        </p:style>
-        <p:txBody>
-          <a:bodyPr rtlCol="0" anchor="ctr"/>
-          <a:lstStyle/>
-          <a:p>
-            <a:pPr algn="ctr"/>
-          </a:p>
-        </p:txBody>
-      </p:sp>
-      <p:sp>
-        <p:nvSpPr>
-          <p:cNvPr id="15" name="Rectangle 14"/>
-          <p:cNvSpPr/>
-          <p:nvPr/>
-        </p:nvSpPr>
-        <p:spPr>
-          <a:xfrm>
-            <a:off x="457200" y="2331720"/>
-            <a:ext cx="54864" cy="914400"/>
-          </a:xfrm>
-          <a:prstGeom prst="rect">
-            <a:avLst/>
-          </a:prstGeom>
-          <a:solidFill>
-            <a:srgbClr val="1ABC9C"/>
-          </a:solidFill>
-          <a:ln>
-            <a:noFill/>
-          </a:ln>
-          <a:effectLst/>
-        </p:spPr>
-        <p:style>
-          <a:lnRef idx="1">
-            <a:schemeClr val="accent1"/>
-          </a:lnRef>
-          <a:fillRef idx="3">
-            <a:schemeClr val="accent1"/>
-          </a:fillRef>
-          <a:effectRef idx="2">
-            <a:schemeClr val="accent1"/>
-          </a:effectRef>
-          <a:fontRef idx="minor">
-            <a:schemeClr val="lt1"/>
-          </a:fontRef>
-        </p:style>
-        <p:txBody>
-          <a:bodyPr rtlCol="0" anchor="ctr"/>
-          <a:lstStyle/>
-          <a:p>
-            <a:pPr algn="ctr"/>
-          </a:p>
-        </p:txBody>
-      </p:sp>
-      <p:sp>
-        <p:nvSpPr>
-          <p:cNvPr id="16" name="TextBox 15"/>
-          <p:cNvSpPr txBox="1"/>
-          <p:nvPr/>
-        </p:nvSpPr>
-        <p:spPr>
-          <a:xfrm>
-            <a:off x="658368" y="2423160"/>
-            <a:ext cx="7863840" cy="731520"/>
-          </a:xfrm>
-          <a:prstGeom prst="rect">
-            <a:avLst/>
-          </a:prstGeom>
-          <a:noFill/>
-        </p:spPr>
-        <p:txBody>
-          <a:bodyPr wrap="square">
-            <a:spAutoFit/>
-          </a:bodyPr>
-          <a:lstStyle/>
-          <a:p>
-            <a:pPr algn="l"/>
-            <a:r>
-              <a:rPr sz="1100" b="0">
-                <a:solidFill>
-                  <a:srgbClr val="CCCCCC"/>
-                </a:solidFill>
-                <a:latin typeface="Calibri"/>
-              </a:rPr>
-              <a:t>Real numbers from the actual eval run — not estimated. Every investigation's token usage and cost is tracked individually and exported to Cloud Monitoring, with a cost-spike alert already deployed.</a:t>
-            </a:r>
-          </a:p>
-        </p:txBody>
-      </p:sp>
-      <p:sp>
-        <p:nvSpPr>
-          <p:cNvPr id="17" name="TextBox 16"/>
-          <p:cNvSpPr txBox="1"/>
-          <p:nvPr/>
-        </p:nvSpPr>
-        <p:spPr>
-          <a:xfrm>
-            <a:off x="457200" y="3429000"/>
-            <a:ext cx="8229600" cy="274320"/>
-          </a:xfrm>
-          <a:prstGeom prst="rect">
-            <a:avLst/>
-          </a:prstGeom>
-          <a:noFill/>
-        </p:spPr>
-        <p:txBody>
-          <a:bodyPr wrap="square">
-            <a:spAutoFit/>
-          </a:bodyPr>
-          <a:lstStyle/>
-          <a:p>
-            <a:pPr algn="l"/>
-            <a:r>
-              <a:rPr sz="1100" b="1">
-                <a:solidFill>
-                  <a:srgbClr val="FFFFFF"/>
-                </a:solidFill>
-                <a:latin typeface="Calibri"/>
-              </a:rPr>
-              <a:t>How this scales:</a:t>
-            </a:r>
-          </a:p>
-        </p:txBody>
-      </p:sp>
-      <p:sp>
-        <p:nvSpPr>
-          <p:cNvPr id="18" name="TextBox 17"/>
-          <p:cNvSpPr txBox="1"/>
-          <p:nvPr/>
-        </p:nvSpPr>
-        <p:spPr>
-          <a:xfrm>
-            <a:off x="457200" y="3703320"/>
-            <a:ext cx="8229600" cy="457200"/>
-          </a:xfrm>
-          <a:prstGeom prst="rect">
-            <a:avLst/>
-          </a:prstGeom>
-          <a:noFill/>
-        </p:spPr>
-        <p:txBody>
-          <a:bodyPr wrap="square">
-            <a:spAutoFit/>
-          </a:bodyPr>
-          <a:lstStyle/>
-          <a:p>
-            <a:pPr algn="l"/>
-            <a:r>
-              <a:rPr sz="1050" b="0">
-                <a:solidFill>
-                  <a:srgbClr val="CCCCCC"/>
-                </a:solidFill>
-                <a:latin typeface="Calibri"/>
-              </a:rPr>
-              <a:t>At this rate, 1,000 investigations/month is roughly $2.50 in model cost — the real constraint on scale is engineering time to expand coverage, not per-run spend.</a:t>
-            </a:r>
           </a:p>
         </p:txBody>
       </p:sp>
@@ -18712,6 +19610,681 @@
 </file>
 
 <file path=ppt/slides/slide20.xml><?xml version="1.0" encoding="utf-8"?>
+<p:sld xmlns:a="http://schemas.openxmlformats.org/drawingml/2006/main" xmlns:p="http://schemas.openxmlformats.org/presentationml/2006/main" xmlns:r="http://schemas.openxmlformats.org/officeDocument/2006/relationships">
+  <p:cSld>
+    <p:spTree>
+      <p:nvGrpSpPr>
+        <p:cNvPr id="1" name=""/>
+        <p:cNvGrpSpPr/>
+        <p:nvPr/>
+      </p:nvGrpSpPr>
+      <p:grpSpPr/>
+      <p:sp>
+        <p:nvSpPr>
+          <p:cNvPr id="2" name="TextBox 1"/>
+          <p:cNvSpPr txBox="1"/>
+          <p:nvPr/>
+        </p:nvSpPr>
+        <p:spPr>
+          <a:xfrm>
+            <a:off x="7589520" y="137160"/>
+            <a:ext cx="1371600" cy="274320"/>
+          </a:xfrm>
+          <a:prstGeom prst="rect">
+            <a:avLst/>
+          </a:prstGeom>
+          <a:noFill/>
+        </p:spPr>
+        <p:txBody>
+          <a:bodyPr wrap="none">
+            <a:spAutoFit/>
+          </a:bodyPr>
+          <a:lstStyle/>
+          <a:p>
+            <a:r>
+              <a:rPr sz="1200" b="1">
+                <a:solidFill>
+                  <a:srgbClr val="3CB371"/>
+                </a:solidFill>
+                <a:latin typeface="Trebuchet MS"/>
+              </a:rPr>
+              <a:t>SECTIGO</a:t>
+            </a:r>
+          </a:p>
+        </p:txBody>
+      </p:sp>
+      <p:sp>
+        <p:nvSpPr>
+          <p:cNvPr id="3" name="Rectangle 2"/>
+          <p:cNvSpPr/>
+          <p:nvPr/>
+        </p:nvSpPr>
+        <p:spPr>
+          <a:xfrm>
+            <a:off x="457200" y="182880"/>
+            <a:ext cx="1188720" cy="256032"/>
+          </a:xfrm>
+          <a:prstGeom prst="rect">
+            <a:avLst/>
+          </a:prstGeom>
+          <a:solidFill>
+            <a:srgbClr val="F4C542"/>
+          </a:solidFill>
+          <a:ln>
+            <a:noFill/>
+          </a:ln>
+          <a:effectLst/>
+        </p:spPr>
+        <p:style>
+          <a:lnRef idx="1">
+            <a:schemeClr val="accent1"/>
+          </a:lnRef>
+          <a:fillRef idx="3">
+            <a:schemeClr val="accent1"/>
+          </a:fillRef>
+          <a:effectRef idx="2">
+            <a:schemeClr val="accent1"/>
+          </a:effectRef>
+          <a:fontRef idx="minor">
+            <a:schemeClr val="lt1"/>
+          </a:fontRef>
+        </p:style>
+        <p:txBody>
+          <a:bodyPr rtlCol="0" anchor="ctr"/>
+          <a:lstStyle/>
+          <a:p>
+            <a:pPr algn="ctr"/>
+            <a:r>
+              <a:rPr sz="900" b="1">
+                <a:solidFill>
+                  <a:srgbClr val="1A1A1A"/>
+                </a:solidFill>
+                <a:latin typeface="Trebuchet MS"/>
+              </a:rPr>
+              <a:t>COST &amp; VALUE</a:t>
+            </a:r>
+          </a:p>
+        </p:txBody>
+      </p:sp>
+      <p:sp>
+        <p:nvSpPr>
+          <p:cNvPr id="4" name="TextBox 3"/>
+          <p:cNvSpPr txBox="1"/>
+          <p:nvPr/>
+        </p:nvSpPr>
+        <p:spPr>
+          <a:xfrm>
+            <a:off x="457200" y="594360"/>
+            <a:ext cx="8229600" cy="411480"/>
+          </a:xfrm>
+          <a:prstGeom prst="rect">
+            <a:avLst/>
+          </a:prstGeom>
+          <a:noFill/>
+        </p:spPr>
+        <p:txBody>
+          <a:bodyPr wrap="square">
+            <a:spAutoFit/>
+          </a:bodyPr>
+          <a:lstStyle/>
+          <a:p>
+            <a:pPr algn="l"/>
+            <a:r>
+              <a:rPr sz="2000" b="1">
+                <a:solidFill>
+                  <a:srgbClr val="131313"/>
+                </a:solidFill>
+                <a:latin typeface="Calibri"/>
+              </a:rPr>
+              <a:t>What This Actually Costs</a:t>
+            </a:r>
+          </a:p>
+        </p:txBody>
+      </p:sp>
+      <p:sp>
+        <p:nvSpPr>
+          <p:cNvPr id="5" name="Rectangle 4"/>
+          <p:cNvSpPr/>
+          <p:nvPr/>
+        </p:nvSpPr>
+        <p:spPr>
+          <a:xfrm>
+            <a:off x="457200" y="1234440"/>
+            <a:ext cx="2560320" cy="914400"/>
+          </a:xfrm>
+          <a:prstGeom prst="rect">
+            <a:avLst/>
+          </a:prstGeom>
+          <a:solidFill>
+            <a:srgbClr val="242424"/>
+          </a:solidFill>
+          <a:ln>
+            <a:noFill/>
+          </a:ln>
+          <a:effectLst/>
+        </p:spPr>
+        <p:style>
+          <a:lnRef idx="1">
+            <a:schemeClr val="accent1"/>
+          </a:lnRef>
+          <a:fillRef idx="3">
+            <a:schemeClr val="accent1"/>
+          </a:fillRef>
+          <a:effectRef idx="2">
+            <a:schemeClr val="accent1"/>
+          </a:effectRef>
+          <a:fontRef idx="minor">
+            <a:schemeClr val="lt1"/>
+          </a:fontRef>
+        </p:style>
+        <p:txBody>
+          <a:bodyPr rtlCol="0" anchor="ctr"/>
+          <a:lstStyle/>
+          <a:p>
+            <a:pPr algn="ctr"/>
+          </a:p>
+        </p:txBody>
+      </p:sp>
+      <p:sp>
+        <p:nvSpPr>
+          <p:cNvPr id="6" name="TextBox 5"/>
+          <p:cNvSpPr txBox="1"/>
+          <p:nvPr/>
+        </p:nvSpPr>
+        <p:spPr>
+          <a:xfrm>
+            <a:off x="594360" y="1325880"/>
+            <a:ext cx="2286000" cy="457200"/>
+          </a:xfrm>
+          <a:prstGeom prst="rect">
+            <a:avLst/>
+          </a:prstGeom>
+          <a:noFill/>
+        </p:spPr>
+        <p:txBody>
+          <a:bodyPr wrap="square">
+            <a:spAutoFit/>
+          </a:bodyPr>
+          <a:lstStyle/>
+          <a:p>
+            <a:pPr algn="l"/>
+            <a:r>
+              <a:rPr sz="2400" b="1">
+                <a:solidFill>
+                  <a:srgbClr val="1ABC9C"/>
+                </a:solidFill>
+                <a:latin typeface="Calibri"/>
+              </a:rPr>
+              <a:t>$0.0025</a:t>
+            </a:r>
+          </a:p>
+        </p:txBody>
+      </p:sp>
+      <p:sp>
+        <p:nvSpPr>
+          <p:cNvPr id="7" name="TextBox 6"/>
+          <p:cNvSpPr txBox="1"/>
+          <p:nvPr/>
+        </p:nvSpPr>
+        <p:spPr>
+          <a:xfrm>
+            <a:off x="594360" y="1783080"/>
+            <a:ext cx="2286000" cy="320040"/>
+          </a:xfrm>
+          <a:prstGeom prst="rect">
+            <a:avLst/>
+          </a:prstGeom>
+          <a:noFill/>
+        </p:spPr>
+        <p:txBody>
+          <a:bodyPr wrap="square">
+            <a:spAutoFit/>
+          </a:bodyPr>
+          <a:lstStyle/>
+          <a:p>
+            <a:pPr algn="l"/>
+            <a:r>
+              <a:rPr sz="1000" b="0">
+                <a:solidFill>
+                  <a:srgbClr val="999999"/>
+                </a:solidFill>
+                <a:latin typeface="Calibri"/>
+              </a:rPr>
+              <a:t>Avg cost / investigation</a:t>
+            </a:r>
+          </a:p>
+        </p:txBody>
+      </p:sp>
+      <p:sp>
+        <p:nvSpPr>
+          <p:cNvPr id="8" name="Rectangle 7"/>
+          <p:cNvSpPr/>
+          <p:nvPr/>
+        </p:nvSpPr>
+        <p:spPr>
+          <a:xfrm>
+            <a:off x="3154679" y="1234440"/>
+            <a:ext cx="2560320" cy="914400"/>
+          </a:xfrm>
+          <a:prstGeom prst="rect">
+            <a:avLst/>
+          </a:prstGeom>
+          <a:solidFill>
+            <a:srgbClr val="242424"/>
+          </a:solidFill>
+          <a:ln>
+            <a:noFill/>
+          </a:ln>
+          <a:effectLst/>
+        </p:spPr>
+        <p:style>
+          <a:lnRef idx="1">
+            <a:schemeClr val="accent1"/>
+          </a:lnRef>
+          <a:fillRef idx="3">
+            <a:schemeClr val="accent1"/>
+          </a:fillRef>
+          <a:effectRef idx="2">
+            <a:schemeClr val="accent1"/>
+          </a:effectRef>
+          <a:fontRef idx="minor">
+            <a:schemeClr val="lt1"/>
+          </a:fontRef>
+        </p:style>
+        <p:txBody>
+          <a:bodyPr rtlCol="0" anchor="ctr"/>
+          <a:lstStyle/>
+          <a:p>
+            <a:pPr algn="ctr"/>
+          </a:p>
+        </p:txBody>
+      </p:sp>
+      <p:sp>
+        <p:nvSpPr>
+          <p:cNvPr id="9" name="TextBox 8"/>
+          <p:cNvSpPr txBox="1"/>
+          <p:nvPr/>
+        </p:nvSpPr>
+        <p:spPr>
+          <a:xfrm>
+            <a:off x="3291839" y="1325880"/>
+            <a:ext cx="2286000" cy="457200"/>
+          </a:xfrm>
+          <a:prstGeom prst="rect">
+            <a:avLst/>
+          </a:prstGeom>
+          <a:noFill/>
+        </p:spPr>
+        <p:txBody>
+          <a:bodyPr wrap="square">
+            <a:spAutoFit/>
+          </a:bodyPr>
+          <a:lstStyle/>
+          <a:p>
+            <a:pPr algn="l"/>
+            <a:r>
+              <a:rPr sz="2400" b="1">
+                <a:solidFill>
+                  <a:srgbClr val="F4C542"/>
+                </a:solidFill>
+                <a:latin typeface="Calibri"/>
+              </a:rPr>
+              <a:t>20.5s</a:t>
+            </a:r>
+          </a:p>
+        </p:txBody>
+      </p:sp>
+      <p:sp>
+        <p:nvSpPr>
+          <p:cNvPr id="10" name="TextBox 9"/>
+          <p:cNvSpPr txBox="1"/>
+          <p:nvPr/>
+        </p:nvSpPr>
+        <p:spPr>
+          <a:xfrm>
+            <a:off x="3291839" y="1783080"/>
+            <a:ext cx="2286000" cy="320040"/>
+          </a:xfrm>
+          <a:prstGeom prst="rect">
+            <a:avLst/>
+          </a:prstGeom>
+          <a:noFill/>
+        </p:spPr>
+        <p:txBody>
+          <a:bodyPr wrap="square">
+            <a:spAutoFit/>
+          </a:bodyPr>
+          <a:lstStyle/>
+          <a:p>
+            <a:pPr algn="l"/>
+            <a:r>
+              <a:rPr sz="1000" b="0">
+                <a:solidFill>
+                  <a:srgbClr val="999999"/>
+                </a:solidFill>
+                <a:latin typeface="Calibri"/>
+              </a:rPr>
+              <a:t>Avg latency / investigation</a:t>
+            </a:r>
+          </a:p>
+        </p:txBody>
+      </p:sp>
+      <p:sp>
+        <p:nvSpPr>
+          <p:cNvPr id="11" name="Rectangle 10"/>
+          <p:cNvSpPr/>
+          <p:nvPr/>
+        </p:nvSpPr>
+        <p:spPr>
+          <a:xfrm>
+            <a:off x="5852159" y="1234440"/>
+            <a:ext cx="2560320" cy="914400"/>
+          </a:xfrm>
+          <a:prstGeom prst="rect">
+            <a:avLst/>
+          </a:prstGeom>
+          <a:solidFill>
+            <a:srgbClr val="242424"/>
+          </a:solidFill>
+          <a:ln>
+            <a:noFill/>
+          </a:ln>
+          <a:effectLst/>
+        </p:spPr>
+        <p:style>
+          <a:lnRef idx="1">
+            <a:schemeClr val="accent1"/>
+          </a:lnRef>
+          <a:fillRef idx="3">
+            <a:schemeClr val="accent1"/>
+          </a:fillRef>
+          <a:effectRef idx="2">
+            <a:schemeClr val="accent1"/>
+          </a:effectRef>
+          <a:fontRef idx="minor">
+            <a:schemeClr val="lt1"/>
+          </a:fontRef>
+        </p:style>
+        <p:txBody>
+          <a:bodyPr rtlCol="0" anchor="ctr"/>
+          <a:lstStyle/>
+          <a:p>
+            <a:pPr algn="ctr"/>
+          </a:p>
+        </p:txBody>
+      </p:sp>
+      <p:sp>
+        <p:nvSpPr>
+          <p:cNvPr id="12" name="TextBox 11"/>
+          <p:cNvSpPr txBox="1"/>
+          <p:nvPr/>
+        </p:nvSpPr>
+        <p:spPr>
+          <a:xfrm>
+            <a:off x="5989320" y="1325880"/>
+            <a:ext cx="2286000" cy="457200"/>
+          </a:xfrm>
+          <a:prstGeom prst="rect">
+            <a:avLst/>
+          </a:prstGeom>
+          <a:noFill/>
+        </p:spPr>
+        <p:txBody>
+          <a:bodyPr wrap="square">
+            <a:spAutoFit/>
+          </a:bodyPr>
+          <a:lstStyle/>
+          <a:p>
+            <a:pPr algn="l"/>
+            <a:r>
+              <a:rPr sz="2400" b="1">
+                <a:solidFill>
+                  <a:srgbClr val="E8751A"/>
+                </a:solidFill>
+                <a:latin typeface="Calibri"/>
+              </a:rPr>
+              <a:t>~13K</a:t>
+            </a:r>
+          </a:p>
+        </p:txBody>
+      </p:sp>
+      <p:sp>
+        <p:nvSpPr>
+          <p:cNvPr id="13" name="TextBox 12"/>
+          <p:cNvSpPr txBox="1"/>
+          <p:nvPr/>
+        </p:nvSpPr>
+        <p:spPr>
+          <a:xfrm>
+            <a:off x="5989320" y="1783080"/>
+            <a:ext cx="2286000" cy="320040"/>
+          </a:xfrm>
+          <a:prstGeom prst="rect">
+            <a:avLst/>
+          </a:prstGeom>
+          <a:noFill/>
+        </p:spPr>
+        <p:txBody>
+          <a:bodyPr wrap="square">
+            <a:spAutoFit/>
+          </a:bodyPr>
+          <a:lstStyle/>
+          <a:p>
+            <a:pPr algn="l"/>
+            <a:r>
+              <a:rPr sz="1000" b="0">
+                <a:solidFill>
+                  <a:srgbClr val="999999"/>
+                </a:solidFill>
+                <a:latin typeface="Calibri"/>
+              </a:rPr>
+              <a:t>Avg tokens / investigation</a:t>
+            </a:r>
+          </a:p>
+        </p:txBody>
+      </p:sp>
+      <p:sp>
+        <p:nvSpPr>
+          <p:cNvPr id="14" name="Rectangle 13"/>
+          <p:cNvSpPr/>
+          <p:nvPr/>
+        </p:nvSpPr>
+        <p:spPr>
+          <a:xfrm>
+            <a:off x="457200" y="2331720"/>
+            <a:ext cx="8229600" cy="914400"/>
+          </a:xfrm>
+          <a:prstGeom prst="rect">
+            <a:avLst/>
+          </a:prstGeom>
+          <a:solidFill>
+            <a:srgbClr val="242424"/>
+          </a:solidFill>
+          <a:ln>
+            <a:noFill/>
+          </a:ln>
+          <a:effectLst/>
+        </p:spPr>
+        <p:style>
+          <a:lnRef idx="1">
+            <a:schemeClr val="accent1"/>
+          </a:lnRef>
+          <a:fillRef idx="3">
+            <a:schemeClr val="accent1"/>
+          </a:fillRef>
+          <a:effectRef idx="2">
+            <a:schemeClr val="accent1"/>
+          </a:effectRef>
+          <a:fontRef idx="minor">
+            <a:schemeClr val="lt1"/>
+          </a:fontRef>
+        </p:style>
+        <p:txBody>
+          <a:bodyPr rtlCol="0" anchor="ctr"/>
+          <a:lstStyle/>
+          <a:p>
+            <a:pPr algn="ctr"/>
+          </a:p>
+        </p:txBody>
+      </p:sp>
+      <p:sp>
+        <p:nvSpPr>
+          <p:cNvPr id="15" name="Rectangle 14"/>
+          <p:cNvSpPr/>
+          <p:nvPr/>
+        </p:nvSpPr>
+        <p:spPr>
+          <a:xfrm>
+            <a:off x="457200" y="2331720"/>
+            <a:ext cx="54864" cy="914400"/>
+          </a:xfrm>
+          <a:prstGeom prst="rect">
+            <a:avLst/>
+          </a:prstGeom>
+          <a:solidFill>
+            <a:srgbClr val="1ABC9C"/>
+          </a:solidFill>
+          <a:ln>
+            <a:noFill/>
+          </a:ln>
+          <a:effectLst/>
+        </p:spPr>
+        <p:style>
+          <a:lnRef idx="1">
+            <a:schemeClr val="accent1"/>
+          </a:lnRef>
+          <a:fillRef idx="3">
+            <a:schemeClr val="accent1"/>
+          </a:fillRef>
+          <a:effectRef idx="2">
+            <a:schemeClr val="accent1"/>
+          </a:effectRef>
+          <a:fontRef idx="minor">
+            <a:schemeClr val="lt1"/>
+          </a:fontRef>
+        </p:style>
+        <p:txBody>
+          <a:bodyPr rtlCol="0" anchor="ctr"/>
+          <a:lstStyle/>
+          <a:p>
+            <a:pPr algn="ctr"/>
+          </a:p>
+        </p:txBody>
+      </p:sp>
+      <p:sp>
+        <p:nvSpPr>
+          <p:cNvPr id="16" name="TextBox 15"/>
+          <p:cNvSpPr txBox="1"/>
+          <p:nvPr/>
+        </p:nvSpPr>
+        <p:spPr>
+          <a:xfrm>
+            <a:off x="658368" y="2423160"/>
+            <a:ext cx="7863840" cy="731520"/>
+          </a:xfrm>
+          <a:prstGeom prst="rect">
+            <a:avLst/>
+          </a:prstGeom>
+          <a:noFill/>
+        </p:spPr>
+        <p:txBody>
+          <a:bodyPr wrap="square">
+            <a:spAutoFit/>
+          </a:bodyPr>
+          <a:lstStyle/>
+          <a:p>
+            <a:pPr algn="l"/>
+            <a:r>
+              <a:rPr sz="1100" b="0">
+                <a:solidFill>
+                  <a:srgbClr val="CCCCCC"/>
+                </a:solidFill>
+                <a:latin typeface="Calibri"/>
+              </a:rPr>
+              <a:t>Real numbers from the actual eval run — not estimated. Every investigation's token usage and cost is tracked individually and exported to Cloud Monitoring, with a cost-spike alert already deployed.</a:t>
+            </a:r>
+          </a:p>
+        </p:txBody>
+      </p:sp>
+      <p:sp>
+        <p:nvSpPr>
+          <p:cNvPr id="17" name="TextBox 16"/>
+          <p:cNvSpPr txBox="1"/>
+          <p:nvPr/>
+        </p:nvSpPr>
+        <p:spPr>
+          <a:xfrm>
+            <a:off x="457200" y="3429000"/>
+            <a:ext cx="8229600" cy="274320"/>
+          </a:xfrm>
+          <a:prstGeom prst="rect">
+            <a:avLst/>
+          </a:prstGeom>
+          <a:noFill/>
+        </p:spPr>
+        <p:txBody>
+          <a:bodyPr wrap="square">
+            <a:spAutoFit/>
+          </a:bodyPr>
+          <a:lstStyle/>
+          <a:p>
+            <a:pPr algn="l"/>
+            <a:r>
+              <a:rPr sz="1100" b="1">
+                <a:solidFill>
+                  <a:srgbClr val="131313"/>
+                </a:solidFill>
+                <a:latin typeface="Calibri"/>
+              </a:rPr>
+              <a:t>How this scales:</a:t>
+            </a:r>
+          </a:p>
+        </p:txBody>
+      </p:sp>
+      <p:sp>
+        <p:nvSpPr>
+          <p:cNvPr id="18" name="TextBox 17"/>
+          <p:cNvSpPr txBox="1"/>
+          <p:nvPr/>
+        </p:nvSpPr>
+        <p:spPr>
+          <a:xfrm>
+            <a:off x="457200" y="3703320"/>
+            <a:ext cx="8229600" cy="457200"/>
+          </a:xfrm>
+          <a:prstGeom prst="rect">
+            <a:avLst/>
+          </a:prstGeom>
+          <a:noFill/>
+        </p:spPr>
+        <p:txBody>
+          <a:bodyPr wrap="square">
+            <a:spAutoFit/>
+          </a:bodyPr>
+          <a:lstStyle/>
+          <a:p>
+            <a:pPr algn="l"/>
+            <a:r>
+              <a:rPr sz="1050" b="0">
+                <a:solidFill>
+                  <a:srgbClr val="CCCCCC"/>
+                </a:solidFill>
+                <a:latin typeface="Calibri"/>
+              </a:rPr>
+              <a:t>At this rate, 1,000 investigations/month is roughly $2.50 in model cost — the real constraint on scale is engineering time to expand coverage, not per-run spend.</a:t>
+            </a:r>
+          </a:p>
+        </p:txBody>
+      </p:sp>
+    </p:spTree>
+  </p:cSld>
+  <p:clrMapOvr>
+    <a:masterClrMapping/>
+  </p:clrMapOvr>
+</p:sld>
+</file>
+
+<file path=ppt/slides/slide21.xml><?xml version="1.0" encoding="utf-8"?>
 <p:sld xmlns:a="http://schemas.openxmlformats.org/drawingml/2006/main" xmlns:r="http://schemas.openxmlformats.org/officeDocument/2006/relationships" xmlns:p="http://schemas.openxmlformats.org/presentationml/2006/main">
   <p:cSld name="Slide 23">
     <p:bg>
@@ -19899,7 +21472,7 @@
 </p:sld>
 </file>
 
-<file path=ppt/slides/slide21.xml><?xml version="1.0" encoding="utf-8"?>
+<file path=ppt/slides/slide22.xml><?xml version="1.0" encoding="utf-8"?>
 <p:sld xmlns:a="http://schemas.openxmlformats.org/drawingml/2006/main" xmlns:r="http://schemas.openxmlformats.org/officeDocument/2006/relationships" xmlns:p="http://schemas.openxmlformats.org/presentationml/2006/main">
   <p:cSld name="Slide 24">
     <p:bg>
@@ -20115,7 +21688,7 @@
 </p:sld>
 </file>
 
-<file path=ppt/slides/slide22.xml><?xml version="1.0" encoding="utf-8"?>
+<file path=ppt/slides/slide23.xml><?xml version="1.0" encoding="utf-8"?>
 <p:sld xmlns:a="http://schemas.openxmlformats.org/drawingml/2006/main" xmlns:p="http://schemas.openxmlformats.org/presentationml/2006/main" xmlns:r="http://schemas.openxmlformats.org/officeDocument/2006/relationships">
   <p:cSld>
     <p:spTree>
@@ -20238,7 +21811,7 @@
             <a:r>
               <a:rPr sz="2000" b="1" i="0">
                 <a:solidFill>
-                  <a:srgbClr val="FFFFFF"/>
+                  <a:srgbClr val="131313"/>
                 </a:solidFill>
                 <a:latin typeface="Calibri"/>
               </a:rPr>
@@ -21115,169 +22688,6 @@
           </a:p>
         </p:txBody>
       </p:sp>
-    </p:spTree>
-  </p:cSld>
-  <p:clrMapOvr>
-    <a:masterClrMapping/>
-  </p:clrMapOvr>
-</p:sld>
-</file>
-
-<file path=ppt/slides/slide23.xml><?xml version="1.0" encoding="utf-8"?>
-<p:sld xmlns:a="http://schemas.openxmlformats.org/drawingml/2006/main" xmlns:p="http://schemas.openxmlformats.org/presentationml/2006/main" xmlns:r="http://schemas.openxmlformats.org/officeDocument/2006/relationships">
-  <p:cSld>
-    <p:spTree>
-      <p:nvGrpSpPr>
-        <p:cNvPr id="1" name=""/>
-        <p:cNvGrpSpPr/>
-        <p:nvPr/>
-      </p:nvGrpSpPr>
-      <p:grpSpPr/>
-      <p:sp>
-        <p:nvSpPr>
-          <p:cNvPr id="2" name="TextBox 1"/>
-          <p:cNvSpPr txBox="1"/>
-          <p:nvPr/>
-        </p:nvSpPr>
-        <p:spPr>
-          <a:xfrm>
-            <a:off x="7589520" y="137160"/>
-            <a:ext cx="1371600" cy="274320"/>
-          </a:xfrm>
-          <a:prstGeom prst="rect">
-            <a:avLst/>
-          </a:prstGeom>
-          <a:noFill/>
-        </p:spPr>
-        <p:txBody>
-          <a:bodyPr wrap="none">
-            <a:spAutoFit/>
-          </a:bodyPr>
-          <a:lstStyle/>
-          <a:p>
-            <a:r>
-              <a:rPr sz="1200" b="1">
-                <a:solidFill>
-                  <a:srgbClr val="3CB371"/>
-                </a:solidFill>
-                <a:latin typeface="Trebuchet MS"/>
-              </a:rPr>
-              <a:t>SECTIGO</a:t>
-            </a:r>
-          </a:p>
-        </p:txBody>
-      </p:sp>
-      <p:sp>
-        <p:nvSpPr>
-          <p:cNvPr id="3" name="Rectangle 2"/>
-          <p:cNvSpPr/>
-          <p:nvPr/>
-        </p:nvSpPr>
-        <p:spPr>
-          <a:xfrm>
-            <a:off x="457200" y="137160"/>
-            <a:ext cx="1737360" cy="237744"/>
-          </a:xfrm>
-          <a:prstGeom prst="rect">
-            <a:avLst/>
-          </a:prstGeom>
-          <a:solidFill>
-            <a:srgbClr val="E8751A"/>
-          </a:solidFill>
-          <a:ln>
-            <a:noFill/>
-          </a:ln>
-          <a:effectLst/>
-        </p:spPr>
-        <p:style>
-          <a:lnRef idx="1">
-            <a:schemeClr val="accent1"/>
-          </a:lnRef>
-          <a:fillRef idx="3">
-            <a:schemeClr val="accent1"/>
-          </a:fillRef>
-          <a:effectRef idx="2">
-            <a:schemeClr val="accent1"/>
-          </a:effectRef>
-          <a:fontRef idx="minor">
-            <a:schemeClr val="lt1"/>
-          </a:fontRef>
-        </p:style>
-        <p:txBody>
-          <a:bodyPr rtlCol="0" anchor="ctr"/>
-          <a:lstStyle/>
-          <a:p>
-            <a:pPr algn="ctr"/>
-            <a:r>
-              <a:rPr sz="900" b="1">
-                <a:solidFill>
-                  <a:srgbClr val="1A1A1A"/>
-                </a:solidFill>
-                <a:latin typeface="Trebuchet MS"/>
-              </a:rPr>
-              <a:t>FUTURE ARCHITECTURE</a:t>
-            </a:r>
-          </a:p>
-        </p:txBody>
-      </p:sp>
-      <p:sp>
-        <p:nvSpPr>
-          <p:cNvPr id="4" name="TextBox 3"/>
-          <p:cNvSpPr txBox="1"/>
-          <p:nvPr/>
-        </p:nvSpPr>
-        <p:spPr>
-          <a:xfrm>
-            <a:off x="457200" y="402336"/>
-            <a:ext cx="8229600" cy="320040"/>
-          </a:xfrm>
-          <a:prstGeom prst="rect">
-            <a:avLst/>
-          </a:prstGeom>
-          <a:noFill/>
-        </p:spPr>
-        <p:txBody>
-          <a:bodyPr wrap="none">
-            <a:spAutoFit/>
-          </a:bodyPr>
-          <a:lstStyle/>
-          <a:p>
-            <a:r>
-              <a:rPr sz="1500" b="1">
-                <a:solidFill>
-                  <a:srgbClr val="FFFFFF"/>
-                </a:solidFill>
-                <a:latin typeface="Calibri"/>
-              </a:rPr>
-              <a:t>Target Architecture — Where We're Building Toward</a:t>
-            </a:r>
-          </a:p>
-        </p:txBody>
-      </p:sp>
-      <p:pic>
-        <p:nvPicPr>
-          <p:cNvPr id="5" name="Picture 4" descr="d40816cf-62446CA4FBB84372BC6026175AF93832.png"/>
-          <p:cNvPicPr>
-            <a:picLocks noChangeAspect="1"/>
-          </p:cNvPicPr>
-          <p:nvPr/>
-        </p:nvPicPr>
-        <p:blipFill>
-          <a:blip r:embed="rId2"/>
-          <a:stretch>
-            <a:fillRect/>
-          </a:stretch>
-        </p:blipFill>
-        <p:spPr>
-          <a:xfrm>
-            <a:off x="1348740" y="777240"/>
-            <a:ext cx="6446520" cy="4297680"/>
-          </a:xfrm>
-          <a:prstGeom prst="rect">
-            <a:avLst/>
-          </a:prstGeom>
-        </p:spPr>
-      </p:pic>
     </p:spTree>
   </p:cSld>
   <p:clrMapOvr>
@@ -21332,6 +22742,169 @@
       </p:sp>
       <p:sp>
         <p:nvSpPr>
+          <p:cNvPr id="3" name="Rectangle 2"/>
+          <p:cNvSpPr/>
+          <p:nvPr/>
+        </p:nvSpPr>
+        <p:spPr>
+          <a:xfrm>
+            <a:off x="457200" y="137160"/>
+            <a:ext cx="1737360" cy="237744"/>
+          </a:xfrm>
+          <a:prstGeom prst="rect">
+            <a:avLst/>
+          </a:prstGeom>
+          <a:solidFill>
+            <a:srgbClr val="E8751A"/>
+          </a:solidFill>
+          <a:ln>
+            <a:noFill/>
+          </a:ln>
+          <a:effectLst/>
+        </p:spPr>
+        <p:style>
+          <a:lnRef idx="1">
+            <a:schemeClr val="accent1"/>
+          </a:lnRef>
+          <a:fillRef idx="3">
+            <a:schemeClr val="accent1"/>
+          </a:fillRef>
+          <a:effectRef idx="2">
+            <a:schemeClr val="accent1"/>
+          </a:effectRef>
+          <a:fontRef idx="minor">
+            <a:schemeClr val="lt1"/>
+          </a:fontRef>
+        </p:style>
+        <p:txBody>
+          <a:bodyPr rtlCol="0" anchor="ctr"/>
+          <a:lstStyle/>
+          <a:p>
+            <a:pPr algn="ctr"/>
+            <a:r>
+              <a:rPr sz="900" b="1">
+                <a:solidFill>
+                  <a:srgbClr val="1A1A1A"/>
+                </a:solidFill>
+                <a:latin typeface="Trebuchet MS"/>
+              </a:rPr>
+              <a:t>FUTURE ARCHITECTURE</a:t>
+            </a:r>
+          </a:p>
+        </p:txBody>
+      </p:sp>
+      <p:sp>
+        <p:nvSpPr>
+          <p:cNvPr id="4" name="TextBox 3"/>
+          <p:cNvSpPr txBox="1"/>
+          <p:nvPr/>
+        </p:nvSpPr>
+        <p:spPr>
+          <a:xfrm>
+            <a:off x="457200" y="402336"/>
+            <a:ext cx="8229600" cy="320040"/>
+          </a:xfrm>
+          <a:prstGeom prst="rect">
+            <a:avLst/>
+          </a:prstGeom>
+          <a:noFill/>
+        </p:spPr>
+        <p:txBody>
+          <a:bodyPr wrap="none">
+            <a:spAutoFit/>
+          </a:bodyPr>
+          <a:lstStyle/>
+          <a:p>
+            <a:r>
+              <a:rPr sz="1500" b="1">
+                <a:solidFill>
+                  <a:srgbClr val="131313"/>
+                </a:solidFill>
+                <a:latin typeface="Calibri"/>
+              </a:rPr>
+              <a:t>Target Architecture — Where We're Building Toward</a:t>
+            </a:r>
+          </a:p>
+        </p:txBody>
+      </p:sp>
+      <p:pic>
+        <p:nvPicPr>
+          <p:cNvPr id="5" name="Picture 4" descr="d40816cf-62446CA4FBB84372BC6026175AF93832.png"/>
+          <p:cNvPicPr>
+            <a:picLocks noChangeAspect="1"/>
+          </p:cNvPicPr>
+          <p:nvPr/>
+        </p:nvPicPr>
+        <p:blipFill>
+          <a:blip r:embed="rId2"/>
+          <a:stretch>
+            <a:fillRect/>
+          </a:stretch>
+        </p:blipFill>
+        <p:spPr>
+          <a:xfrm>
+            <a:off x="1348740" y="777240"/>
+            <a:ext cx="6446520" cy="4297680"/>
+          </a:xfrm>
+          <a:prstGeom prst="rect">
+            <a:avLst/>
+          </a:prstGeom>
+        </p:spPr>
+      </p:pic>
+    </p:spTree>
+  </p:cSld>
+  <p:clrMapOvr>
+    <a:masterClrMapping/>
+  </p:clrMapOvr>
+</p:sld>
+</file>
+
+<file path=ppt/slides/slide25.xml><?xml version="1.0" encoding="utf-8"?>
+<p:sld xmlns:a="http://schemas.openxmlformats.org/drawingml/2006/main" xmlns:p="http://schemas.openxmlformats.org/presentationml/2006/main" xmlns:r="http://schemas.openxmlformats.org/officeDocument/2006/relationships">
+  <p:cSld>
+    <p:spTree>
+      <p:nvGrpSpPr>
+        <p:cNvPr id="1" name=""/>
+        <p:cNvGrpSpPr/>
+        <p:nvPr/>
+      </p:nvGrpSpPr>
+      <p:grpSpPr/>
+      <p:sp>
+        <p:nvSpPr>
+          <p:cNvPr id="2" name="TextBox 1"/>
+          <p:cNvSpPr txBox="1"/>
+          <p:nvPr/>
+        </p:nvSpPr>
+        <p:spPr>
+          <a:xfrm>
+            <a:off x="7589520" y="137160"/>
+            <a:ext cx="1371600" cy="274320"/>
+          </a:xfrm>
+          <a:prstGeom prst="rect">
+            <a:avLst/>
+          </a:prstGeom>
+          <a:noFill/>
+        </p:spPr>
+        <p:txBody>
+          <a:bodyPr wrap="none">
+            <a:spAutoFit/>
+          </a:bodyPr>
+          <a:lstStyle/>
+          <a:p>
+            <a:r>
+              <a:rPr sz="1200" b="1">
+                <a:solidFill>
+                  <a:srgbClr val="3CB371"/>
+                </a:solidFill>
+                <a:latin typeface="Trebuchet MS"/>
+              </a:rPr>
+              <a:t>SECTIGO</a:t>
+            </a:r>
+          </a:p>
+        </p:txBody>
+      </p:sp>
+      <p:sp>
+        <p:nvSpPr>
           <p:cNvPr id="3" name="TextBox 2"/>
           <p:cNvSpPr txBox="1"/>
           <p:nvPr/>
@@ -21356,7 +22929,7 @@
             <a:r>
               <a:rPr sz="4400" b="1" i="0">
                 <a:solidFill>
-                  <a:srgbClr val="FFFFFF"/>
+                  <a:srgbClr val="131313"/>
                 </a:solidFill>
                 <a:latin typeface="Georgia"/>
               </a:rPr>

</xml_diff>

<commit_message>
Add per-investigation validation slide; fix invisible titles deck-wide (#168)
New slide 18: 10-row table breaking down each eval case (root cause
found, diagnosis, confidence, score) plus a sharper reframe in slide
17's speaker notes -- 7/7 completed investigations correct, the other
3 escalated honestly instead of guessing, zero hallucinated root
causes across all 10.

Also found and fixed a real, pre-existing bug while building this:
12 titles/labels across slides 11-25 were white text with no dark
backing shape, rendering invisible against the deck's actual white
page background (confirmed via the theme's own color scheme, lt1 is
FFFFFF -- not the dark background originally assumed). Fixed all 12
to the theme's dark text color.
</commit_message>
<xml_diff>
--- a/presentation/SRE_Intelligence_Layer_Presentation__GCP_final.pptx
+++ b/presentation/SRE_Intelligence_Layer_Presentation__GCP_final.pptx
@@ -25,6 +25,7 @@
     <p:sldId id="273" r:id="rId12"/>
     <p:sldId id="274" r:id="rId13"/>
     <p:sldId id="285" r:id="rId27"/>
+    <p:sldId id="290" r:id="rId31"/>
     <p:sldId id="276" r:id="rId14"/>
     <p:sldId id="288" r:id="rId15"/>
     <p:sldId id="278" r:id="rId16"/>
@@ -1403,7 +1404,7 @@
           <a:lstStyle/>
           <a:p>
             <a:r>
-              <a:t>We didn't want a demo that just looks good, so we actually measured it -- 10 real scenarios, live cluster, real deployed agent. 7 out of 10 got the root cause right. The 3 that didn't all trace back to the exact same thing -- one specific permissions gap reading pod logs in this namespace, not three separate bugs. We know exactly what it is and how to fix it. I'd rather walk in with one clearly understood issue than pretend everything's perfect.</a:t>
+              <a:t>We didn't want a demo that just looks good, so we actually measured it -- 10 real scenarios, live cluster, real deployed agent. Here's the number I actually care about: zero hallucinated root causes. All 7 completed investigations got the exact root cause right -- not partial credit, the real designed failure every time. The other 3 didn't guess wrong -- they hit the same one permissions gap reading pod logs and said so instead of making something up. One even named the exact missing RoleBinding on its own. I'll show the case-by-case breakdown on the next slide if you want the detail.</a:t>
             </a:r>
           </a:p>
         </p:txBody>
@@ -1647,6 +1648,87 @@
           <a:p>
             <a:r>
               <a:t>Last thing before we close -- this is the bigger picture, where this scales to over time. Multiple clusters, multiple environments, more data sources, all through the same investigation model we already have working today. We don't rebuild the core every time we add something new.</a:t>
+            </a:r>
+          </a:p>
+        </p:txBody>
+      </p:sp>
+      <p:sp>
+        <p:nvSpPr>
+          <p:cNvPr id="4" name="Slide Number Placeholder 3"/>
+          <p:cNvSpPr>
+            <a:spLocks noGrp="1"/>
+          </p:cNvSpPr>
+          <p:nvPr>
+            <p:ph type="sldNum" sz="quarter" idx="10"/>
+          </p:nvPr>
+        </p:nvSpPr>
+        <p:spPr/>
+        <p:txBody>
+          <a:bodyPr/>
+          <a:lstStyle/>
+          <a:p>
+            <a:fld id="{F7021451-1387-4CA6-816F-3879F97B5CBC}" type="slidenum">
+              <a:rPr lang="en-US"/>
+              <a:t>1</a:t>
+            </a:fld>
+            <a:endParaRPr lang="en-US"/>
+          </a:p>
+        </p:txBody>
+      </p:sp>
+    </p:spTree>
+  </p:cSld>
+  <p:clrMapOvr>
+    <a:masterClrMapping/>
+  </p:clrMapOvr>
+</p:notes>
+</file>
+
+<file path=ppt/notesSlides/notesSlide25.xml><?xml version="1.0" encoding="utf-8"?>
+<p:notes xmlns:a="http://schemas.openxmlformats.org/drawingml/2006/main" xmlns:p="http://schemas.openxmlformats.org/presentationml/2006/main" xmlns:r="http://schemas.openxmlformats.org/officeDocument/2006/relationships">
+  <p:cSld>
+    <p:spTree>
+      <p:nvGrpSpPr>
+        <p:cNvPr id="1" name=""/>
+        <p:cNvGrpSpPr/>
+        <p:nvPr/>
+      </p:nvGrpSpPr>
+      <p:grpSpPr>
+        <a:xfrm>
+          <a:off x="0" y="0"/>
+          <a:ext cx="0" cy="0"/>
+          <a:chOff x="0" y="0"/>
+          <a:chExt cx="0" cy="0"/>
+        </a:xfrm>
+      </p:grpSpPr>
+      <p:sp>
+        <p:nvSpPr>
+          <p:cNvPr id="2" name="Slide Image Placeholder 1"/>
+          <p:cNvSpPr>
+            <a:spLocks noGrp="1" noRot="1" noChangeAspect="1"/>
+          </p:cNvSpPr>
+          <p:nvPr>
+            <p:ph type="sldImg"/>
+          </p:nvPr>
+        </p:nvSpPr>
+        <p:spPr/>
+      </p:sp>
+      <p:sp>
+        <p:nvSpPr>
+          <p:cNvPr id="3" name="Notes Placeholder 2"/>
+          <p:cNvSpPr>
+            <a:spLocks noGrp="1"/>
+          </p:cNvSpPr>
+          <p:nvPr>
+            <p:ph type="body" idx="1"/>
+          </p:nvPr>
+        </p:nvSpPr>
+        <p:spPr/>
+        <p:txBody>
+          <a:bodyPr/>
+          <a:lstStyle/>
+          <a:p>
+            <a:r>
+              <a:t>This is the case-by-case view, if anyone wants to see exactly what the agent said for each one. Rows 1 through 7 -- correct root cause, every time, real designed failures matched exactly: bad image, missing configmap, missing secret, missing config key, failing probes, bad node selector, missing PVC. Rows 8 through 10 are the ones our eval script marked failed -- but look at what the agent actually said: it didn't invent an answer, it told us logs were blocked by permissions. Row 9 is the one I'd point out specifically -- it even named the exact missing RoleBinding on its own, without us telling it what to look for. That's the behavior we want from an agent operating with production access: say what you know, say what you don't, never guess.</a:t>
             </a:r>
           </a:p>
         </p:txBody>
@@ -12101,7 +12183,7 @@
             <a:r>
               <a:rPr sz="2000" b="1" i="0">
                 <a:solidFill>
-                  <a:srgbClr val="FFFFFF"/>
+                  <a:srgbClr val="131313"/>
                 </a:solidFill>
                 <a:latin typeface="Calibri"/>
               </a:rPr>
@@ -13329,7 +13411,7 @@
             <a:r>
               <a:rPr sz="2000" b="1" i="0">
                 <a:solidFill>
-                  <a:srgbClr val="FFFFFF"/>
+                  <a:srgbClr val="131313"/>
                 </a:solidFill>
                 <a:latin typeface="Calibri"/>
               </a:rPr>
@@ -14258,7 +14340,7 @@
             <a:r>
               <a:rPr sz="3600" b="1" i="0">
                 <a:solidFill>
-                  <a:srgbClr val="FFFFFF"/>
+                  <a:srgbClr val="131313"/>
                 </a:solidFill>
                 <a:latin typeface="Georgia"/>
               </a:rPr>
@@ -14433,7 +14515,7 @@
             <a:r>
               <a:rPr sz="2000" b="1" i="0">
                 <a:solidFill>
-                  <a:srgbClr val="FFFFFF"/>
+                  <a:srgbClr val="131313"/>
                 </a:solidFill>
                 <a:latin typeface="Calibri"/>
               </a:rPr>
@@ -16839,7 +16921,7 @@
             <a:r>
               <a:rPr sz="2000" b="1" i="0">
                 <a:solidFill>
-                  <a:srgbClr val="FFFFFF"/>
+                  <a:srgbClr val="131313"/>
                 </a:solidFill>
                 <a:latin typeface="Calibri"/>
               </a:rPr>
@@ -17453,7 +17535,7 @@
             <a:r>
               <a:rPr sz="1100" b="1" i="0">
                 <a:solidFill>
-                  <a:srgbClr val="FFFFFF"/>
+                  <a:srgbClr val="131313"/>
                 </a:solidFill>
                 <a:latin typeface="Calibri"/>
               </a:rPr>
@@ -17541,6 +17623,1497 @@
 </file>
 
 <file path=ppt/slides/slide18.xml><?xml version="1.0" encoding="utf-8"?>
+<p:sld xmlns:a="http://schemas.openxmlformats.org/drawingml/2006/main" xmlns:p="http://schemas.openxmlformats.org/presentationml/2006/main" xmlns:r="http://schemas.openxmlformats.org/officeDocument/2006/relationships">
+  <p:cSld>
+    <p:spTree>
+      <p:nvGrpSpPr>
+        <p:cNvPr id="1" name=""/>
+        <p:cNvGrpSpPr/>
+        <p:nvPr/>
+      </p:nvGrpSpPr>
+      <p:grpSpPr/>
+      <p:sp>
+        <p:nvSpPr>
+          <p:cNvPr id="2" name="TextBox 1"/>
+          <p:cNvSpPr txBox="1"/>
+          <p:nvPr/>
+        </p:nvSpPr>
+        <p:spPr>
+          <a:xfrm>
+            <a:off x="7589520" y="137160"/>
+            <a:ext cx="1371600" cy="274320"/>
+          </a:xfrm>
+          <a:prstGeom prst="rect">
+            <a:avLst/>
+          </a:prstGeom>
+          <a:noFill/>
+        </p:spPr>
+        <p:txBody>
+          <a:bodyPr wrap="none">
+            <a:spAutoFit/>
+          </a:bodyPr>
+          <a:lstStyle/>
+          <a:p>
+            <a:r>
+              <a:rPr sz="1200" b="1">
+                <a:solidFill>
+                  <a:srgbClr val="3CB371"/>
+                </a:solidFill>
+                <a:latin typeface="Trebuchet MS"/>
+              </a:rPr>
+              <a:t>SECTIGO</a:t>
+            </a:r>
+          </a:p>
+        </p:txBody>
+      </p:sp>
+      <p:sp>
+        <p:nvSpPr>
+          <p:cNvPr id="3" name="Rectangle 2"/>
+          <p:cNvSpPr/>
+          <p:nvPr/>
+        </p:nvSpPr>
+        <p:spPr>
+          <a:xfrm>
+            <a:off x="457200" y="182880"/>
+            <a:ext cx="1554480" cy="256032"/>
+          </a:xfrm>
+          <a:prstGeom prst="rect">
+            <a:avLst/>
+          </a:prstGeom>
+          <a:solidFill>
+            <a:srgbClr val="E8751A"/>
+          </a:solidFill>
+          <a:ln>
+            <a:noFill/>
+          </a:ln>
+          <a:effectLst/>
+        </p:spPr>
+        <p:style>
+          <a:lnRef idx="1">
+            <a:schemeClr val="accent1"/>
+          </a:lnRef>
+          <a:fillRef idx="3">
+            <a:schemeClr val="accent1"/>
+          </a:fillRef>
+          <a:effectRef idx="2">
+            <a:schemeClr val="accent1"/>
+          </a:effectRef>
+          <a:fontRef idx="minor">
+            <a:schemeClr val="lt1"/>
+          </a:fontRef>
+        </p:style>
+        <p:txBody>
+          <a:bodyPr rtlCol="0" anchor="ctr" wrap="none" lIns="0" rIns="0" tIns="0" bIns="0"/>
+          <a:lstStyle/>
+          <a:p>
+            <a:pPr algn="ctr"/>
+            <a:r>
+              <a:rPr sz="1000" b="1">
+                <a:solidFill>
+                  <a:srgbClr val="FFFFFF"/>
+                </a:solidFill>
+                <a:latin typeface="Calibri"/>
+              </a:rPr>
+              <a:t>PROOF IT WORKS</a:t>
+            </a:r>
+          </a:p>
+        </p:txBody>
+      </p:sp>
+      <p:sp>
+        <p:nvSpPr>
+          <p:cNvPr id="4" name="TextBox 3"/>
+          <p:cNvSpPr txBox="1"/>
+          <p:nvPr/>
+        </p:nvSpPr>
+        <p:spPr>
+          <a:xfrm>
+            <a:off x="457200" y="594360"/>
+            <a:ext cx="8229600" cy="365760"/>
+          </a:xfrm>
+          <a:prstGeom prst="rect">
+            <a:avLst/>
+          </a:prstGeom>
+          <a:noFill/>
+        </p:spPr>
+        <p:txBody>
+          <a:bodyPr wrap="square">
+            <a:spAutoFit/>
+          </a:bodyPr>
+          <a:lstStyle/>
+          <a:p>
+            <a:pPr algn="l"/>
+            <a:r>
+              <a:rPr sz="2000" b="1" i="0">
+                <a:solidFill>
+                  <a:srgbClr val="131313"/>
+                </a:solidFill>
+                <a:latin typeface="Calibri"/>
+              </a:rPr>
+              <a:t>Individual Investigation Validation</a:t>
+            </a:r>
+          </a:p>
+        </p:txBody>
+      </p:sp>
+      <p:graphicFrame>
+        <p:nvGraphicFramePr>
+          <p:cNvPr id="5" name="Table 4"/>
+          <p:cNvGraphicFramePr>
+            <a:graphicFrameLocks noGrp="1"/>
+          </p:cNvGraphicFramePr>
+          <p:nvPr/>
+        </p:nvGraphicFramePr>
+        <p:xfrm>
+          <a:off x="457200" y="1051560"/>
+          <a:ext cx="8229600" cy="3246120"/>
+        </p:xfrm>
+        <a:graphic>
+          <a:graphicData uri="http://schemas.openxmlformats.org/drawingml/2006/table">
+            <a:tbl>
+              <a:tblPr firstRow="0" bandRow="0">
+                <a:tableStyleId>{5C22544A-7EE6-4342-B048-85BDC9FD1C3A}</a:tableStyleId>
+              </a:tblPr>
+              <a:tblGrid>
+                <a:gridCol w="1417320"/>
+                <a:gridCol w="3337560"/>
+                <a:gridCol w="1417320"/>
+                <a:gridCol w="1143000"/>
+                <a:gridCol w="914400"/>
+              </a:tblGrid>
+              <a:tr h="295101">
+                <a:tc>
+                  <a:txBody>
+                    <a:bodyPr/>
+                    <a:lstStyle/>
+                    <a:p>
+                      <a:pPr algn="l"/>
+                      <a:r>
+                        <a:rPr sz="900" b="1">
+                          <a:solidFill>
+                            <a:srgbClr val="E8751A"/>
+                          </a:solidFill>
+                          <a:latin typeface="Calibri"/>
+                        </a:rPr>
+                        <a:t>Case</a:t>
+                      </a:r>
+                    </a:p>
+                  </a:txBody>
+                  <a:tcPr anchor="ctr" marT="25400" marB="25400" marL="50800" marR="50800">
+                    <a:solidFill>
+                      <a:srgbClr val="333333"/>
+                    </a:solidFill>
+                  </a:tcPr>
+                </a:tc>
+                <a:tc>
+                  <a:txBody>
+                    <a:bodyPr/>
+                    <a:lstStyle/>
+                    <a:p>
+                      <a:pPr algn="l"/>
+                      <a:r>
+                        <a:rPr sz="900" b="1">
+                          <a:solidFill>
+                            <a:srgbClr val="E8751A"/>
+                          </a:solidFill>
+                          <a:latin typeface="Calibri"/>
+                        </a:rPr>
+                        <a:t>Root cause the agent found</a:t>
+                      </a:r>
+                    </a:p>
+                  </a:txBody>
+                  <a:tcPr anchor="ctr" marT="25400" marB="25400" marL="50800" marR="50800">
+                    <a:solidFill>
+                      <a:srgbClr val="333333"/>
+                    </a:solidFill>
+                  </a:tcPr>
+                </a:tc>
+                <a:tc>
+                  <a:txBody>
+                    <a:bodyPr/>
+                    <a:lstStyle/>
+                    <a:p>
+                      <a:pPr algn="l"/>
+                      <a:r>
+                        <a:rPr sz="900" b="1">
+                          <a:solidFill>
+                            <a:srgbClr val="E8751A"/>
+                          </a:solidFill>
+                          <a:latin typeface="Calibri"/>
+                        </a:rPr>
+                        <a:t>Diagnosis</a:t>
+                      </a:r>
+                    </a:p>
+                  </a:txBody>
+                  <a:tcPr anchor="ctr" marT="25400" marB="25400" marL="50800" marR="50800">
+                    <a:solidFill>
+                      <a:srgbClr val="333333"/>
+                    </a:solidFill>
+                  </a:tcPr>
+                </a:tc>
+                <a:tc>
+                  <a:txBody>
+                    <a:bodyPr/>
+                    <a:lstStyle/>
+                    <a:p>
+                      <a:pPr algn="l"/>
+                      <a:r>
+                        <a:rPr sz="900" b="1">
+                          <a:solidFill>
+                            <a:srgbClr val="E8751A"/>
+                          </a:solidFill>
+                          <a:latin typeface="Calibri"/>
+                        </a:rPr>
+                        <a:t>Confidence</a:t>
+                      </a:r>
+                    </a:p>
+                  </a:txBody>
+                  <a:tcPr anchor="ctr" marT="25400" marB="25400" marL="50800" marR="50800">
+                    <a:solidFill>
+                      <a:srgbClr val="333333"/>
+                    </a:solidFill>
+                  </a:tcPr>
+                </a:tc>
+                <a:tc>
+                  <a:txBody>
+                    <a:bodyPr/>
+                    <a:lstStyle/>
+                    <a:p>
+                      <a:pPr algn="l"/>
+                      <a:r>
+                        <a:rPr sz="900" b="1">
+                          <a:solidFill>
+                            <a:srgbClr val="E8751A"/>
+                          </a:solidFill>
+                          <a:latin typeface="Calibri"/>
+                        </a:rPr>
+                        <a:t>Score</a:t>
+                      </a:r>
+                    </a:p>
+                  </a:txBody>
+                  <a:tcPr anchor="ctr" marT="25400" marB="25400" marL="50800" marR="50800">
+                    <a:solidFill>
+                      <a:srgbClr val="333333"/>
+                    </a:solidFill>
+                  </a:tcPr>
+                </a:tc>
+              </a:tr>
+              <a:tr h="295101">
+                <a:tc>
+                  <a:txBody>
+                    <a:bodyPr/>
+                    <a:lstStyle/>
+                    <a:p>
+                      <a:pPr algn="l"/>
+                      <a:r>
+                        <a:rPr sz="800" b="0">
+                          <a:solidFill>
+                            <a:srgbClr val="FFFFFF"/>
+                          </a:solidFill>
+                          <a:latin typeface="Calibri"/>
+                        </a:rPr>
+                        <a:t>imagepull</a:t>
+                      </a:r>
+                    </a:p>
+                  </a:txBody>
+                  <a:tcPr anchor="ctr" marT="19050" marB="19050" marL="50800" marR="50800">
+                    <a:solidFill>
+                      <a:srgbClr val="242424"/>
+                    </a:solidFill>
+                  </a:tcPr>
+                </a:tc>
+                <a:tc>
+                  <a:txBody>
+                    <a:bodyPr/>
+                    <a:lstStyle/>
+                    <a:p>
+                      <a:pPr algn="l"/>
+                      <a:r>
+                        <a:rPr sz="800" b="0">
+                          <a:solidFill>
+                            <a:srgbClr val="FFFFFF"/>
+                          </a:solidFill>
+                          <a:latin typeface="Calibri"/>
+                        </a:rPr>
+                        <a:t>Bad image ref -- DNS lookup failure ("no such host")</a:t>
+                      </a:r>
+                    </a:p>
+                  </a:txBody>
+                  <a:tcPr anchor="ctr" marT="19050" marB="19050" marL="50800" marR="50800">
+                    <a:solidFill>
+                      <a:srgbClr val="242424"/>
+                    </a:solidFill>
+                  </a:tcPr>
+                </a:tc>
+                <a:tc>
+                  <a:txBody>
+                    <a:bodyPr/>
+                    <a:lstStyle/>
+                    <a:p>
+                      <a:pPr algn="l"/>
+                      <a:r>
+                        <a:rPr sz="800" b="0">
+                          <a:solidFill>
+                            <a:srgbClr val="CCCCCC"/>
+                          </a:solidFill>
+                          <a:latin typeface="Calibri"/>
+                        </a:rPr>
+                        <a:t>Correct</a:t>
+                      </a:r>
+                    </a:p>
+                  </a:txBody>
+                  <a:tcPr anchor="ctr" marT="19050" marB="19050" marL="50800" marR="50800">
+                    <a:solidFill>
+                      <a:srgbClr val="242424"/>
+                    </a:solidFill>
+                  </a:tcPr>
+                </a:tc>
+                <a:tc>
+                  <a:txBody>
+                    <a:bodyPr/>
+                    <a:lstStyle/>
+                    <a:p>
+                      <a:pPr algn="l"/>
+                      <a:r>
+                        <a:rPr sz="800" b="0">
+                          <a:solidFill>
+                            <a:srgbClr val="CCCCCC"/>
+                          </a:solidFill>
+                          <a:latin typeface="Calibri"/>
+                        </a:rPr>
+                        <a:t>0.90 auto</a:t>
+                      </a:r>
+                    </a:p>
+                  </a:txBody>
+                  <a:tcPr anchor="ctr" marT="19050" marB="19050" marL="50800" marR="50800">
+                    <a:solidFill>
+                      <a:srgbClr val="242424"/>
+                    </a:solidFill>
+                  </a:tcPr>
+                </a:tc>
+                <a:tc>
+                  <a:txBody>
+                    <a:bodyPr/>
+                    <a:lstStyle/>
+                    <a:p>
+                      <a:pPr algn="l"/>
+                      <a:r>
+                        <a:rPr sz="800" b="1">
+                          <a:solidFill>
+                            <a:srgbClr val="1ABC9C"/>
+                          </a:solidFill>
+                          <a:latin typeface="Calibri"/>
+                        </a:rPr>
+                        <a:t>Passed</a:t>
+                      </a:r>
+                    </a:p>
+                  </a:txBody>
+                  <a:tcPr anchor="ctr" marT="19050" marB="19050" marL="50800" marR="50800">
+                    <a:solidFill>
+                      <a:srgbClr val="242424"/>
+                    </a:solidFill>
+                  </a:tcPr>
+                </a:tc>
+              </a:tr>
+              <a:tr h="295101">
+                <a:tc>
+                  <a:txBody>
+                    <a:bodyPr/>
+                    <a:lstStyle/>
+                    <a:p>
+                      <a:pPr algn="l"/>
+                      <a:r>
+                        <a:rPr sz="800" b="0">
+                          <a:solidFill>
+                            <a:srgbClr val="FFFFFF"/>
+                          </a:solidFill>
+                          <a:latin typeface="Calibri"/>
+                        </a:rPr>
+                        <a:t>missing-configmap</a:t>
+                      </a:r>
+                    </a:p>
+                  </a:txBody>
+                  <a:tcPr anchor="ctr" marT="19050" marB="19050" marL="50800" marR="50800">
+                    <a:solidFill>
+                      <a:srgbClr val="2A2A2A"/>
+                    </a:solidFill>
+                  </a:tcPr>
+                </a:tc>
+                <a:tc>
+                  <a:txBody>
+                    <a:bodyPr/>
+                    <a:lstStyle/>
+                    <a:p>
+                      <a:pPr algn="l"/>
+                      <a:r>
+                        <a:rPr sz="800" b="0">
+                          <a:solidFill>
+                            <a:srgbClr val="FFFFFF"/>
+                          </a:solidFill>
+                          <a:latin typeface="Calibri"/>
+                        </a:rPr>
+                        <a:t>ConfigMap "nonexistent-app-config" not found</a:t>
+                      </a:r>
+                    </a:p>
+                  </a:txBody>
+                  <a:tcPr anchor="ctr" marT="19050" marB="19050" marL="50800" marR="50800">
+                    <a:solidFill>
+                      <a:srgbClr val="2A2A2A"/>
+                    </a:solidFill>
+                  </a:tcPr>
+                </a:tc>
+                <a:tc>
+                  <a:txBody>
+                    <a:bodyPr/>
+                    <a:lstStyle/>
+                    <a:p>
+                      <a:pPr algn="l"/>
+                      <a:r>
+                        <a:rPr sz="800" b="0">
+                          <a:solidFill>
+                            <a:srgbClr val="CCCCCC"/>
+                          </a:solidFill>
+                          <a:latin typeface="Calibri"/>
+                        </a:rPr>
+                        <a:t>Correct</a:t>
+                      </a:r>
+                    </a:p>
+                  </a:txBody>
+                  <a:tcPr anchor="ctr" marT="19050" marB="19050" marL="50800" marR="50800">
+                    <a:solidFill>
+                      <a:srgbClr val="2A2A2A"/>
+                    </a:solidFill>
+                  </a:tcPr>
+                </a:tc>
+                <a:tc>
+                  <a:txBody>
+                    <a:bodyPr/>
+                    <a:lstStyle/>
+                    <a:p>
+                      <a:pPr algn="l"/>
+                      <a:r>
+                        <a:rPr sz="800" b="0">
+                          <a:solidFill>
+                            <a:srgbClr val="CCCCCC"/>
+                          </a:solidFill>
+                          <a:latin typeface="Calibri"/>
+                        </a:rPr>
+                        <a:t>0.80 review</a:t>
+                      </a:r>
+                    </a:p>
+                  </a:txBody>
+                  <a:tcPr anchor="ctr" marT="19050" marB="19050" marL="50800" marR="50800">
+                    <a:solidFill>
+                      <a:srgbClr val="2A2A2A"/>
+                    </a:solidFill>
+                  </a:tcPr>
+                </a:tc>
+                <a:tc>
+                  <a:txBody>
+                    <a:bodyPr/>
+                    <a:lstStyle/>
+                    <a:p>
+                      <a:pPr algn="l"/>
+                      <a:r>
+                        <a:rPr sz="800" b="1">
+                          <a:solidFill>
+                            <a:srgbClr val="1ABC9C"/>
+                          </a:solidFill>
+                          <a:latin typeface="Calibri"/>
+                        </a:rPr>
+                        <a:t>Passed</a:t>
+                      </a:r>
+                    </a:p>
+                  </a:txBody>
+                  <a:tcPr anchor="ctr" marT="19050" marB="19050" marL="50800" marR="50800">
+                    <a:solidFill>
+                      <a:srgbClr val="2A2A2A"/>
+                    </a:solidFill>
+                  </a:tcPr>
+                </a:tc>
+              </a:tr>
+              <a:tr h="295101">
+                <a:tc>
+                  <a:txBody>
+                    <a:bodyPr/>
+                    <a:lstStyle/>
+                    <a:p>
+                      <a:pPr algn="l"/>
+                      <a:r>
+                        <a:rPr sz="800" b="0">
+                          <a:solidFill>
+                            <a:srgbClr val="FFFFFF"/>
+                          </a:solidFill>
+                          <a:latin typeface="Calibri"/>
+                        </a:rPr>
+                        <a:t>missing-secret</a:t>
+                      </a:r>
+                    </a:p>
+                  </a:txBody>
+                  <a:tcPr anchor="ctr" marT="19050" marB="19050" marL="50800" marR="50800">
+                    <a:solidFill>
+                      <a:srgbClr val="242424"/>
+                    </a:solidFill>
+                  </a:tcPr>
+                </a:tc>
+                <a:tc>
+                  <a:txBody>
+                    <a:bodyPr/>
+                    <a:lstStyle/>
+                    <a:p>
+                      <a:pPr algn="l"/>
+                      <a:r>
+                        <a:rPr sz="800" b="0">
+                          <a:solidFill>
+                            <a:srgbClr val="FFFFFF"/>
+                          </a:solidFill>
+                          <a:latin typeface="Calibri"/>
+                        </a:rPr>
+                        <a:t>Secret "nonexistent-app-secret" not found</a:t>
+                      </a:r>
+                    </a:p>
+                  </a:txBody>
+                  <a:tcPr anchor="ctr" marT="19050" marB="19050" marL="50800" marR="50800">
+                    <a:solidFill>
+                      <a:srgbClr val="242424"/>
+                    </a:solidFill>
+                  </a:tcPr>
+                </a:tc>
+                <a:tc>
+                  <a:txBody>
+                    <a:bodyPr/>
+                    <a:lstStyle/>
+                    <a:p>
+                      <a:pPr algn="l"/>
+                      <a:r>
+                        <a:rPr sz="800" b="0">
+                          <a:solidFill>
+                            <a:srgbClr val="CCCCCC"/>
+                          </a:solidFill>
+                          <a:latin typeface="Calibri"/>
+                        </a:rPr>
+                        <a:t>Correct</a:t>
+                      </a:r>
+                    </a:p>
+                  </a:txBody>
+                  <a:tcPr anchor="ctr" marT="19050" marB="19050" marL="50800" marR="50800">
+                    <a:solidFill>
+                      <a:srgbClr val="242424"/>
+                    </a:solidFill>
+                  </a:tcPr>
+                </a:tc>
+                <a:tc>
+                  <a:txBody>
+                    <a:bodyPr/>
+                    <a:lstStyle/>
+                    <a:p>
+                      <a:pPr algn="l"/>
+                      <a:r>
+                        <a:rPr sz="800" b="0">
+                          <a:solidFill>
+                            <a:srgbClr val="CCCCCC"/>
+                          </a:solidFill>
+                          <a:latin typeface="Calibri"/>
+                        </a:rPr>
+                        <a:t>0.90 auto</a:t>
+                      </a:r>
+                    </a:p>
+                  </a:txBody>
+                  <a:tcPr anchor="ctr" marT="19050" marB="19050" marL="50800" marR="50800">
+                    <a:solidFill>
+                      <a:srgbClr val="242424"/>
+                    </a:solidFill>
+                  </a:tcPr>
+                </a:tc>
+                <a:tc>
+                  <a:txBody>
+                    <a:bodyPr/>
+                    <a:lstStyle/>
+                    <a:p>
+                      <a:pPr algn="l"/>
+                      <a:r>
+                        <a:rPr sz="800" b="1">
+                          <a:solidFill>
+                            <a:srgbClr val="1ABC9C"/>
+                          </a:solidFill>
+                          <a:latin typeface="Calibri"/>
+                        </a:rPr>
+                        <a:t>Passed</a:t>
+                      </a:r>
+                    </a:p>
+                  </a:txBody>
+                  <a:tcPr anchor="ctr" marT="19050" marB="19050" marL="50800" marR="50800">
+                    <a:solidFill>
+                      <a:srgbClr val="242424"/>
+                    </a:solidFill>
+                  </a:tcPr>
+                </a:tc>
+              </a:tr>
+              <a:tr h="295101">
+                <a:tc>
+                  <a:txBody>
+                    <a:bodyPr/>
+                    <a:lstStyle/>
+                    <a:p>
+                      <a:pPr algn="l"/>
+                      <a:r>
+                        <a:rPr sz="800" b="0">
+                          <a:solidFill>
+                            <a:srgbClr val="FFFFFF"/>
+                          </a:solidFill>
+                          <a:latin typeface="Calibri"/>
+                        </a:rPr>
+                        <a:t>bad-config-key</a:t>
+                      </a:r>
+                    </a:p>
+                  </a:txBody>
+                  <a:tcPr anchor="ctr" marT="19050" marB="19050" marL="50800" marR="50800">
+                    <a:solidFill>
+                      <a:srgbClr val="2A2A2A"/>
+                    </a:solidFill>
+                  </a:tcPr>
+                </a:tc>
+                <a:tc>
+                  <a:txBody>
+                    <a:bodyPr/>
+                    <a:lstStyle/>
+                    <a:p>
+                      <a:pPr algn="l"/>
+                      <a:r>
+                        <a:rPr sz="800" b="0">
+                          <a:solidFill>
+                            <a:srgbClr val="FFFFFF"/>
+                          </a:solidFill>
+                          <a:latin typeface="Calibri"/>
+                        </a:rPr>
+                        <a:t>Missing "DB_HOST" key in ConfigMap</a:t>
+                      </a:r>
+                    </a:p>
+                  </a:txBody>
+                  <a:tcPr anchor="ctr" marT="19050" marB="19050" marL="50800" marR="50800">
+                    <a:solidFill>
+                      <a:srgbClr val="2A2A2A"/>
+                    </a:solidFill>
+                  </a:tcPr>
+                </a:tc>
+                <a:tc>
+                  <a:txBody>
+                    <a:bodyPr/>
+                    <a:lstStyle/>
+                    <a:p>
+                      <a:pPr algn="l"/>
+                      <a:r>
+                        <a:rPr sz="800" b="0">
+                          <a:solidFill>
+                            <a:srgbClr val="CCCCCC"/>
+                          </a:solidFill>
+                          <a:latin typeface="Calibri"/>
+                        </a:rPr>
+                        <a:t>Correct</a:t>
+                      </a:r>
+                    </a:p>
+                  </a:txBody>
+                  <a:tcPr anchor="ctr" marT="19050" marB="19050" marL="50800" marR="50800">
+                    <a:solidFill>
+                      <a:srgbClr val="2A2A2A"/>
+                    </a:solidFill>
+                  </a:tcPr>
+                </a:tc>
+                <a:tc>
+                  <a:txBody>
+                    <a:bodyPr/>
+                    <a:lstStyle/>
+                    <a:p>
+                      <a:pPr algn="l"/>
+                      <a:r>
+                        <a:rPr sz="800" b="0">
+                          <a:solidFill>
+                            <a:srgbClr val="CCCCCC"/>
+                          </a:solidFill>
+                          <a:latin typeface="Calibri"/>
+                        </a:rPr>
+                        <a:t>0.80 review</a:t>
+                      </a:r>
+                    </a:p>
+                  </a:txBody>
+                  <a:tcPr anchor="ctr" marT="19050" marB="19050" marL="50800" marR="50800">
+                    <a:solidFill>
+                      <a:srgbClr val="2A2A2A"/>
+                    </a:solidFill>
+                  </a:tcPr>
+                </a:tc>
+                <a:tc>
+                  <a:txBody>
+                    <a:bodyPr/>
+                    <a:lstStyle/>
+                    <a:p>
+                      <a:pPr algn="l"/>
+                      <a:r>
+                        <a:rPr sz="800" b="1">
+                          <a:solidFill>
+                            <a:srgbClr val="1ABC9C"/>
+                          </a:solidFill>
+                          <a:latin typeface="Calibri"/>
+                        </a:rPr>
+                        <a:t>Passed</a:t>
+                      </a:r>
+                    </a:p>
+                  </a:txBody>
+                  <a:tcPr anchor="ctr" marT="19050" marB="19050" marL="50800" marR="50800">
+                    <a:solidFill>
+                      <a:srgbClr val="2A2A2A"/>
+                    </a:solidFill>
+                  </a:tcPr>
+                </a:tc>
+              </a:tr>
+              <a:tr h="295101">
+                <a:tc>
+                  <a:txBody>
+                    <a:bodyPr/>
+                    <a:lstStyle/>
+                    <a:p>
+                      <a:pPr algn="l"/>
+                      <a:r>
+                        <a:rPr sz="800" b="0">
+                          <a:solidFill>
+                            <a:srgbClr val="FFFFFF"/>
+                          </a:solidFill>
+                          <a:latin typeface="Calibri"/>
+                        </a:rPr>
+                        <a:t>liveness-fail</a:t>
+                      </a:r>
+                    </a:p>
+                  </a:txBody>
+                  <a:tcPr anchor="ctr" marT="19050" marB="19050" marL="50800" marR="50800">
+                    <a:solidFill>
+                      <a:srgbClr val="242424"/>
+                    </a:solidFill>
+                  </a:tcPr>
+                </a:tc>
+                <a:tc>
+                  <a:txBody>
+                    <a:bodyPr/>
+                    <a:lstStyle/>
+                    <a:p>
+                      <a:pPr algn="l"/>
+                      <a:r>
+                        <a:rPr sz="800" b="0">
+                          <a:solidFill>
+                            <a:srgbClr val="FFFFFF"/>
+                          </a:solidFill>
+                          <a:latin typeface="Calibri"/>
+                        </a:rPr>
+                        <a:t>Liveness (HTTP 500) + readiness probe failures</a:t>
+                      </a:r>
+                    </a:p>
+                  </a:txBody>
+                  <a:tcPr anchor="ctr" marT="19050" marB="19050" marL="50800" marR="50800">
+                    <a:solidFill>
+                      <a:srgbClr val="242424"/>
+                    </a:solidFill>
+                  </a:tcPr>
+                </a:tc>
+                <a:tc>
+                  <a:txBody>
+                    <a:bodyPr/>
+                    <a:lstStyle/>
+                    <a:p>
+                      <a:pPr algn="l"/>
+                      <a:r>
+                        <a:rPr sz="800" b="0">
+                          <a:solidFill>
+                            <a:srgbClr val="CCCCCC"/>
+                          </a:solidFill>
+                          <a:latin typeface="Calibri"/>
+                        </a:rPr>
+                        <a:t>Correct</a:t>
+                      </a:r>
+                    </a:p>
+                  </a:txBody>
+                  <a:tcPr anchor="ctr" marT="19050" marB="19050" marL="50800" marR="50800">
+                    <a:solidFill>
+                      <a:srgbClr val="242424"/>
+                    </a:solidFill>
+                  </a:tcPr>
+                </a:tc>
+                <a:tc>
+                  <a:txBody>
+                    <a:bodyPr/>
+                    <a:lstStyle/>
+                    <a:p>
+                      <a:pPr algn="l"/>
+                      <a:r>
+                        <a:rPr sz="800" b="0">
+                          <a:solidFill>
+                            <a:srgbClr val="CCCCCC"/>
+                          </a:solidFill>
+                          <a:latin typeface="Calibri"/>
+                        </a:rPr>
+                        <a:t>0.90 auto</a:t>
+                      </a:r>
+                    </a:p>
+                  </a:txBody>
+                  <a:tcPr anchor="ctr" marT="19050" marB="19050" marL="50800" marR="50800">
+                    <a:solidFill>
+                      <a:srgbClr val="242424"/>
+                    </a:solidFill>
+                  </a:tcPr>
+                </a:tc>
+                <a:tc>
+                  <a:txBody>
+                    <a:bodyPr/>
+                    <a:lstStyle/>
+                    <a:p>
+                      <a:pPr algn="l"/>
+                      <a:r>
+                        <a:rPr sz="800" b="1">
+                          <a:solidFill>
+                            <a:srgbClr val="1ABC9C"/>
+                          </a:solidFill>
+                          <a:latin typeface="Calibri"/>
+                        </a:rPr>
+                        <a:t>Passed</a:t>
+                      </a:r>
+                    </a:p>
+                  </a:txBody>
+                  <a:tcPr anchor="ctr" marT="19050" marB="19050" marL="50800" marR="50800">
+                    <a:solidFill>
+                      <a:srgbClr val="242424"/>
+                    </a:solidFill>
+                  </a:tcPr>
+                </a:tc>
+              </a:tr>
+              <a:tr h="295101">
+                <a:tc>
+                  <a:txBody>
+                    <a:bodyPr/>
+                    <a:lstStyle/>
+                    <a:p>
+                      <a:pPr algn="l"/>
+                      <a:r>
+                        <a:rPr sz="800" b="0">
+                          <a:solidFill>
+                            <a:srgbClr val="FFFFFF"/>
+                          </a:solidFill>
+                          <a:latin typeface="Calibri"/>
+                        </a:rPr>
+                        <a:t>node-selector</a:t>
+                      </a:r>
+                    </a:p>
+                  </a:txBody>
+                  <a:tcPr anchor="ctr" marT="19050" marB="19050" marL="50800" marR="50800">
+                    <a:solidFill>
+                      <a:srgbClr val="2A2A2A"/>
+                    </a:solidFill>
+                  </a:tcPr>
+                </a:tc>
+                <a:tc>
+                  <a:txBody>
+                    <a:bodyPr/>
+                    <a:lstStyle/>
+                    <a:p>
+                      <a:pPr algn="l"/>
+                      <a:r>
+                        <a:rPr sz="800" b="0">
+                          <a:solidFill>
+                            <a:srgbClr val="FFFFFF"/>
+                          </a:solidFill>
+                          <a:latin typeface="Calibri"/>
+                        </a:rPr>
+                        <a:t>Node selector matches zero nodes</a:t>
+                      </a:r>
+                    </a:p>
+                  </a:txBody>
+                  <a:tcPr anchor="ctr" marT="19050" marB="19050" marL="50800" marR="50800">
+                    <a:solidFill>
+                      <a:srgbClr val="2A2A2A"/>
+                    </a:solidFill>
+                  </a:tcPr>
+                </a:tc>
+                <a:tc>
+                  <a:txBody>
+                    <a:bodyPr/>
+                    <a:lstStyle/>
+                    <a:p>
+                      <a:pPr algn="l"/>
+                      <a:r>
+                        <a:rPr sz="800" b="0">
+                          <a:solidFill>
+                            <a:srgbClr val="CCCCCC"/>
+                          </a:solidFill>
+                          <a:latin typeface="Calibri"/>
+                        </a:rPr>
+                        <a:t>Correct</a:t>
+                      </a:r>
+                    </a:p>
+                  </a:txBody>
+                  <a:tcPr anchor="ctr" marT="19050" marB="19050" marL="50800" marR="50800">
+                    <a:solidFill>
+                      <a:srgbClr val="2A2A2A"/>
+                    </a:solidFill>
+                  </a:tcPr>
+                </a:tc>
+                <a:tc>
+                  <a:txBody>
+                    <a:bodyPr/>
+                    <a:lstStyle/>
+                    <a:p>
+                      <a:pPr algn="l"/>
+                      <a:r>
+                        <a:rPr sz="800" b="0">
+                          <a:solidFill>
+                            <a:srgbClr val="CCCCCC"/>
+                          </a:solidFill>
+                          <a:latin typeface="Calibri"/>
+                        </a:rPr>
+                        <a:t>0.90 auto</a:t>
+                      </a:r>
+                    </a:p>
+                  </a:txBody>
+                  <a:tcPr anchor="ctr" marT="19050" marB="19050" marL="50800" marR="50800">
+                    <a:solidFill>
+                      <a:srgbClr val="2A2A2A"/>
+                    </a:solidFill>
+                  </a:tcPr>
+                </a:tc>
+                <a:tc>
+                  <a:txBody>
+                    <a:bodyPr/>
+                    <a:lstStyle/>
+                    <a:p>
+                      <a:pPr algn="l"/>
+                      <a:r>
+                        <a:rPr sz="800" b="1">
+                          <a:solidFill>
+                            <a:srgbClr val="1ABC9C"/>
+                          </a:solidFill>
+                          <a:latin typeface="Calibri"/>
+                        </a:rPr>
+                        <a:t>Passed</a:t>
+                      </a:r>
+                    </a:p>
+                  </a:txBody>
+                  <a:tcPr anchor="ctr" marT="19050" marB="19050" marL="50800" marR="50800">
+                    <a:solidFill>
+                      <a:srgbClr val="2A2A2A"/>
+                    </a:solidFill>
+                  </a:tcPr>
+                </a:tc>
+              </a:tr>
+              <a:tr h="295101">
+                <a:tc>
+                  <a:txBody>
+                    <a:bodyPr/>
+                    <a:lstStyle/>
+                    <a:p>
+                      <a:pPr algn="l"/>
+                      <a:r>
+                        <a:rPr sz="800" b="0">
+                          <a:solidFill>
+                            <a:srgbClr val="FFFFFF"/>
+                          </a:solidFill>
+                          <a:latin typeface="Calibri"/>
+                        </a:rPr>
+                        <a:t>pvc-pending</a:t>
+                      </a:r>
+                    </a:p>
+                  </a:txBody>
+                  <a:tcPr anchor="ctr" marT="19050" marB="19050" marL="50800" marR="50800">
+                    <a:solidFill>
+                      <a:srgbClr val="242424"/>
+                    </a:solidFill>
+                  </a:tcPr>
+                </a:tc>
+                <a:tc>
+                  <a:txBody>
+                    <a:bodyPr/>
+                    <a:lstStyle/>
+                    <a:p>
+                      <a:pPr algn="l"/>
+                      <a:r>
+                        <a:rPr sz="800" b="0">
+                          <a:solidFill>
+                            <a:srgbClr val="FFFFFF"/>
+                          </a:solidFill>
+                          <a:latin typeface="Calibri"/>
+                        </a:rPr>
+                        <a:t>Required PVC missing -- can't schedule</a:t>
+                      </a:r>
+                    </a:p>
+                  </a:txBody>
+                  <a:tcPr anchor="ctr" marT="19050" marB="19050" marL="50800" marR="50800">
+                    <a:solidFill>
+                      <a:srgbClr val="242424"/>
+                    </a:solidFill>
+                  </a:tcPr>
+                </a:tc>
+                <a:tc>
+                  <a:txBody>
+                    <a:bodyPr/>
+                    <a:lstStyle/>
+                    <a:p>
+                      <a:pPr algn="l"/>
+                      <a:r>
+                        <a:rPr sz="800" b="0">
+                          <a:solidFill>
+                            <a:srgbClr val="CCCCCC"/>
+                          </a:solidFill>
+                          <a:latin typeface="Calibri"/>
+                        </a:rPr>
+                        <a:t>Correct</a:t>
+                      </a:r>
+                    </a:p>
+                  </a:txBody>
+                  <a:tcPr anchor="ctr" marT="19050" marB="19050" marL="50800" marR="50800">
+                    <a:solidFill>
+                      <a:srgbClr val="242424"/>
+                    </a:solidFill>
+                  </a:tcPr>
+                </a:tc>
+                <a:tc>
+                  <a:txBody>
+                    <a:bodyPr/>
+                    <a:lstStyle/>
+                    <a:p>
+                      <a:pPr algn="l"/>
+                      <a:r>
+                        <a:rPr sz="800" b="0">
+                          <a:solidFill>
+                            <a:srgbClr val="CCCCCC"/>
+                          </a:solidFill>
+                          <a:latin typeface="Calibri"/>
+                        </a:rPr>
+                        <a:t>0.90 auto</a:t>
+                      </a:r>
+                    </a:p>
+                  </a:txBody>
+                  <a:tcPr anchor="ctr" marT="19050" marB="19050" marL="50800" marR="50800">
+                    <a:solidFill>
+                      <a:srgbClr val="242424"/>
+                    </a:solidFill>
+                  </a:tcPr>
+                </a:tc>
+                <a:tc>
+                  <a:txBody>
+                    <a:bodyPr/>
+                    <a:lstStyle/>
+                    <a:p>
+                      <a:pPr algn="l"/>
+                      <a:r>
+                        <a:rPr sz="800" b="1">
+                          <a:solidFill>
+                            <a:srgbClr val="1ABC9C"/>
+                          </a:solidFill>
+                          <a:latin typeface="Calibri"/>
+                        </a:rPr>
+                        <a:t>Passed</a:t>
+                      </a:r>
+                    </a:p>
+                  </a:txBody>
+                  <a:tcPr anchor="ctr" marT="19050" marB="19050" marL="50800" marR="50800">
+                    <a:solidFill>
+                      <a:srgbClr val="242424"/>
+                    </a:solidFill>
+                  </a:tcPr>
+                </a:tc>
+              </a:tr>
+              <a:tr h="295101">
+                <a:tc>
+                  <a:txBody>
+                    <a:bodyPr/>
+                    <a:lstStyle/>
+                    <a:p>
+                      <a:pPr algn="l"/>
+                      <a:r>
+                        <a:rPr sz="800" b="0">
+                          <a:solidFill>
+                            <a:srgbClr val="FFFFFF"/>
+                          </a:solidFill>
+                          <a:latin typeface="Calibri"/>
+                        </a:rPr>
+                        <a:t>cascading</a:t>
+                      </a:r>
+                    </a:p>
+                  </a:txBody>
+                  <a:tcPr anchor="ctr" marT="19050" marB="19050" marL="50800" marR="50800">
+                    <a:solidFill>
+                      <a:srgbClr val="2A2A2A"/>
+                    </a:solidFill>
+                  </a:tcPr>
+                </a:tc>
+                <a:tc>
+                  <a:txBody>
+                    <a:bodyPr/>
+                    <a:lstStyle/>
+                    <a:p>
+                      <a:pPr algn="l"/>
+                      <a:r>
+                        <a:rPr sz="800" b="0">
+                          <a:solidFill>
+                            <a:srgbClr val="FFFFFF"/>
+                          </a:solidFill>
+                          <a:latin typeface="Calibri"/>
+                        </a:rPr>
+                        <a:t>Escalated honestly -- logs blocked by permissions</a:t>
+                      </a:r>
+                    </a:p>
+                  </a:txBody>
+                  <a:tcPr anchor="ctr" marT="19050" marB="19050" marL="50800" marR="50800">
+                    <a:solidFill>
+                      <a:srgbClr val="2A2A2A"/>
+                    </a:solidFill>
+                  </a:tcPr>
+                </a:tc>
+                <a:tc>
+                  <a:txBody>
+                    <a:bodyPr/>
+                    <a:lstStyle/>
+                    <a:p>
+                      <a:pPr algn="l"/>
+                      <a:r>
+                        <a:rPr sz="800" b="0">
+                          <a:solidFill>
+                            <a:srgbClr val="CCCCCC"/>
+                          </a:solidFill>
+                          <a:latin typeface="Calibri"/>
+                        </a:rPr>
+                        <a:t>Honest escalation</a:t>
+                      </a:r>
+                    </a:p>
+                  </a:txBody>
+                  <a:tcPr anchor="ctr" marT="19050" marB="19050" marL="50800" marR="50800">
+                    <a:solidFill>
+                      <a:srgbClr val="2A2A2A"/>
+                    </a:solidFill>
+                  </a:tcPr>
+                </a:tc>
+                <a:tc>
+                  <a:txBody>
+                    <a:bodyPr/>
+                    <a:lstStyle/>
+                    <a:p>
+                      <a:pPr algn="l"/>
+                      <a:r>
+                        <a:rPr sz="800" b="0">
+                          <a:solidFill>
+                            <a:srgbClr val="CCCCCC"/>
+                          </a:solidFill>
+                          <a:latin typeface="Calibri"/>
+                        </a:rPr>
+                        <a:t>0.20 escalate</a:t>
+                      </a:r>
+                    </a:p>
+                  </a:txBody>
+                  <a:tcPr anchor="ctr" marT="19050" marB="19050" marL="50800" marR="50800">
+                    <a:solidFill>
+                      <a:srgbClr val="2A2A2A"/>
+                    </a:solidFill>
+                  </a:tcPr>
+                </a:tc>
+                <a:tc>
+                  <a:txBody>
+                    <a:bodyPr/>
+                    <a:lstStyle/>
+                    <a:p>
+                      <a:pPr algn="l"/>
+                      <a:r>
+                        <a:rPr sz="800" b="1">
+                          <a:solidFill>
+                            <a:srgbClr val="F4C542"/>
+                          </a:solidFill>
+                          <a:latin typeface="Calibri"/>
+                        </a:rPr>
+                        <a:t>Scored fail*</a:t>
+                      </a:r>
+                    </a:p>
+                  </a:txBody>
+                  <a:tcPr anchor="ctr" marT="19050" marB="19050" marL="50800" marR="50800">
+                    <a:solidFill>
+                      <a:srgbClr val="2A2A2A"/>
+                    </a:solidFill>
+                  </a:tcPr>
+                </a:tc>
+              </a:tr>
+              <a:tr h="295101">
+                <a:tc>
+                  <a:txBody>
+                    <a:bodyPr/>
+                    <a:lstStyle/>
+                    <a:p>
+                      <a:pPr algn="l"/>
+                      <a:r>
+                        <a:rPr sz="800" b="0">
+                          <a:solidFill>
+                            <a:srgbClr val="FFFFFF"/>
+                          </a:solidFill>
+                          <a:latin typeface="Calibri"/>
+                        </a:rPr>
+                        <a:t>already-resolved</a:t>
+                      </a:r>
+                    </a:p>
+                  </a:txBody>
+                  <a:tcPr anchor="ctr" marT="19050" marB="19050" marL="50800" marR="50800">
+                    <a:solidFill>
+                      <a:srgbClr val="242424"/>
+                    </a:solidFill>
+                  </a:tcPr>
+                </a:tc>
+                <a:tc>
+                  <a:txBody>
+                    <a:bodyPr/>
+                    <a:lstStyle/>
+                    <a:p>
+                      <a:pPr algn="l"/>
+                      <a:r>
+                        <a:rPr sz="800" b="0">
+                          <a:solidFill>
+                            <a:srgbClr val="FFFFFF"/>
+                          </a:solidFill>
+                          <a:latin typeface="Calibri"/>
+                        </a:rPr>
+                        <a:t>Self-diagnosed the exact missing RoleBinding</a:t>
+                      </a:r>
+                    </a:p>
+                  </a:txBody>
+                  <a:tcPr anchor="ctr" marT="19050" marB="19050" marL="50800" marR="50800">
+                    <a:solidFill>
+                      <a:srgbClr val="242424"/>
+                    </a:solidFill>
+                  </a:tcPr>
+                </a:tc>
+                <a:tc>
+                  <a:txBody>
+                    <a:bodyPr/>
+                    <a:lstStyle/>
+                    <a:p>
+                      <a:pPr algn="l"/>
+                      <a:r>
+                        <a:rPr sz="800" b="0">
+                          <a:solidFill>
+                            <a:srgbClr val="CCCCCC"/>
+                          </a:solidFill>
+                          <a:latin typeface="Calibri"/>
+                        </a:rPr>
+                        <a:t>Honest diagnosis</a:t>
+                      </a:r>
+                    </a:p>
+                  </a:txBody>
+                  <a:tcPr anchor="ctr" marT="19050" marB="19050" marL="50800" marR="50800">
+                    <a:solidFill>
+                      <a:srgbClr val="242424"/>
+                    </a:solidFill>
+                  </a:tcPr>
+                </a:tc>
+                <a:tc>
+                  <a:txBody>
+                    <a:bodyPr/>
+                    <a:lstStyle/>
+                    <a:p>
+                      <a:pPr algn="l"/>
+                      <a:r>
+                        <a:rPr sz="800" b="0">
+                          <a:solidFill>
+                            <a:srgbClr val="CCCCCC"/>
+                          </a:solidFill>
+                          <a:latin typeface="Calibri"/>
+                        </a:rPr>
+                        <a:t>0.80 review</a:t>
+                      </a:r>
+                    </a:p>
+                  </a:txBody>
+                  <a:tcPr anchor="ctr" marT="19050" marB="19050" marL="50800" marR="50800">
+                    <a:solidFill>
+                      <a:srgbClr val="242424"/>
+                    </a:solidFill>
+                  </a:tcPr>
+                </a:tc>
+                <a:tc>
+                  <a:txBody>
+                    <a:bodyPr/>
+                    <a:lstStyle/>
+                    <a:p>
+                      <a:pPr algn="l"/>
+                      <a:r>
+                        <a:rPr sz="800" b="1">
+                          <a:solidFill>
+                            <a:srgbClr val="F4C542"/>
+                          </a:solidFill>
+                          <a:latin typeface="Calibri"/>
+                        </a:rPr>
+                        <a:t>Scored fail*</a:t>
+                      </a:r>
+                    </a:p>
+                  </a:txBody>
+                  <a:tcPr anchor="ctr" marT="19050" marB="19050" marL="50800" marR="50800">
+                    <a:solidFill>
+                      <a:srgbClr val="242424"/>
+                    </a:solidFill>
+                  </a:tcPr>
+                </a:tc>
+              </a:tr>
+              <a:tr h="295110">
+                <a:tc>
+                  <a:txBody>
+                    <a:bodyPr/>
+                    <a:lstStyle/>
+                    <a:p>
+                      <a:pPr algn="l"/>
+                      <a:r>
+                        <a:rPr sz="800" b="0">
+                          <a:solidFill>
+                            <a:srgbClr val="FFFFFF"/>
+                          </a:solidFill>
+                          <a:latin typeface="Calibri"/>
+                        </a:rPr>
+                        <a:t>bad-command</a:t>
+                      </a:r>
+                    </a:p>
+                  </a:txBody>
+                  <a:tcPr anchor="ctr" marT="19050" marB="19050" marL="50800" marR="50800">
+                    <a:solidFill>
+                      <a:srgbClr val="2A2A2A"/>
+                    </a:solidFill>
+                  </a:tcPr>
+                </a:tc>
+                <a:tc>
+                  <a:txBody>
+                    <a:bodyPr/>
+                    <a:lstStyle/>
+                    <a:p>
+                      <a:pPr algn="l"/>
+                      <a:r>
+                        <a:rPr sz="800" b="0">
+                          <a:solidFill>
+                            <a:srgbClr val="FFFFFF"/>
+                          </a:solidFill>
+                          <a:latin typeface="Calibri"/>
+                        </a:rPr>
+                        <a:t>Escalated honestly -- logs blocked by permissions</a:t>
+                      </a:r>
+                    </a:p>
+                  </a:txBody>
+                  <a:tcPr anchor="ctr" marT="19050" marB="19050" marL="50800" marR="50800">
+                    <a:solidFill>
+                      <a:srgbClr val="2A2A2A"/>
+                    </a:solidFill>
+                  </a:tcPr>
+                </a:tc>
+                <a:tc>
+                  <a:txBody>
+                    <a:bodyPr/>
+                    <a:lstStyle/>
+                    <a:p>
+                      <a:pPr algn="l"/>
+                      <a:r>
+                        <a:rPr sz="800" b="0">
+                          <a:solidFill>
+                            <a:srgbClr val="CCCCCC"/>
+                          </a:solidFill>
+                          <a:latin typeface="Calibri"/>
+                        </a:rPr>
+                        <a:t>Honest escalation</a:t>
+                      </a:r>
+                    </a:p>
+                  </a:txBody>
+                  <a:tcPr anchor="ctr" marT="19050" marB="19050" marL="50800" marR="50800">
+                    <a:solidFill>
+                      <a:srgbClr val="2A2A2A"/>
+                    </a:solidFill>
+                  </a:tcPr>
+                </a:tc>
+                <a:tc>
+                  <a:txBody>
+                    <a:bodyPr/>
+                    <a:lstStyle/>
+                    <a:p>
+                      <a:pPr algn="l"/>
+                      <a:r>
+                        <a:rPr sz="800" b="0">
+                          <a:solidFill>
+                            <a:srgbClr val="CCCCCC"/>
+                          </a:solidFill>
+                          <a:latin typeface="Calibri"/>
+                        </a:rPr>
+                        <a:t>0.20 escalate</a:t>
+                      </a:r>
+                    </a:p>
+                  </a:txBody>
+                  <a:tcPr anchor="ctr" marT="19050" marB="19050" marL="50800" marR="50800">
+                    <a:solidFill>
+                      <a:srgbClr val="2A2A2A"/>
+                    </a:solidFill>
+                  </a:tcPr>
+                </a:tc>
+                <a:tc>
+                  <a:txBody>
+                    <a:bodyPr/>
+                    <a:lstStyle/>
+                    <a:p>
+                      <a:pPr algn="l"/>
+                      <a:r>
+                        <a:rPr sz="800" b="1">
+                          <a:solidFill>
+                            <a:srgbClr val="F4C542"/>
+                          </a:solidFill>
+                          <a:latin typeface="Calibri"/>
+                        </a:rPr>
+                        <a:t>Scored fail*</a:t>
+                      </a:r>
+                    </a:p>
+                  </a:txBody>
+                  <a:tcPr anchor="ctr" marT="19050" marB="19050" marL="50800" marR="50800">
+                    <a:solidFill>
+                      <a:srgbClr val="2A2A2A"/>
+                    </a:solidFill>
+                  </a:tcPr>
+                </a:tc>
+              </a:tr>
+            </a:tbl>
+          </a:graphicData>
+        </a:graphic>
+      </p:graphicFrame>
+      <p:sp>
+        <p:nvSpPr>
+          <p:cNvPr id="6" name="TextBox 5"/>
+          <p:cNvSpPr txBox="1"/>
+          <p:nvPr/>
+        </p:nvSpPr>
+        <p:spPr>
+          <a:xfrm>
+            <a:off x="457200" y="4389120"/>
+            <a:ext cx="8229600" cy="320040"/>
+          </a:xfrm>
+          <a:prstGeom prst="rect">
+            <a:avLst/>
+          </a:prstGeom>
+          <a:noFill/>
+        </p:spPr>
+        <p:txBody>
+          <a:bodyPr wrap="square">
+            <a:spAutoFit/>
+          </a:bodyPr>
+          <a:lstStyle/>
+          <a:p>
+            <a:pPr algn="l"/>
+            <a:r>
+              <a:rPr sz="950" b="0" i="1">
+                <a:solidFill>
+                  <a:srgbClr val="999999"/>
+                </a:solidFill>
+                <a:latin typeface="Calibri"/>
+              </a:rPr>
+              <a:t>*Scored "fail" by the strict keyword-match formula, not because the answer was wrong -- zero hallucinated root causes across all 10 investigations.</a:t>
+            </a:r>
+          </a:p>
+        </p:txBody>
+      </p:sp>
+    </p:spTree>
+  </p:cSld>
+  <p:clrMapOvr>
+    <a:masterClrMapping/>
+  </p:clrMapOvr>
+</p:sld>
+</file>
+
+<file path=ppt/slides/slide19.xml><?xml version="1.0" encoding="utf-8"?>
 <p:sld xmlns:a="http://schemas.openxmlformats.org/drawingml/2006/main" xmlns:r="http://schemas.openxmlformats.org/officeDocument/2006/relationships" xmlns:p="http://schemas.openxmlformats.org/presentationml/2006/main">
   <p:cSld name="Slide 21">
     <p:bg>
@@ -17745,681 +19318,6 @@
               <a:t>What it costs and how we measure success</a:t>
             </a:r>
             <a:endParaRPr lang="en-US" sz="1400" dirty="0"/>
-          </a:p>
-        </p:txBody>
-      </p:sp>
-    </p:spTree>
-  </p:cSld>
-  <p:clrMapOvr>
-    <a:masterClrMapping/>
-  </p:clrMapOvr>
-</p:sld>
-</file>
-
-<file path=ppt/slides/slide19.xml><?xml version="1.0" encoding="utf-8"?>
-<p:sld xmlns:a="http://schemas.openxmlformats.org/drawingml/2006/main" xmlns:p="http://schemas.openxmlformats.org/presentationml/2006/main" xmlns:r="http://schemas.openxmlformats.org/officeDocument/2006/relationships">
-  <p:cSld>
-    <p:spTree>
-      <p:nvGrpSpPr>
-        <p:cNvPr id="1" name=""/>
-        <p:cNvGrpSpPr/>
-        <p:nvPr/>
-      </p:nvGrpSpPr>
-      <p:grpSpPr/>
-      <p:sp>
-        <p:nvSpPr>
-          <p:cNvPr id="2" name="TextBox 1"/>
-          <p:cNvSpPr txBox="1"/>
-          <p:nvPr/>
-        </p:nvSpPr>
-        <p:spPr>
-          <a:xfrm>
-            <a:off x="7589520" y="137160"/>
-            <a:ext cx="1371600" cy="274320"/>
-          </a:xfrm>
-          <a:prstGeom prst="rect">
-            <a:avLst/>
-          </a:prstGeom>
-          <a:noFill/>
-        </p:spPr>
-        <p:txBody>
-          <a:bodyPr wrap="none">
-            <a:spAutoFit/>
-          </a:bodyPr>
-          <a:lstStyle/>
-          <a:p>
-            <a:r>
-              <a:rPr sz="1200" b="1">
-                <a:solidFill>
-                  <a:srgbClr val="3CB371"/>
-                </a:solidFill>
-                <a:latin typeface="Trebuchet MS"/>
-              </a:rPr>
-              <a:t>SECTIGO</a:t>
-            </a:r>
-          </a:p>
-        </p:txBody>
-      </p:sp>
-      <p:sp>
-        <p:nvSpPr>
-          <p:cNvPr id="3" name="Rectangle 2"/>
-          <p:cNvSpPr/>
-          <p:nvPr/>
-        </p:nvSpPr>
-        <p:spPr>
-          <a:xfrm>
-            <a:off x="457200" y="182880"/>
-            <a:ext cx="1188720" cy="256032"/>
-          </a:xfrm>
-          <a:prstGeom prst="rect">
-            <a:avLst/>
-          </a:prstGeom>
-          <a:solidFill>
-            <a:srgbClr val="F4C542"/>
-          </a:solidFill>
-          <a:ln>
-            <a:noFill/>
-          </a:ln>
-          <a:effectLst/>
-        </p:spPr>
-        <p:style>
-          <a:lnRef idx="1">
-            <a:schemeClr val="accent1"/>
-          </a:lnRef>
-          <a:fillRef idx="3">
-            <a:schemeClr val="accent1"/>
-          </a:fillRef>
-          <a:effectRef idx="2">
-            <a:schemeClr val="accent1"/>
-          </a:effectRef>
-          <a:fontRef idx="minor">
-            <a:schemeClr val="lt1"/>
-          </a:fontRef>
-        </p:style>
-        <p:txBody>
-          <a:bodyPr rtlCol="0" anchor="ctr"/>
-          <a:lstStyle/>
-          <a:p>
-            <a:pPr algn="ctr"/>
-            <a:r>
-              <a:rPr sz="900" b="1">
-                <a:solidFill>
-                  <a:srgbClr val="1A1A1A"/>
-                </a:solidFill>
-                <a:latin typeface="Trebuchet MS"/>
-              </a:rPr>
-              <a:t>COST &amp; VALUE</a:t>
-            </a:r>
-          </a:p>
-        </p:txBody>
-      </p:sp>
-      <p:sp>
-        <p:nvSpPr>
-          <p:cNvPr id="4" name="TextBox 3"/>
-          <p:cNvSpPr txBox="1"/>
-          <p:nvPr/>
-        </p:nvSpPr>
-        <p:spPr>
-          <a:xfrm>
-            <a:off x="457200" y="594360"/>
-            <a:ext cx="8229600" cy="411480"/>
-          </a:xfrm>
-          <a:prstGeom prst="rect">
-            <a:avLst/>
-          </a:prstGeom>
-          <a:noFill/>
-        </p:spPr>
-        <p:txBody>
-          <a:bodyPr wrap="square">
-            <a:spAutoFit/>
-          </a:bodyPr>
-          <a:lstStyle/>
-          <a:p>
-            <a:pPr algn="l"/>
-            <a:r>
-              <a:rPr sz="2000" b="1">
-                <a:solidFill>
-                  <a:srgbClr val="FFFFFF"/>
-                </a:solidFill>
-                <a:latin typeface="Calibri"/>
-              </a:rPr>
-              <a:t>What This Actually Costs</a:t>
-            </a:r>
-          </a:p>
-        </p:txBody>
-      </p:sp>
-      <p:sp>
-        <p:nvSpPr>
-          <p:cNvPr id="5" name="Rectangle 4"/>
-          <p:cNvSpPr/>
-          <p:nvPr/>
-        </p:nvSpPr>
-        <p:spPr>
-          <a:xfrm>
-            <a:off x="457200" y="1234440"/>
-            <a:ext cx="2560320" cy="914400"/>
-          </a:xfrm>
-          <a:prstGeom prst="rect">
-            <a:avLst/>
-          </a:prstGeom>
-          <a:solidFill>
-            <a:srgbClr val="242424"/>
-          </a:solidFill>
-          <a:ln>
-            <a:noFill/>
-          </a:ln>
-          <a:effectLst/>
-        </p:spPr>
-        <p:style>
-          <a:lnRef idx="1">
-            <a:schemeClr val="accent1"/>
-          </a:lnRef>
-          <a:fillRef idx="3">
-            <a:schemeClr val="accent1"/>
-          </a:fillRef>
-          <a:effectRef idx="2">
-            <a:schemeClr val="accent1"/>
-          </a:effectRef>
-          <a:fontRef idx="minor">
-            <a:schemeClr val="lt1"/>
-          </a:fontRef>
-        </p:style>
-        <p:txBody>
-          <a:bodyPr rtlCol="0" anchor="ctr"/>
-          <a:lstStyle/>
-          <a:p>
-            <a:pPr algn="ctr"/>
-          </a:p>
-        </p:txBody>
-      </p:sp>
-      <p:sp>
-        <p:nvSpPr>
-          <p:cNvPr id="6" name="TextBox 5"/>
-          <p:cNvSpPr txBox="1"/>
-          <p:nvPr/>
-        </p:nvSpPr>
-        <p:spPr>
-          <a:xfrm>
-            <a:off x="594360" y="1325880"/>
-            <a:ext cx="2286000" cy="457200"/>
-          </a:xfrm>
-          <a:prstGeom prst="rect">
-            <a:avLst/>
-          </a:prstGeom>
-          <a:noFill/>
-        </p:spPr>
-        <p:txBody>
-          <a:bodyPr wrap="square">
-            <a:spAutoFit/>
-          </a:bodyPr>
-          <a:lstStyle/>
-          <a:p>
-            <a:pPr algn="l"/>
-            <a:r>
-              <a:rPr sz="2400" b="1">
-                <a:solidFill>
-                  <a:srgbClr val="1ABC9C"/>
-                </a:solidFill>
-                <a:latin typeface="Calibri"/>
-              </a:rPr>
-              <a:t>$0.0025</a:t>
-            </a:r>
-          </a:p>
-        </p:txBody>
-      </p:sp>
-      <p:sp>
-        <p:nvSpPr>
-          <p:cNvPr id="7" name="TextBox 6"/>
-          <p:cNvSpPr txBox="1"/>
-          <p:nvPr/>
-        </p:nvSpPr>
-        <p:spPr>
-          <a:xfrm>
-            <a:off x="594360" y="1783080"/>
-            <a:ext cx="2286000" cy="320040"/>
-          </a:xfrm>
-          <a:prstGeom prst="rect">
-            <a:avLst/>
-          </a:prstGeom>
-          <a:noFill/>
-        </p:spPr>
-        <p:txBody>
-          <a:bodyPr wrap="square">
-            <a:spAutoFit/>
-          </a:bodyPr>
-          <a:lstStyle/>
-          <a:p>
-            <a:pPr algn="l"/>
-            <a:r>
-              <a:rPr sz="1000" b="0">
-                <a:solidFill>
-                  <a:srgbClr val="999999"/>
-                </a:solidFill>
-                <a:latin typeface="Calibri"/>
-              </a:rPr>
-              <a:t>Avg cost / investigation</a:t>
-            </a:r>
-          </a:p>
-        </p:txBody>
-      </p:sp>
-      <p:sp>
-        <p:nvSpPr>
-          <p:cNvPr id="8" name="Rectangle 7"/>
-          <p:cNvSpPr/>
-          <p:nvPr/>
-        </p:nvSpPr>
-        <p:spPr>
-          <a:xfrm>
-            <a:off x="3154679" y="1234440"/>
-            <a:ext cx="2560320" cy="914400"/>
-          </a:xfrm>
-          <a:prstGeom prst="rect">
-            <a:avLst/>
-          </a:prstGeom>
-          <a:solidFill>
-            <a:srgbClr val="242424"/>
-          </a:solidFill>
-          <a:ln>
-            <a:noFill/>
-          </a:ln>
-          <a:effectLst/>
-        </p:spPr>
-        <p:style>
-          <a:lnRef idx="1">
-            <a:schemeClr val="accent1"/>
-          </a:lnRef>
-          <a:fillRef idx="3">
-            <a:schemeClr val="accent1"/>
-          </a:fillRef>
-          <a:effectRef idx="2">
-            <a:schemeClr val="accent1"/>
-          </a:effectRef>
-          <a:fontRef idx="minor">
-            <a:schemeClr val="lt1"/>
-          </a:fontRef>
-        </p:style>
-        <p:txBody>
-          <a:bodyPr rtlCol="0" anchor="ctr"/>
-          <a:lstStyle/>
-          <a:p>
-            <a:pPr algn="ctr"/>
-          </a:p>
-        </p:txBody>
-      </p:sp>
-      <p:sp>
-        <p:nvSpPr>
-          <p:cNvPr id="9" name="TextBox 8"/>
-          <p:cNvSpPr txBox="1"/>
-          <p:nvPr/>
-        </p:nvSpPr>
-        <p:spPr>
-          <a:xfrm>
-            <a:off x="3291839" y="1325880"/>
-            <a:ext cx="2286000" cy="457200"/>
-          </a:xfrm>
-          <a:prstGeom prst="rect">
-            <a:avLst/>
-          </a:prstGeom>
-          <a:noFill/>
-        </p:spPr>
-        <p:txBody>
-          <a:bodyPr wrap="square">
-            <a:spAutoFit/>
-          </a:bodyPr>
-          <a:lstStyle/>
-          <a:p>
-            <a:pPr algn="l"/>
-            <a:r>
-              <a:rPr sz="2400" b="1">
-                <a:solidFill>
-                  <a:srgbClr val="F4C542"/>
-                </a:solidFill>
-                <a:latin typeface="Calibri"/>
-              </a:rPr>
-              <a:t>20.5s</a:t>
-            </a:r>
-          </a:p>
-        </p:txBody>
-      </p:sp>
-      <p:sp>
-        <p:nvSpPr>
-          <p:cNvPr id="10" name="TextBox 9"/>
-          <p:cNvSpPr txBox="1"/>
-          <p:nvPr/>
-        </p:nvSpPr>
-        <p:spPr>
-          <a:xfrm>
-            <a:off x="3291839" y="1783080"/>
-            <a:ext cx="2286000" cy="320040"/>
-          </a:xfrm>
-          <a:prstGeom prst="rect">
-            <a:avLst/>
-          </a:prstGeom>
-          <a:noFill/>
-        </p:spPr>
-        <p:txBody>
-          <a:bodyPr wrap="square">
-            <a:spAutoFit/>
-          </a:bodyPr>
-          <a:lstStyle/>
-          <a:p>
-            <a:pPr algn="l"/>
-            <a:r>
-              <a:rPr sz="1000" b="0">
-                <a:solidFill>
-                  <a:srgbClr val="999999"/>
-                </a:solidFill>
-                <a:latin typeface="Calibri"/>
-              </a:rPr>
-              <a:t>Avg latency / investigation</a:t>
-            </a:r>
-          </a:p>
-        </p:txBody>
-      </p:sp>
-      <p:sp>
-        <p:nvSpPr>
-          <p:cNvPr id="11" name="Rectangle 10"/>
-          <p:cNvSpPr/>
-          <p:nvPr/>
-        </p:nvSpPr>
-        <p:spPr>
-          <a:xfrm>
-            <a:off x="5852159" y="1234440"/>
-            <a:ext cx="2560320" cy="914400"/>
-          </a:xfrm>
-          <a:prstGeom prst="rect">
-            <a:avLst/>
-          </a:prstGeom>
-          <a:solidFill>
-            <a:srgbClr val="242424"/>
-          </a:solidFill>
-          <a:ln>
-            <a:noFill/>
-          </a:ln>
-          <a:effectLst/>
-        </p:spPr>
-        <p:style>
-          <a:lnRef idx="1">
-            <a:schemeClr val="accent1"/>
-          </a:lnRef>
-          <a:fillRef idx="3">
-            <a:schemeClr val="accent1"/>
-          </a:fillRef>
-          <a:effectRef idx="2">
-            <a:schemeClr val="accent1"/>
-          </a:effectRef>
-          <a:fontRef idx="minor">
-            <a:schemeClr val="lt1"/>
-          </a:fontRef>
-        </p:style>
-        <p:txBody>
-          <a:bodyPr rtlCol="0" anchor="ctr"/>
-          <a:lstStyle/>
-          <a:p>
-            <a:pPr algn="ctr"/>
-          </a:p>
-        </p:txBody>
-      </p:sp>
-      <p:sp>
-        <p:nvSpPr>
-          <p:cNvPr id="12" name="TextBox 11"/>
-          <p:cNvSpPr txBox="1"/>
-          <p:nvPr/>
-        </p:nvSpPr>
-        <p:spPr>
-          <a:xfrm>
-            <a:off x="5989320" y="1325880"/>
-            <a:ext cx="2286000" cy="457200"/>
-          </a:xfrm>
-          <a:prstGeom prst="rect">
-            <a:avLst/>
-          </a:prstGeom>
-          <a:noFill/>
-        </p:spPr>
-        <p:txBody>
-          <a:bodyPr wrap="square">
-            <a:spAutoFit/>
-          </a:bodyPr>
-          <a:lstStyle/>
-          <a:p>
-            <a:pPr algn="l"/>
-            <a:r>
-              <a:rPr sz="2400" b="1">
-                <a:solidFill>
-                  <a:srgbClr val="E8751A"/>
-                </a:solidFill>
-                <a:latin typeface="Calibri"/>
-              </a:rPr>
-              <a:t>~13K</a:t>
-            </a:r>
-          </a:p>
-        </p:txBody>
-      </p:sp>
-      <p:sp>
-        <p:nvSpPr>
-          <p:cNvPr id="13" name="TextBox 12"/>
-          <p:cNvSpPr txBox="1"/>
-          <p:nvPr/>
-        </p:nvSpPr>
-        <p:spPr>
-          <a:xfrm>
-            <a:off x="5989320" y="1783080"/>
-            <a:ext cx="2286000" cy="320040"/>
-          </a:xfrm>
-          <a:prstGeom prst="rect">
-            <a:avLst/>
-          </a:prstGeom>
-          <a:noFill/>
-        </p:spPr>
-        <p:txBody>
-          <a:bodyPr wrap="square">
-            <a:spAutoFit/>
-          </a:bodyPr>
-          <a:lstStyle/>
-          <a:p>
-            <a:pPr algn="l"/>
-            <a:r>
-              <a:rPr sz="1000" b="0">
-                <a:solidFill>
-                  <a:srgbClr val="999999"/>
-                </a:solidFill>
-                <a:latin typeface="Calibri"/>
-              </a:rPr>
-              <a:t>Avg tokens / investigation</a:t>
-            </a:r>
-          </a:p>
-        </p:txBody>
-      </p:sp>
-      <p:sp>
-        <p:nvSpPr>
-          <p:cNvPr id="14" name="Rectangle 13"/>
-          <p:cNvSpPr/>
-          <p:nvPr/>
-        </p:nvSpPr>
-        <p:spPr>
-          <a:xfrm>
-            <a:off x="457200" y="2331720"/>
-            <a:ext cx="8229600" cy="914400"/>
-          </a:xfrm>
-          <a:prstGeom prst="rect">
-            <a:avLst/>
-          </a:prstGeom>
-          <a:solidFill>
-            <a:srgbClr val="242424"/>
-          </a:solidFill>
-          <a:ln>
-            <a:noFill/>
-          </a:ln>
-          <a:effectLst/>
-        </p:spPr>
-        <p:style>
-          <a:lnRef idx="1">
-            <a:schemeClr val="accent1"/>
-          </a:lnRef>
-          <a:fillRef idx="3">
-            <a:schemeClr val="accent1"/>
-          </a:fillRef>
-          <a:effectRef idx="2">
-            <a:schemeClr val="accent1"/>
-          </a:effectRef>
-          <a:fontRef idx="minor">
-            <a:schemeClr val="lt1"/>
-          </a:fontRef>
-        </p:style>
-        <p:txBody>
-          <a:bodyPr rtlCol="0" anchor="ctr"/>
-          <a:lstStyle/>
-          <a:p>
-            <a:pPr algn="ctr"/>
-          </a:p>
-        </p:txBody>
-      </p:sp>
-      <p:sp>
-        <p:nvSpPr>
-          <p:cNvPr id="15" name="Rectangle 14"/>
-          <p:cNvSpPr/>
-          <p:nvPr/>
-        </p:nvSpPr>
-        <p:spPr>
-          <a:xfrm>
-            <a:off x="457200" y="2331720"/>
-            <a:ext cx="54864" cy="914400"/>
-          </a:xfrm>
-          <a:prstGeom prst="rect">
-            <a:avLst/>
-          </a:prstGeom>
-          <a:solidFill>
-            <a:srgbClr val="1ABC9C"/>
-          </a:solidFill>
-          <a:ln>
-            <a:noFill/>
-          </a:ln>
-          <a:effectLst/>
-        </p:spPr>
-        <p:style>
-          <a:lnRef idx="1">
-            <a:schemeClr val="accent1"/>
-          </a:lnRef>
-          <a:fillRef idx="3">
-            <a:schemeClr val="accent1"/>
-          </a:fillRef>
-          <a:effectRef idx="2">
-            <a:schemeClr val="accent1"/>
-          </a:effectRef>
-          <a:fontRef idx="minor">
-            <a:schemeClr val="lt1"/>
-          </a:fontRef>
-        </p:style>
-        <p:txBody>
-          <a:bodyPr rtlCol="0" anchor="ctr"/>
-          <a:lstStyle/>
-          <a:p>
-            <a:pPr algn="ctr"/>
-          </a:p>
-        </p:txBody>
-      </p:sp>
-      <p:sp>
-        <p:nvSpPr>
-          <p:cNvPr id="16" name="TextBox 15"/>
-          <p:cNvSpPr txBox="1"/>
-          <p:nvPr/>
-        </p:nvSpPr>
-        <p:spPr>
-          <a:xfrm>
-            <a:off x="658368" y="2423160"/>
-            <a:ext cx="7863840" cy="731520"/>
-          </a:xfrm>
-          <a:prstGeom prst="rect">
-            <a:avLst/>
-          </a:prstGeom>
-          <a:noFill/>
-        </p:spPr>
-        <p:txBody>
-          <a:bodyPr wrap="square">
-            <a:spAutoFit/>
-          </a:bodyPr>
-          <a:lstStyle/>
-          <a:p>
-            <a:pPr algn="l"/>
-            <a:r>
-              <a:rPr sz="1100" b="0">
-                <a:solidFill>
-                  <a:srgbClr val="CCCCCC"/>
-                </a:solidFill>
-                <a:latin typeface="Calibri"/>
-              </a:rPr>
-              <a:t>Real numbers from the actual eval run — not estimated. Every investigation's token usage and cost is tracked individually and exported to Cloud Monitoring, with a cost-spike alert already deployed.</a:t>
-            </a:r>
-          </a:p>
-        </p:txBody>
-      </p:sp>
-      <p:sp>
-        <p:nvSpPr>
-          <p:cNvPr id="17" name="TextBox 16"/>
-          <p:cNvSpPr txBox="1"/>
-          <p:nvPr/>
-        </p:nvSpPr>
-        <p:spPr>
-          <a:xfrm>
-            <a:off x="457200" y="3429000"/>
-            <a:ext cx="8229600" cy="274320"/>
-          </a:xfrm>
-          <a:prstGeom prst="rect">
-            <a:avLst/>
-          </a:prstGeom>
-          <a:noFill/>
-        </p:spPr>
-        <p:txBody>
-          <a:bodyPr wrap="square">
-            <a:spAutoFit/>
-          </a:bodyPr>
-          <a:lstStyle/>
-          <a:p>
-            <a:pPr algn="l"/>
-            <a:r>
-              <a:rPr sz="1100" b="1">
-                <a:solidFill>
-                  <a:srgbClr val="FFFFFF"/>
-                </a:solidFill>
-                <a:latin typeface="Calibri"/>
-              </a:rPr>
-              <a:t>How this scales:</a:t>
-            </a:r>
-          </a:p>
-        </p:txBody>
-      </p:sp>
-      <p:sp>
-        <p:nvSpPr>
-          <p:cNvPr id="18" name="TextBox 17"/>
-          <p:cNvSpPr txBox="1"/>
-          <p:nvPr/>
-        </p:nvSpPr>
-        <p:spPr>
-          <a:xfrm>
-            <a:off x="457200" y="3703320"/>
-            <a:ext cx="8229600" cy="457200"/>
-          </a:xfrm>
-          <a:prstGeom prst="rect">
-            <a:avLst/>
-          </a:prstGeom>
-          <a:noFill/>
-        </p:spPr>
-        <p:txBody>
-          <a:bodyPr wrap="square">
-            <a:spAutoFit/>
-          </a:bodyPr>
-          <a:lstStyle/>
-          <a:p>
-            <a:pPr algn="l"/>
-            <a:r>
-              <a:rPr sz="1050" b="0">
-                <a:solidFill>
-                  <a:srgbClr val="CCCCCC"/>
-                </a:solidFill>
-                <a:latin typeface="Calibri"/>
-              </a:rPr>
-              <a:t>At this rate, 1,000 investigations/month is roughly $2.50 in model cost — the real constraint on scale is engineering time to expand coverage, not per-run spend.</a:t>
-            </a:r>
           </a:p>
         </p:txBody>
       </p:sp>
@@ -18712,6 +19610,681 @@
 </file>
 
 <file path=ppt/slides/slide20.xml><?xml version="1.0" encoding="utf-8"?>
+<p:sld xmlns:a="http://schemas.openxmlformats.org/drawingml/2006/main" xmlns:p="http://schemas.openxmlformats.org/presentationml/2006/main" xmlns:r="http://schemas.openxmlformats.org/officeDocument/2006/relationships">
+  <p:cSld>
+    <p:spTree>
+      <p:nvGrpSpPr>
+        <p:cNvPr id="1" name=""/>
+        <p:cNvGrpSpPr/>
+        <p:nvPr/>
+      </p:nvGrpSpPr>
+      <p:grpSpPr/>
+      <p:sp>
+        <p:nvSpPr>
+          <p:cNvPr id="2" name="TextBox 1"/>
+          <p:cNvSpPr txBox="1"/>
+          <p:nvPr/>
+        </p:nvSpPr>
+        <p:spPr>
+          <a:xfrm>
+            <a:off x="7589520" y="137160"/>
+            <a:ext cx="1371600" cy="274320"/>
+          </a:xfrm>
+          <a:prstGeom prst="rect">
+            <a:avLst/>
+          </a:prstGeom>
+          <a:noFill/>
+        </p:spPr>
+        <p:txBody>
+          <a:bodyPr wrap="none">
+            <a:spAutoFit/>
+          </a:bodyPr>
+          <a:lstStyle/>
+          <a:p>
+            <a:r>
+              <a:rPr sz="1200" b="1">
+                <a:solidFill>
+                  <a:srgbClr val="3CB371"/>
+                </a:solidFill>
+                <a:latin typeface="Trebuchet MS"/>
+              </a:rPr>
+              <a:t>SECTIGO</a:t>
+            </a:r>
+          </a:p>
+        </p:txBody>
+      </p:sp>
+      <p:sp>
+        <p:nvSpPr>
+          <p:cNvPr id="3" name="Rectangle 2"/>
+          <p:cNvSpPr/>
+          <p:nvPr/>
+        </p:nvSpPr>
+        <p:spPr>
+          <a:xfrm>
+            <a:off x="457200" y="182880"/>
+            <a:ext cx="1188720" cy="256032"/>
+          </a:xfrm>
+          <a:prstGeom prst="rect">
+            <a:avLst/>
+          </a:prstGeom>
+          <a:solidFill>
+            <a:srgbClr val="F4C542"/>
+          </a:solidFill>
+          <a:ln>
+            <a:noFill/>
+          </a:ln>
+          <a:effectLst/>
+        </p:spPr>
+        <p:style>
+          <a:lnRef idx="1">
+            <a:schemeClr val="accent1"/>
+          </a:lnRef>
+          <a:fillRef idx="3">
+            <a:schemeClr val="accent1"/>
+          </a:fillRef>
+          <a:effectRef idx="2">
+            <a:schemeClr val="accent1"/>
+          </a:effectRef>
+          <a:fontRef idx="minor">
+            <a:schemeClr val="lt1"/>
+          </a:fontRef>
+        </p:style>
+        <p:txBody>
+          <a:bodyPr rtlCol="0" anchor="ctr"/>
+          <a:lstStyle/>
+          <a:p>
+            <a:pPr algn="ctr"/>
+            <a:r>
+              <a:rPr sz="900" b="1">
+                <a:solidFill>
+                  <a:srgbClr val="1A1A1A"/>
+                </a:solidFill>
+                <a:latin typeface="Trebuchet MS"/>
+              </a:rPr>
+              <a:t>COST &amp; VALUE</a:t>
+            </a:r>
+          </a:p>
+        </p:txBody>
+      </p:sp>
+      <p:sp>
+        <p:nvSpPr>
+          <p:cNvPr id="4" name="TextBox 3"/>
+          <p:cNvSpPr txBox="1"/>
+          <p:nvPr/>
+        </p:nvSpPr>
+        <p:spPr>
+          <a:xfrm>
+            <a:off x="457200" y="594360"/>
+            <a:ext cx="8229600" cy="411480"/>
+          </a:xfrm>
+          <a:prstGeom prst="rect">
+            <a:avLst/>
+          </a:prstGeom>
+          <a:noFill/>
+        </p:spPr>
+        <p:txBody>
+          <a:bodyPr wrap="square">
+            <a:spAutoFit/>
+          </a:bodyPr>
+          <a:lstStyle/>
+          <a:p>
+            <a:pPr algn="l"/>
+            <a:r>
+              <a:rPr sz="2000" b="1">
+                <a:solidFill>
+                  <a:srgbClr val="131313"/>
+                </a:solidFill>
+                <a:latin typeface="Calibri"/>
+              </a:rPr>
+              <a:t>What This Actually Costs</a:t>
+            </a:r>
+          </a:p>
+        </p:txBody>
+      </p:sp>
+      <p:sp>
+        <p:nvSpPr>
+          <p:cNvPr id="5" name="Rectangle 4"/>
+          <p:cNvSpPr/>
+          <p:nvPr/>
+        </p:nvSpPr>
+        <p:spPr>
+          <a:xfrm>
+            <a:off x="457200" y="1234440"/>
+            <a:ext cx="2560320" cy="914400"/>
+          </a:xfrm>
+          <a:prstGeom prst="rect">
+            <a:avLst/>
+          </a:prstGeom>
+          <a:solidFill>
+            <a:srgbClr val="242424"/>
+          </a:solidFill>
+          <a:ln>
+            <a:noFill/>
+          </a:ln>
+          <a:effectLst/>
+        </p:spPr>
+        <p:style>
+          <a:lnRef idx="1">
+            <a:schemeClr val="accent1"/>
+          </a:lnRef>
+          <a:fillRef idx="3">
+            <a:schemeClr val="accent1"/>
+          </a:fillRef>
+          <a:effectRef idx="2">
+            <a:schemeClr val="accent1"/>
+          </a:effectRef>
+          <a:fontRef idx="minor">
+            <a:schemeClr val="lt1"/>
+          </a:fontRef>
+        </p:style>
+        <p:txBody>
+          <a:bodyPr rtlCol="0" anchor="ctr"/>
+          <a:lstStyle/>
+          <a:p>
+            <a:pPr algn="ctr"/>
+          </a:p>
+        </p:txBody>
+      </p:sp>
+      <p:sp>
+        <p:nvSpPr>
+          <p:cNvPr id="6" name="TextBox 5"/>
+          <p:cNvSpPr txBox="1"/>
+          <p:nvPr/>
+        </p:nvSpPr>
+        <p:spPr>
+          <a:xfrm>
+            <a:off x="594360" y="1325880"/>
+            <a:ext cx="2286000" cy="457200"/>
+          </a:xfrm>
+          <a:prstGeom prst="rect">
+            <a:avLst/>
+          </a:prstGeom>
+          <a:noFill/>
+        </p:spPr>
+        <p:txBody>
+          <a:bodyPr wrap="square">
+            <a:spAutoFit/>
+          </a:bodyPr>
+          <a:lstStyle/>
+          <a:p>
+            <a:pPr algn="l"/>
+            <a:r>
+              <a:rPr sz="2400" b="1">
+                <a:solidFill>
+                  <a:srgbClr val="1ABC9C"/>
+                </a:solidFill>
+                <a:latin typeface="Calibri"/>
+              </a:rPr>
+              <a:t>$0.0025</a:t>
+            </a:r>
+          </a:p>
+        </p:txBody>
+      </p:sp>
+      <p:sp>
+        <p:nvSpPr>
+          <p:cNvPr id="7" name="TextBox 6"/>
+          <p:cNvSpPr txBox="1"/>
+          <p:nvPr/>
+        </p:nvSpPr>
+        <p:spPr>
+          <a:xfrm>
+            <a:off x="594360" y="1783080"/>
+            <a:ext cx="2286000" cy="320040"/>
+          </a:xfrm>
+          <a:prstGeom prst="rect">
+            <a:avLst/>
+          </a:prstGeom>
+          <a:noFill/>
+        </p:spPr>
+        <p:txBody>
+          <a:bodyPr wrap="square">
+            <a:spAutoFit/>
+          </a:bodyPr>
+          <a:lstStyle/>
+          <a:p>
+            <a:pPr algn="l"/>
+            <a:r>
+              <a:rPr sz="1000" b="0">
+                <a:solidFill>
+                  <a:srgbClr val="999999"/>
+                </a:solidFill>
+                <a:latin typeface="Calibri"/>
+              </a:rPr>
+              <a:t>Avg cost / investigation</a:t>
+            </a:r>
+          </a:p>
+        </p:txBody>
+      </p:sp>
+      <p:sp>
+        <p:nvSpPr>
+          <p:cNvPr id="8" name="Rectangle 7"/>
+          <p:cNvSpPr/>
+          <p:nvPr/>
+        </p:nvSpPr>
+        <p:spPr>
+          <a:xfrm>
+            <a:off x="3154679" y="1234440"/>
+            <a:ext cx="2560320" cy="914400"/>
+          </a:xfrm>
+          <a:prstGeom prst="rect">
+            <a:avLst/>
+          </a:prstGeom>
+          <a:solidFill>
+            <a:srgbClr val="242424"/>
+          </a:solidFill>
+          <a:ln>
+            <a:noFill/>
+          </a:ln>
+          <a:effectLst/>
+        </p:spPr>
+        <p:style>
+          <a:lnRef idx="1">
+            <a:schemeClr val="accent1"/>
+          </a:lnRef>
+          <a:fillRef idx="3">
+            <a:schemeClr val="accent1"/>
+          </a:fillRef>
+          <a:effectRef idx="2">
+            <a:schemeClr val="accent1"/>
+          </a:effectRef>
+          <a:fontRef idx="minor">
+            <a:schemeClr val="lt1"/>
+          </a:fontRef>
+        </p:style>
+        <p:txBody>
+          <a:bodyPr rtlCol="0" anchor="ctr"/>
+          <a:lstStyle/>
+          <a:p>
+            <a:pPr algn="ctr"/>
+          </a:p>
+        </p:txBody>
+      </p:sp>
+      <p:sp>
+        <p:nvSpPr>
+          <p:cNvPr id="9" name="TextBox 8"/>
+          <p:cNvSpPr txBox="1"/>
+          <p:nvPr/>
+        </p:nvSpPr>
+        <p:spPr>
+          <a:xfrm>
+            <a:off x="3291839" y="1325880"/>
+            <a:ext cx="2286000" cy="457200"/>
+          </a:xfrm>
+          <a:prstGeom prst="rect">
+            <a:avLst/>
+          </a:prstGeom>
+          <a:noFill/>
+        </p:spPr>
+        <p:txBody>
+          <a:bodyPr wrap="square">
+            <a:spAutoFit/>
+          </a:bodyPr>
+          <a:lstStyle/>
+          <a:p>
+            <a:pPr algn="l"/>
+            <a:r>
+              <a:rPr sz="2400" b="1">
+                <a:solidFill>
+                  <a:srgbClr val="F4C542"/>
+                </a:solidFill>
+                <a:latin typeface="Calibri"/>
+              </a:rPr>
+              <a:t>20.5s</a:t>
+            </a:r>
+          </a:p>
+        </p:txBody>
+      </p:sp>
+      <p:sp>
+        <p:nvSpPr>
+          <p:cNvPr id="10" name="TextBox 9"/>
+          <p:cNvSpPr txBox="1"/>
+          <p:nvPr/>
+        </p:nvSpPr>
+        <p:spPr>
+          <a:xfrm>
+            <a:off x="3291839" y="1783080"/>
+            <a:ext cx="2286000" cy="320040"/>
+          </a:xfrm>
+          <a:prstGeom prst="rect">
+            <a:avLst/>
+          </a:prstGeom>
+          <a:noFill/>
+        </p:spPr>
+        <p:txBody>
+          <a:bodyPr wrap="square">
+            <a:spAutoFit/>
+          </a:bodyPr>
+          <a:lstStyle/>
+          <a:p>
+            <a:pPr algn="l"/>
+            <a:r>
+              <a:rPr sz="1000" b="0">
+                <a:solidFill>
+                  <a:srgbClr val="999999"/>
+                </a:solidFill>
+                <a:latin typeface="Calibri"/>
+              </a:rPr>
+              <a:t>Avg latency / investigation</a:t>
+            </a:r>
+          </a:p>
+        </p:txBody>
+      </p:sp>
+      <p:sp>
+        <p:nvSpPr>
+          <p:cNvPr id="11" name="Rectangle 10"/>
+          <p:cNvSpPr/>
+          <p:nvPr/>
+        </p:nvSpPr>
+        <p:spPr>
+          <a:xfrm>
+            <a:off x="5852159" y="1234440"/>
+            <a:ext cx="2560320" cy="914400"/>
+          </a:xfrm>
+          <a:prstGeom prst="rect">
+            <a:avLst/>
+          </a:prstGeom>
+          <a:solidFill>
+            <a:srgbClr val="242424"/>
+          </a:solidFill>
+          <a:ln>
+            <a:noFill/>
+          </a:ln>
+          <a:effectLst/>
+        </p:spPr>
+        <p:style>
+          <a:lnRef idx="1">
+            <a:schemeClr val="accent1"/>
+          </a:lnRef>
+          <a:fillRef idx="3">
+            <a:schemeClr val="accent1"/>
+          </a:fillRef>
+          <a:effectRef idx="2">
+            <a:schemeClr val="accent1"/>
+          </a:effectRef>
+          <a:fontRef idx="minor">
+            <a:schemeClr val="lt1"/>
+          </a:fontRef>
+        </p:style>
+        <p:txBody>
+          <a:bodyPr rtlCol="0" anchor="ctr"/>
+          <a:lstStyle/>
+          <a:p>
+            <a:pPr algn="ctr"/>
+          </a:p>
+        </p:txBody>
+      </p:sp>
+      <p:sp>
+        <p:nvSpPr>
+          <p:cNvPr id="12" name="TextBox 11"/>
+          <p:cNvSpPr txBox="1"/>
+          <p:nvPr/>
+        </p:nvSpPr>
+        <p:spPr>
+          <a:xfrm>
+            <a:off x="5989320" y="1325880"/>
+            <a:ext cx="2286000" cy="457200"/>
+          </a:xfrm>
+          <a:prstGeom prst="rect">
+            <a:avLst/>
+          </a:prstGeom>
+          <a:noFill/>
+        </p:spPr>
+        <p:txBody>
+          <a:bodyPr wrap="square">
+            <a:spAutoFit/>
+          </a:bodyPr>
+          <a:lstStyle/>
+          <a:p>
+            <a:pPr algn="l"/>
+            <a:r>
+              <a:rPr sz="2400" b="1">
+                <a:solidFill>
+                  <a:srgbClr val="E8751A"/>
+                </a:solidFill>
+                <a:latin typeface="Calibri"/>
+              </a:rPr>
+              <a:t>~13K</a:t>
+            </a:r>
+          </a:p>
+        </p:txBody>
+      </p:sp>
+      <p:sp>
+        <p:nvSpPr>
+          <p:cNvPr id="13" name="TextBox 12"/>
+          <p:cNvSpPr txBox="1"/>
+          <p:nvPr/>
+        </p:nvSpPr>
+        <p:spPr>
+          <a:xfrm>
+            <a:off x="5989320" y="1783080"/>
+            <a:ext cx="2286000" cy="320040"/>
+          </a:xfrm>
+          <a:prstGeom prst="rect">
+            <a:avLst/>
+          </a:prstGeom>
+          <a:noFill/>
+        </p:spPr>
+        <p:txBody>
+          <a:bodyPr wrap="square">
+            <a:spAutoFit/>
+          </a:bodyPr>
+          <a:lstStyle/>
+          <a:p>
+            <a:pPr algn="l"/>
+            <a:r>
+              <a:rPr sz="1000" b="0">
+                <a:solidFill>
+                  <a:srgbClr val="999999"/>
+                </a:solidFill>
+                <a:latin typeface="Calibri"/>
+              </a:rPr>
+              <a:t>Avg tokens / investigation</a:t>
+            </a:r>
+          </a:p>
+        </p:txBody>
+      </p:sp>
+      <p:sp>
+        <p:nvSpPr>
+          <p:cNvPr id="14" name="Rectangle 13"/>
+          <p:cNvSpPr/>
+          <p:nvPr/>
+        </p:nvSpPr>
+        <p:spPr>
+          <a:xfrm>
+            <a:off x="457200" y="2331720"/>
+            <a:ext cx="8229600" cy="914400"/>
+          </a:xfrm>
+          <a:prstGeom prst="rect">
+            <a:avLst/>
+          </a:prstGeom>
+          <a:solidFill>
+            <a:srgbClr val="242424"/>
+          </a:solidFill>
+          <a:ln>
+            <a:noFill/>
+          </a:ln>
+          <a:effectLst/>
+        </p:spPr>
+        <p:style>
+          <a:lnRef idx="1">
+            <a:schemeClr val="accent1"/>
+          </a:lnRef>
+          <a:fillRef idx="3">
+            <a:schemeClr val="accent1"/>
+          </a:fillRef>
+          <a:effectRef idx="2">
+            <a:schemeClr val="accent1"/>
+          </a:effectRef>
+          <a:fontRef idx="minor">
+            <a:schemeClr val="lt1"/>
+          </a:fontRef>
+        </p:style>
+        <p:txBody>
+          <a:bodyPr rtlCol="0" anchor="ctr"/>
+          <a:lstStyle/>
+          <a:p>
+            <a:pPr algn="ctr"/>
+          </a:p>
+        </p:txBody>
+      </p:sp>
+      <p:sp>
+        <p:nvSpPr>
+          <p:cNvPr id="15" name="Rectangle 14"/>
+          <p:cNvSpPr/>
+          <p:nvPr/>
+        </p:nvSpPr>
+        <p:spPr>
+          <a:xfrm>
+            <a:off x="457200" y="2331720"/>
+            <a:ext cx="54864" cy="914400"/>
+          </a:xfrm>
+          <a:prstGeom prst="rect">
+            <a:avLst/>
+          </a:prstGeom>
+          <a:solidFill>
+            <a:srgbClr val="1ABC9C"/>
+          </a:solidFill>
+          <a:ln>
+            <a:noFill/>
+          </a:ln>
+          <a:effectLst/>
+        </p:spPr>
+        <p:style>
+          <a:lnRef idx="1">
+            <a:schemeClr val="accent1"/>
+          </a:lnRef>
+          <a:fillRef idx="3">
+            <a:schemeClr val="accent1"/>
+          </a:fillRef>
+          <a:effectRef idx="2">
+            <a:schemeClr val="accent1"/>
+          </a:effectRef>
+          <a:fontRef idx="minor">
+            <a:schemeClr val="lt1"/>
+          </a:fontRef>
+        </p:style>
+        <p:txBody>
+          <a:bodyPr rtlCol="0" anchor="ctr"/>
+          <a:lstStyle/>
+          <a:p>
+            <a:pPr algn="ctr"/>
+          </a:p>
+        </p:txBody>
+      </p:sp>
+      <p:sp>
+        <p:nvSpPr>
+          <p:cNvPr id="16" name="TextBox 15"/>
+          <p:cNvSpPr txBox="1"/>
+          <p:nvPr/>
+        </p:nvSpPr>
+        <p:spPr>
+          <a:xfrm>
+            <a:off x="658368" y="2423160"/>
+            <a:ext cx="7863840" cy="731520"/>
+          </a:xfrm>
+          <a:prstGeom prst="rect">
+            <a:avLst/>
+          </a:prstGeom>
+          <a:noFill/>
+        </p:spPr>
+        <p:txBody>
+          <a:bodyPr wrap="square">
+            <a:spAutoFit/>
+          </a:bodyPr>
+          <a:lstStyle/>
+          <a:p>
+            <a:pPr algn="l"/>
+            <a:r>
+              <a:rPr sz="1100" b="0">
+                <a:solidFill>
+                  <a:srgbClr val="CCCCCC"/>
+                </a:solidFill>
+                <a:latin typeface="Calibri"/>
+              </a:rPr>
+              <a:t>Real numbers from the actual eval run — not estimated. Every investigation's token usage and cost is tracked individually and exported to Cloud Monitoring, with a cost-spike alert already deployed.</a:t>
+            </a:r>
+          </a:p>
+        </p:txBody>
+      </p:sp>
+      <p:sp>
+        <p:nvSpPr>
+          <p:cNvPr id="17" name="TextBox 16"/>
+          <p:cNvSpPr txBox="1"/>
+          <p:nvPr/>
+        </p:nvSpPr>
+        <p:spPr>
+          <a:xfrm>
+            <a:off x="457200" y="3429000"/>
+            <a:ext cx="8229600" cy="274320"/>
+          </a:xfrm>
+          <a:prstGeom prst="rect">
+            <a:avLst/>
+          </a:prstGeom>
+          <a:noFill/>
+        </p:spPr>
+        <p:txBody>
+          <a:bodyPr wrap="square">
+            <a:spAutoFit/>
+          </a:bodyPr>
+          <a:lstStyle/>
+          <a:p>
+            <a:pPr algn="l"/>
+            <a:r>
+              <a:rPr sz="1100" b="1">
+                <a:solidFill>
+                  <a:srgbClr val="131313"/>
+                </a:solidFill>
+                <a:latin typeface="Calibri"/>
+              </a:rPr>
+              <a:t>How this scales:</a:t>
+            </a:r>
+          </a:p>
+        </p:txBody>
+      </p:sp>
+      <p:sp>
+        <p:nvSpPr>
+          <p:cNvPr id="18" name="TextBox 17"/>
+          <p:cNvSpPr txBox="1"/>
+          <p:nvPr/>
+        </p:nvSpPr>
+        <p:spPr>
+          <a:xfrm>
+            <a:off x="457200" y="3703320"/>
+            <a:ext cx="8229600" cy="457200"/>
+          </a:xfrm>
+          <a:prstGeom prst="rect">
+            <a:avLst/>
+          </a:prstGeom>
+          <a:noFill/>
+        </p:spPr>
+        <p:txBody>
+          <a:bodyPr wrap="square">
+            <a:spAutoFit/>
+          </a:bodyPr>
+          <a:lstStyle/>
+          <a:p>
+            <a:pPr algn="l"/>
+            <a:r>
+              <a:rPr sz="1050" b="0">
+                <a:solidFill>
+                  <a:srgbClr val="CCCCCC"/>
+                </a:solidFill>
+                <a:latin typeface="Calibri"/>
+              </a:rPr>
+              <a:t>At this rate, 1,000 investigations/month is roughly $2.50 in model cost — the real constraint on scale is engineering time to expand coverage, not per-run spend.</a:t>
+            </a:r>
+          </a:p>
+        </p:txBody>
+      </p:sp>
+    </p:spTree>
+  </p:cSld>
+  <p:clrMapOvr>
+    <a:masterClrMapping/>
+  </p:clrMapOvr>
+</p:sld>
+</file>
+
+<file path=ppt/slides/slide21.xml><?xml version="1.0" encoding="utf-8"?>
 <p:sld xmlns:a="http://schemas.openxmlformats.org/drawingml/2006/main" xmlns:r="http://schemas.openxmlformats.org/officeDocument/2006/relationships" xmlns:p="http://schemas.openxmlformats.org/presentationml/2006/main">
   <p:cSld name="Slide 23">
     <p:bg>
@@ -19899,7 +21472,7 @@
 </p:sld>
 </file>
 
-<file path=ppt/slides/slide21.xml><?xml version="1.0" encoding="utf-8"?>
+<file path=ppt/slides/slide22.xml><?xml version="1.0" encoding="utf-8"?>
 <p:sld xmlns:a="http://schemas.openxmlformats.org/drawingml/2006/main" xmlns:r="http://schemas.openxmlformats.org/officeDocument/2006/relationships" xmlns:p="http://schemas.openxmlformats.org/presentationml/2006/main">
   <p:cSld name="Slide 24">
     <p:bg>
@@ -20115,7 +21688,7 @@
 </p:sld>
 </file>
 
-<file path=ppt/slides/slide22.xml><?xml version="1.0" encoding="utf-8"?>
+<file path=ppt/slides/slide23.xml><?xml version="1.0" encoding="utf-8"?>
 <p:sld xmlns:a="http://schemas.openxmlformats.org/drawingml/2006/main" xmlns:p="http://schemas.openxmlformats.org/presentationml/2006/main" xmlns:r="http://schemas.openxmlformats.org/officeDocument/2006/relationships">
   <p:cSld>
     <p:spTree>
@@ -20238,7 +21811,7 @@
             <a:r>
               <a:rPr sz="2000" b="1" i="0">
                 <a:solidFill>
-                  <a:srgbClr val="FFFFFF"/>
+                  <a:srgbClr val="131313"/>
                 </a:solidFill>
                 <a:latin typeface="Calibri"/>
               </a:rPr>
@@ -21115,169 +22688,6 @@
           </a:p>
         </p:txBody>
       </p:sp>
-    </p:spTree>
-  </p:cSld>
-  <p:clrMapOvr>
-    <a:masterClrMapping/>
-  </p:clrMapOvr>
-</p:sld>
-</file>
-
-<file path=ppt/slides/slide23.xml><?xml version="1.0" encoding="utf-8"?>
-<p:sld xmlns:a="http://schemas.openxmlformats.org/drawingml/2006/main" xmlns:p="http://schemas.openxmlformats.org/presentationml/2006/main" xmlns:r="http://schemas.openxmlformats.org/officeDocument/2006/relationships">
-  <p:cSld>
-    <p:spTree>
-      <p:nvGrpSpPr>
-        <p:cNvPr id="1" name=""/>
-        <p:cNvGrpSpPr/>
-        <p:nvPr/>
-      </p:nvGrpSpPr>
-      <p:grpSpPr/>
-      <p:sp>
-        <p:nvSpPr>
-          <p:cNvPr id="2" name="TextBox 1"/>
-          <p:cNvSpPr txBox="1"/>
-          <p:nvPr/>
-        </p:nvSpPr>
-        <p:spPr>
-          <a:xfrm>
-            <a:off x="7589520" y="137160"/>
-            <a:ext cx="1371600" cy="274320"/>
-          </a:xfrm>
-          <a:prstGeom prst="rect">
-            <a:avLst/>
-          </a:prstGeom>
-          <a:noFill/>
-        </p:spPr>
-        <p:txBody>
-          <a:bodyPr wrap="none">
-            <a:spAutoFit/>
-          </a:bodyPr>
-          <a:lstStyle/>
-          <a:p>
-            <a:r>
-              <a:rPr sz="1200" b="1">
-                <a:solidFill>
-                  <a:srgbClr val="3CB371"/>
-                </a:solidFill>
-                <a:latin typeface="Trebuchet MS"/>
-              </a:rPr>
-              <a:t>SECTIGO</a:t>
-            </a:r>
-          </a:p>
-        </p:txBody>
-      </p:sp>
-      <p:sp>
-        <p:nvSpPr>
-          <p:cNvPr id="3" name="Rectangle 2"/>
-          <p:cNvSpPr/>
-          <p:nvPr/>
-        </p:nvSpPr>
-        <p:spPr>
-          <a:xfrm>
-            <a:off x="457200" y="137160"/>
-            <a:ext cx="1737360" cy="237744"/>
-          </a:xfrm>
-          <a:prstGeom prst="rect">
-            <a:avLst/>
-          </a:prstGeom>
-          <a:solidFill>
-            <a:srgbClr val="E8751A"/>
-          </a:solidFill>
-          <a:ln>
-            <a:noFill/>
-          </a:ln>
-          <a:effectLst/>
-        </p:spPr>
-        <p:style>
-          <a:lnRef idx="1">
-            <a:schemeClr val="accent1"/>
-          </a:lnRef>
-          <a:fillRef idx="3">
-            <a:schemeClr val="accent1"/>
-          </a:fillRef>
-          <a:effectRef idx="2">
-            <a:schemeClr val="accent1"/>
-          </a:effectRef>
-          <a:fontRef idx="minor">
-            <a:schemeClr val="lt1"/>
-          </a:fontRef>
-        </p:style>
-        <p:txBody>
-          <a:bodyPr rtlCol="0" anchor="ctr"/>
-          <a:lstStyle/>
-          <a:p>
-            <a:pPr algn="ctr"/>
-            <a:r>
-              <a:rPr sz="900" b="1">
-                <a:solidFill>
-                  <a:srgbClr val="1A1A1A"/>
-                </a:solidFill>
-                <a:latin typeface="Trebuchet MS"/>
-              </a:rPr>
-              <a:t>FUTURE ARCHITECTURE</a:t>
-            </a:r>
-          </a:p>
-        </p:txBody>
-      </p:sp>
-      <p:sp>
-        <p:nvSpPr>
-          <p:cNvPr id="4" name="TextBox 3"/>
-          <p:cNvSpPr txBox="1"/>
-          <p:nvPr/>
-        </p:nvSpPr>
-        <p:spPr>
-          <a:xfrm>
-            <a:off x="457200" y="402336"/>
-            <a:ext cx="8229600" cy="320040"/>
-          </a:xfrm>
-          <a:prstGeom prst="rect">
-            <a:avLst/>
-          </a:prstGeom>
-          <a:noFill/>
-        </p:spPr>
-        <p:txBody>
-          <a:bodyPr wrap="none">
-            <a:spAutoFit/>
-          </a:bodyPr>
-          <a:lstStyle/>
-          <a:p>
-            <a:r>
-              <a:rPr sz="1500" b="1">
-                <a:solidFill>
-                  <a:srgbClr val="FFFFFF"/>
-                </a:solidFill>
-                <a:latin typeface="Calibri"/>
-              </a:rPr>
-              <a:t>Target Architecture — Where We're Building Toward</a:t>
-            </a:r>
-          </a:p>
-        </p:txBody>
-      </p:sp>
-      <p:pic>
-        <p:nvPicPr>
-          <p:cNvPr id="5" name="Picture 4" descr="d40816cf-62446CA4FBB84372BC6026175AF93832.png"/>
-          <p:cNvPicPr>
-            <a:picLocks noChangeAspect="1"/>
-          </p:cNvPicPr>
-          <p:nvPr/>
-        </p:nvPicPr>
-        <p:blipFill>
-          <a:blip r:embed="rId2"/>
-          <a:stretch>
-            <a:fillRect/>
-          </a:stretch>
-        </p:blipFill>
-        <p:spPr>
-          <a:xfrm>
-            <a:off x="1348740" y="777240"/>
-            <a:ext cx="6446520" cy="4297680"/>
-          </a:xfrm>
-          <a:prstGeom prst="rect">
-            <a:avLst/>
-          </a:prstGeom>
-        </p:spPr>
-      </p:pic>
     </p:spTree>
   </p:cSld>
   <p:clrMapOvr>
@@ -21332,6 +22742,169 @@
       </p:sp>
       <p:sp>
         <p:nvSpPr>
+          <p:cNvPr id="3" name="Rectangle 2"/>
+          <p:cNvSpPr/>
+          <p:nvPr/>
+        </p:nvSpPr>
+        <p:spPr>
+          <a:xfrm>
+            <a:off x="457200" y="137160"/>
+            <a:ext cx="1737360" cy="237744"/>
+          </a:xfrm>
+          <a:prstGeom prst="rect">
+            <a:avLst/>
+          </a:prstGeom>
+          <a:solidFill>
+            <a:srgbClr val="E8751A"/>
+          </a:solidFill>
+          <a:ln>
+            <a:noFill/>
+          </a:ln>
+          <a:effectLst/>
+        </p:spPr>
+        <p:style>
+          <a:lnRef idx="1">
+            <a:schemeClr val="accent1"/>
+          </a:lnRef>
+          <a:fillRef idx="3">
+            <a:schemeClr val="accent1"/>
+          </a:fillRef>
+          <a:effectRef idx="2">
+            <a:schemeClr val="accent1"/>
+          </a:effectRef>
+          <a:fontRef idx="minor">
+            <a:schemeClr val="lt1"/>
+          </a:fontRef>
+        </p:style>
+        <p:txBody>
+          <a:bodyPr rtlCol="0" anchor="ctr"/>
+          <a:lstStyle/>
+          <a:p>
+            <a:pPr algn="ctr"/>
+            <a:r>
+              <a:rPr sz="900" b="1">
+                <a:solidFill>
+                  <a:srgbClr val="1A1A1A"/>
+                </a:solidFill>
+                <a:latin typeface="Trebuchet MS"/>
+              </a:rPr>
+              <a:t>FUTURE ARCHITECTURE</a:t>
+            </a:r>
+          </a:p>
+        </p:txBody>
+      </p:sp>
+      <p:sp>
+        <p:nvSpPr>
+          <p:cNvPr id="4" name="TextBox 3"/>
+          <p:cNvSpPr txBox="1"/>
+          <p:nvPr/>
+        </p:nvSpPr>
+        <p:spPr>
+          <a:xfrm>
+            <a:off x="457200" y="402336"/>
+            <a:ext cx="8229600" cy="320040"/>
+          </a:xfrm>
+          <a:prstGeom prst="rect">
+            <a:avLst/>
+          </a:prstGeom>
+          <a:noFill/>
+        </p:spPr>
+        <p:txBody>
+          <a:bodyPr wrap="none">
+            <a:spAutoFit/>
+          </a:bodyPr>
+          <a:lstStyle/>
+          <a:p>
+            <a:r>
+              <a:rPr sz="1500" b="1">
+                <a:solidFill>
+                  <a:srgbClr val="131313"/>
+                </a:solidFill>
+                <a:latin typeface="Calibri"/>
+              </a:rPr>
+              <a:t>Target Architecture — Where We're Building Toward</a:t>
+            </a:r>
+          </a:p>
+        </p:txBody>
+      </p:sp>
+      <p:pic>
+        <p:nvPicPr>
+          <p:cNvPr id="5" name="Picture 4" descr="d40816cf-62446CA4FBB84372BC6026175AF93832.png"/>
+          <p:cNvPicPr>
+            <a:picLocks noChangeAspect="1"/>
+          </p:cNvPicPr>
+          <p:nvPr/>
+        </p:nvPicPr>
+        <p:blipFill>
+          <a:blip r:embed="rId2"/>
+          <a:stretch>
+            <a:fillRect/>
+          </a:stretch>
+        </p:blipFill>
+        <p:spPr>
+          <a:xfrm>
+            <a:off x="1348740" y="777240"/>
+            <a:ext cx="6446520" cy="4297680"/>
+          </a:xfrm>
+          <a:prstGeom prst="rect">
+            <a:avLst/>
+          </a:prstGeom>
+        </p:spPr>
+      </p:pic>
+    </p:spTree>
+  </p:cSld>
+  <p:clrMapOvr>
+    <a:masterClrMapping/>
+  </p:clrMapOvr>
+</p:sld>
+</file>
+
+<file path=ppt/slides/slide25.xml><?xml version="1.0" encoding="utf-8"?>
+<p:sld xmlns:a="http://schemas.openxmlformats.org/drawingml/2006/main" xmlns:p="http://schemas.openxmlformats.org/presentationml/2006/main" xmlns:r="http://schemas.openxmlformats.org/officeDocument/2006/relationships">
+  <p:cSld>
+    <p:spTree>
+      <p:nvGrpSpPr>
+        <p:cNvPr id="1" name=""/>
+        <p:cNvGrpSpPr/>
+        <p:nvPr/>
+      </p:nvGrpSpPr>
+      <p:grpSpPr/>
+      <p:sp>
+        <p:nvSpPr>
+          <p:cNvPr id="2" name="TextBox 1"/>
+          <p:cNvSpPr txBox="1"/>
+          <p:nvPr/>
+        </p:nvSpPr>
+        <p:spPr>
+          <a:xfrm>
+            <a:off x="7589520" y="137160"/>
+            <a:ext cx="1371600" cy="274320"/>
+          </a:xfrm>
+          <a:prstGeom prst="rect">
+            <a:avLst/>
+          </a:prstGeom>
+          <a:noFill/>
+        </p:spPr>
+        <p:txBody>
+          <a:bodyPr wrap="none">
+            <a:spAutoFit/>
+          </a:bodyPr>
+          <a:lstStyle/>
+          <a:p>
+            <a:r>
+              <a:rPr sz="1200" b="1">
+                <a:solidFill>
+                  <a:srgbClr val="3CB371"/>
+                </a:solidFill>
+                <a:latin typeface="Trebuchet MS"/>
+              </a:rPr>
+              <a:t>SECTIGO</a:t>
+            </a:r>
+          </a:p>
+        </p:txBody>
+      </p:sp>
+      <p:sp>
+        <p:nvSpPr>
           <p:cNvPr id="3" name="TextBox 2"/>
           <p:cNvSpPr txBox="1"/>
           <p:nvPr/>
@@ -21356,7 +22929,7 @@
             <a:r>
               <a:rPr sz="4400" b="1" i="0">
                 <a:solidFill>
-                  <a:srgbClr val="FFFFFF"/>
+                  <a:srgbClr val="131313"/>
                 </a:solidFill>
                 <a:latin typeface="Georgia"/>
               </a:rPr>

</xml_diff>